<commit_message>
Final deck: interactive slide 4; step 06 UAT gets its own place in the run strip (01-09 in order)
Co-Authored-By: Claude Opus 5.5 <noreply@anthropic.com>
Claude-Session: https://claude.ai/code/session_01Hf94kqMzSofkkrQm7kpNba
</commit_message>
<xml_diff>
--- a/poc/deck/assets/review/Slide 4 interactive - test.pptx
+++ b/poc/deck/assets/review/Slide 4 interactive - test.pptx
@@ -1495,7 +1495,7 @@
           <a:p/>
           <a:p>
             <a:r>
-              <a:t>[CLICK 10  H4, step 06] The Release Agent promotes through Copado to SIT and UAT. Marketing and clinical owners test every message variant and sign off UAT.</a:t>
+              <a:t>[CLICK 10  06 UAT, then H4] The Release Agent promotes through Copado to SIT and UAT (step 05). In step 06, marketing and clinical owners test every message variant; they sign off at H4.</a:t>
             </a:r>
           </a:p>
           <a:p/>
@@ -10303,7 +10303,7 @@
         <p:spPr>
           <a:xfrm>
             <a:off x="1417320" y="5550408"/>
-            <a:ext cx="749808" cy="384048"/>
+            <a:ext cx="694944" cy="384048"/>
           </a:xfrm>
           <a:prstGeom prst="roundRect">
             <a:avLst>
@@ -10349,7 +10349,7 @@
         <p:spPr>
           <a:xfrm>
             <a:off x="1444752" y="5550408"/>
-            <a:ext cx="694944" cy="384048"/>
+            <a:ext cx="640080" cy="384048"/>
           </a:xfrm>
           <a:prstGeom prst="rect">
             <a:avLst/>
@@ -10395,7 +10395,7 @@
         </p:nvSpPr>
         <p:spPr>
           <a:xfrm>
-            <a:off x="1581912" y="5980176"/>
+            <a:off x="1554480" y="5980176"/>
             <a:ext cx="420624" cy="146304"/>
           </a:xfrm>
           <a:prstGeom prst="roundRect">
@@ -10441,7 +10441,7 @@
         </p:nvSpPr>
         <p:spPr>
           <a:xfrm>
-            <a:off x="1581912" y="5980176"/>
+            <a:off x="1554480" y="5980176"/>
             <a:ext cx="420624" cy="146304"/>
           </a:xfrm>
           <a:prstGeom prst="rect">
@@ -10476,7 +10476,7 @@
         </p:nvCxnSpPr>
         <p:spPr>
           <a:xfrm>
-            <a:off x="2167128" y="5742432"/>
+            <a:off x="2112264" y="5742432"/>
             <a:ext cx="45720" cy="0"/>
           </a:xfrm>
           <a:prstGeom prst="line">
@@ -10512,8 +10512,8 @@
         </p:nvSpPr>
         <p:spPr>
           <a:xfrm>
-            <a:off x="2212848" y="5550408"/>
-            <a:ext cx="749808" cy="384048"/>
+            <a:off x="2157984" y="5550408"/>
+            <a:ext cx="694944" cy="384048"/>
           </a:xfrm>
           <a:prstGeom prst="roundRect">
             <a:avLst>
@@ -10558,8 +10558,8 @@
         </p:nvSpPr>
         <p:spPr>
           <a:xfrm>
-            <a:off x="2240279" y="5550408"/>
-            <a:ext cx="694944" cy="384048"/>
+            <a:off x="2185416" y="5550408"/>
+            <a:ext cx="640080" cy="384048"/>
           </a:xfrm>
           <a:prstGeom prst="rect">
             <a:avLst/>
@@ -10605,8 +10605,8 @@
         </p:nvCxnSpPr>
         <p:spPr>
           <a:xfrm>
-            <a:off x="2962656" y="5742432"/>
-            <a:ext cx="45719" cy="0"/>
+            <a:off x="2852928" y="5742432"/>
+            <a:ext cx="45720" cy="0"/>
           </a:xfrm>
           <a:prstGeom prst="line">
             <a:avLst/>
@@ -10641,8 +10641,8 @@
         </p:nvSpPr>
         <p:spPr>
           <a:xfrm>
-            <a:off x="3008376" y="5550408"/>
-            <a:ext cx="749808" cy="384048"/>
+            <a:off x="2898648" y="5550408"/>
+            <a:ext cx="694944" cy="384048"/>
           </a:xfrm>
           <a:prstGeom prst="roundRect">
             <a:avLst>
@@ -10687,8 +10687,8 @@
         </p:nvSpPr>
         <p:spPr>
           <a:xfrm>
-            <a:off x="3035808" y="5550408"/>
-            <a:ext cx="694944" cy="384048"/>
+            <a:off x="2926079" y="5550408"/>
+            <a:ext cx="640080" cy="384048"/>
           </a:xfrm>
           <a:prstGeom prst="rect">
             <a:avLst/>
@@ -10734,7 +10734,7 @@
         </p:nvSpPr>
         <p:spPr>
           <a:xfrm>
-            <a:off x="3172968" y="5980176"/>
+            <a:off x="3035808" y="5980176"/>
             <a:ext cx="420624" cy="146304"/>
           </a:xfrm>
           <a:prstGeom prst="roundRect">
@@ -10780,7 +10780,7 @@
         </p:nvSpPr>
         <p:spPr>
           <a:xfrm>
-            <a:off x="3172968" y="5980176"/>
+            <a:off x="3035808" y="5980176"/>
             <a:ext cx="420624" cy="146304"/>
           </a:xfrm>
           <a:prstGeom prst="rect">
@@ -10815,7 +10815,7 @@
         </p:nvCxnSpPr>
         <p:spPr>
           <a:xfrm>
-            <a:off x="3758184" y="5742432"/>
+            <a:off x="3593591" y="5742432"/>
             <a:ext cx="45720" cy="0"/>
           </a:xfrm>
           <a:prstGeom prst="line">
@@ -10851,8 +10851,8 @@
         </p:nvSpPr>
         <p:spPr>
           <a:xfrm>
-            <a:off x="3803904" y="5550408"/>
-            <a:ext cx="749808" cy="384048"/>
+            <a:off x="3639312" y="5550408"/>
+            <a:ext cx="694944" cy="384048"/>
           </a:xfrm>
           <a:prstGeom prst="roundRect">
             <a:avLst>
@@ -10897,8 +10897,8 @@
         </p:nvSpPr>
         <p:spPr>
           <a:xfrm>
-            <a:off x="3831336" y="5550408"/>
-            <a:ext cx="694944" cy="384048"/>
+            <a:off x="3666744" y="5550408"/>
+            <a:ext cx="640080" cy="384048"/>
           </a:xfrm>
           <a:prstGeom prst="rect">
             <a:avLst/>
@@ -10944,7 +10944,7 @@
         </p:nvCxnSpPr>
         <p:spPr>
           <a:xfrm>
-            <a:off x="4553712" y="5742432"/>
+            <a:off x="4334256" y="5742432"/>
             <a:ext cx="45720" cy="0"/>
           </a:xfrm>
           <a:prstGeom prst="line">
@@ -10980,8 +10980,8 @@
         </p:nvSpPr>
         <p:spPr>
           <a:xfrm>
-            <a:off x="4599432" y="5550408"/>
-            <a:ext cx="749808" cy="384048"/>
+            <a:off x="4379976" y="5550408"/>
+            <a:ext cx="694944" cy="384048"/>
           </a:xfrm>
           <a:prstGeom prst="roundRect">
             <a:avLst>
@@ -11026,8 +11026,8 @@
         </p:nvSpPr>
         <p:spPr>
           <a:xfrm>
-            <a:off x="4626864" y="5550408"/>
-            <a:ext cx="694944" cy="384048"/>
+            <a:off x="4407408" y="5550408"/>
+            <a:ext cx="640080" cy="384048"/>
           </a:xfrm>
           <a:prstGeom prst="rect">
             <a:avLst/>
@@ -11073,7 +11073,7 @@
         </p:nvSpPr>
         <p:spPr>
           <a:xfrm>
-            <a:off x="4764024" y="5980176"/>
+            <a:off x="4517136" y="5980176"/>
             <a:ext cx="420624" cy="146304"/>
           </a:xfrm>
           <a:prstGeom prst="roundRect">
@@ -11119,7 +11119,7 @@
         </p:nvSpPr>
         <p:spPr>
           <a:xfrm>
-            <a:off x="4764024" y="5980176"/>
+            <a:off x="4517136" y="5980176"/>
             <a:ext cx="420624" cy="146304"/>
           </a:xfrm>
           <a:prstGeom prst="rect">
@@ -11154,7 +11154,7 @@
         </p:nvCxnSpPr>
         <p:spPr>
           <a:xfrm>
-            <a:off x="5349240" y="5742432"/>
+            <a:off x="5074920" y="5742432"/>
             <a:ext cx="45720" cy="0"/>
           </a:xfrm>
           <a:prstGeom prst="line">
@@ -11190,8 +11190,8 @@
         </p:nvSpPr>
         <p:spPr>
           <a:xfrm>
-            <a:off x="5394959" y="5550408"/>
-            <a:ext cx="749808" cy="384048"/>
+            <a:off x="5120640" y="5550408"/>
+            <a:ext cx="694944" cy="384048"/>
           </a:xfrm>
           <a:prstGeom prst="roundRect">
             <a:avLst>
@@ -11236,8 +11236,8 @@
         </p:nvSpPr>
         <p:spPr>
           <a:xfrm>
-            <a:off x="5422392" y="5550408"/>
-            <a:ext cx="694944" cy="384048"/>
+            <a:off x="5148072" y="5550408"/>
+            <a:ext cx="640080" cy="384048"/>
           </a:xfrm>
           <a:prstGeom prst="rect">
             <a:avLst/>
@@ -11283,7 +11283,7 @@
         </p:nvSpPr>
         <p:spPr>
           <a:xfrm>
-            <a:off x="5559551" y="5980176"/>
+            <a:off x="5257800" y="5980176"/>
             <a:ext cx="420624" cy="146304"/>
           </a:xfrm>
           <a:prstGeom prst="roundRect">
@@ -11329,7 +11329,7 @@
         </p:nvSpPr>
         <p:spPr>
           <a:xfrm>
-            <a:off x="5559551" y="5980176"/>
+            <a:off x="5257800" y="5980176"/>
             <a:ext cx="420624" cy="146304"/>
           </a:xfrm>
           <a:prstGeom prst="rect">
@@ -11364,7 +11364,7 @@
         </p:nvCxnSpPr>
         <p:spPr>
           <a:xfrm>
-            <a:off x="6144768" y="5742432"/>
+            <a:off x="5815584" y="5742432"/>
             <a:ext cx="45720" cy="0"/>
           </a:xfrm>
           <a:prstGeom prst="line">
@@ -11400,8 +11400,8 @@
         </p:nvSpPr>
         <p:spPr>
           <a:xfrm>
-            <a:off x="6190488" y="5550408"/>
-            <a:ext cx="749808" cy="384048"/>
+            <a:off x="5861304" y="5550408"/>
+            <a:ext cx="694944" cy="384048"/>
           </a:xfrm>
           <a:prstGeom prst="roundRect">
             <a:avLst>
@@ -11446,8 +11446,8 @@
         </p:nvSpPr>
         <p:spPr>
           <a:xfrm>
-            <a:off x="6217920" y="5550408"/>
-            <a:ext cx="694944" cy="384048"/>
+            <a:off x="5888736" y="5550408"/>
+            <a:ext cx="640080" cy="384048"/>
           </a:xfrm>
           <a:prstGeom prst="rect">
             <a:avLst/>
@@ -11493,7 +11493,7 @@
         </p:nvCxnSpPr>
         <p:spPr>
           <a:xfrm>
-            <a:off x="6940296" y="5742432"/>
+            <a:off x="6556248" y="5742432"/>
             <a:ext cx="45720" cy="0"/>
           </a:xfrm>
           <a:prstGeom prst="line">
@@ -11529,8 +11529,8 @@
         </p:nvSpPr>
         <p:spPr>
           <a:xfrm>
-            <a:off x="6986016" y="5550408"/>
-            <a:ext cx="749808" cy="384048"/>
+            <a:off x="6601968" y="5550408"/>
+            <a:ext cx="694944" cy="384048"/>
           </a:xfrm>
           <a:prstGeom prst="roundRect">
             <a:avLst>
@@ -11575,8 +11575,8 @@
         </p:nvSpPr>
         <p:spPr>
           <a:xfrm>
-            <a:off x="7013448" y="5550408"/>
-            <a:ext cx="694944" cy="384048"/>
+            <a:off x="6629400" y="5550408"/>
+            <a:ext cx="640080" cy="384048"/>
           </a:xfrm>
           <a:prstGeom prst="rect">
             <a:avLst/>
@@ -11622,7 +11622,7 @@
         </p:nvSpPr>
         <p:spPr>
           <a:xfrm>
-            <a:off x="7150607" y="5980176"/>
+            <a:off x="6739128" y="5980176"/>
             <a:ext cx="420624" cy="146304"/>
           </a:xfrm>
           <a:prstGeom prst="roundRect">
@@ -11668,7 +11668,7 @@
         </p:nvSpPr>
         <p:spPr>
           <a:xfrm>
-            <a:off x="7150607" y="5980176"/>
+            <a:off x="6739128" y="5980176"/>
             <a:ext cx="420624" cy="146304"/>
           </a:xfrm>
           <a:prstGeom prst="rect">
@@ -11703,8 +11703,8 @@
         </p:nvCxnSpPr>
         <p:spPr>
           <a:xfrm>
-            <a:off x="7735823" y="5742432"/>
-            <a:ext cx="45721" cy="0"/>
+            <a:off x="7296912" y="5742432"/>
+            <a:ext cx="45719" cy="0"/>
           </a:xfrm>
           <a:prstGeom prst="line">
             <a:avLst/>
@@ -11739,8 +11739,8 @@
         </p:nvSpPr>
         <p:spPr>
           <a:xfrm>
-            <a:off x="7781544" y="5550408"/>
-            <a:ext cx="749808" cy="384048"/>
+            <a:off x="7342632" y="5550408"/>
+            <a:ext cx="694944" cy="384048"/>
           </a:xfrm>
           <a:prstGeom prst="roundRect">
             <a:avLst>
@@ -11748,11 +11748,11 @@
             </a:avLst>
           </a:prstGeom>
           <a:solidFill>
-            <a:srgbClr val="FFD700"/>
+            <a:srgbClr val="FFFFFF"/>
           </a:solidFill>
           <a:ln w="9525">
             <a:solidFill>
-              <a:srgbClr val="FFD700"/>
+              <a:srgbClr val="0097AD"/>
             </a:solidFill>
           </a:ln>
           <a:effectLst/>
@@ -11785,8 +11785,8 @@
         </p:nvSpPr>
         <p:spPr>
           <a:xfrm>
-            <a:off x="7808975" y="5550408"/>
-            <a:ext cx="694944" cy="384048"/>
+            <a:off x="7370064" y="5550408"/>
+            <a:ext cx="640080" cy="384048"/>
           </a:xfrm>
           <a:prstGeom prst="rect">
             <a:avLst/>
@@ -11807,7 +11807,7 @@
                 </a:solidFill>
                 <a:latin typeface="Trenda IG Text"/>
               </a:rPr>
-              <a:t>06 UAT · H4</a:t>
+              <a:t>06 UAT</a:t>
             </a:r>
           </a:p>
           <a:p>
@@ -11819,7 +11819,7 @@
                 </a:solidFill>
                 <a:latin typeface="Trenda IG Text"/>
               </a:rPr>
-              <a:t>business sign-off</a:t>
+              <a:t>business testers</a:t>
             </a:r>
           </a:p>
         </p:txBody>
@@ -11832,7 +11832,7 @@
         </p:nvCxnSpPr>
         <p:spPr>
           <a:xfrm>
-            <a:off x="8531352" y="5742432"/>
+            <a:off x="8037576" y="5742432"/>
             <a:ext cx="45720" cy="0"/>
           </a:xfrm>
           <a:prstGeom prst="line">
@@ -11868,8 +11868,8 @@
         </p:nvSpPr>
         <p:spPr>
           <a:xfrm>
-            <a:off x="8577072" y="5550408"/>
-            <a:ext cx="749808" cy="384048"/>
+            <a:off x="8083296" y="5550408"/>
+            <a:ext cx="694944" cy="384048"/>
           </a:xfrm>
           <a:prstGeom prst="roundRect">
             <a:avLst>
@@ -11877,11 +11877,11 @@
             </a:avLst>
           </a:prstGeom>
           <a:solidFill>
-            <a:srgbClr val="FFFFFF"/>
+            <a:srgbClr val="FFD700"/>
           </a:solidFill>
           <a:ln w="9525">
             <a:solidFill>
-              <a:srgbClr val="0097AD"/>
+              <a:srgbClr val="FFD700"/>
             </a:solidFill>
           </a:ln>
           <a:effectLst/>
@@ -11914,8 +11914,137 @@
         </p:nvSpPr>
         <p:spPr>
           <a:xfrm>
-            <a:off x="8604504" y="5550408"/>
+            <a:off x="8110728" y="5550408"/>
+            <a:ext cx="640080" cy="384048"/>
+          </a:xfrm>
+          <a:prstGeom prst="rect">
+            <a:avLst/>
+          </a:prstGeom>
+          <a:noFill/>
+        </p:spPr>
+        <p:txBody>
+          <a:bodyPr wrap="square" lIns="0" rIns="0" tIns="0" bIns="0" anchor="ctr">
+            <a:spAutoFit/>
+          </a:bodyPr>
+          <a:lstStyle/>
+          <a:p>
+            <a:pPr algn="ctr"/>
+            <a:r>
+              <a:rPr sz="650" b="1" i="0">
+                <a:solidFill>
+                  <a:srgbClr val="000000"/>
+                </a:solidFill>
+                <a:latin typeface="Trenda IG Text"/>
+              </a:rPr>
+              <a:t>H4</a:t>
+            </a:r>
+          </a:p>
+          <a:p>
+            <a:pPr algn="ctr"/>
+            <a:r>
+              <a:rPr sz="530" b="0" i="0">
+                <a:solidFill>
+                  <a:srgbClr val="2B2B2B"/>
+                </a:solidFill>
+                <a:latin typeface="Trenda IG Text"/>
+              </a:rPr>
+              <a:t>business sign-off</a:t>
+            </a:r>
+          </a:p>
+        </p:txBody>
+      </p:sp>
+      <p:cxnSp>
+        <p:nvCxnSpPr>
+          <p:cNvPr id="222" name="Arrow 211"/>
+          <p:cNvCxnSpPr/>
+          <p:nvPr/>
+        </p:nvCxnSpPr>
+        <p:spPr>
+          <a:xfrm>
+            <a:off x="8778240" y="5742432"/>
+            <a:ext cx="45720" cy="0"/>
+          </a:xfrm>
+          <a:prstGeom prst="line">
+            <a:avLst/>
+          </a:prstGeom>
+          <a:ln w="9525">
+            <a:solidFill>
+              <a:srgbClr val="595959"/>
+            </a:solidFill>
+            <a:tailEnd type="triangle" w="med" len="med"/>
+          </a:ln>
+        </p:spPr>
+        <p:style>
+          <a:lnRef idx="2">
+            <a:schemeClr val="accent1"/>
+          </a:lnRef>
+          <a:fillRef idx="0">
+            <a:schemeClr val="accent1"/>
+          </a:fillRef>
+          <a:effectRef idx="1">
+            <a:schemeClr val="accent1"/>
+          </a:effectRef>
+          <a:fontRef idx="minor">
+            <a:schemeClr val="tx1"/>
+          </a:fontRef>
+        </p:style>
+      </p:cxnSp>
+      <p:sp>
+        <p:nvSpPr>
+          <p:cNvPr id="223" name="Shape 212"/>
+          <p:cNvSpPr/>
+          <p:nvPr/>
+        </p:nvSpPr>
+        <p:spPr>
+          <a:xfrm>
+            <a:off x="8823960" y="5550408"/>
             <a:ext cx="694944" cy="384048"/>
+          </a:xfrm>
+          <a:prstGeom prst="roundRect">
+            <a:avLst>
+              <a:gd name="adj" fmla="val 25000"/>
+            </a:avLst>
+          </a:prstGeom>
+          <a:solidFill>
+            <a:srgbClr val="FFFFFF"/>
+          </a:solidFill>
+          <a:ln w="9525">
+            <a:solidFill>
+              <a:srgbClr val="0097AD"/>
+            </a:solidFill>
+          </a:ln>
+          <a:effectLst/>
+        </p:spPr>
+        <p:style>
+          <a:lnRef idx="1">
+            <a:schemeClr val="accent1"/>
+          </a:lnRef>
+          <a:fillRef idx="3">
+            <a:schemeClr val="accent1"/>
+          </a:fillRef>
+          <a:effectRef idx="2">
+            <a:schemeClr val="accent1"/>
+          </a:effectRef>
+          <a:fontRef idx="minor">
+            <a:schemeClr val="lt1"/>
+          </a:fontRef>
+        </p:style>
+        <p:txBody>
+          <a:bodyPr rtlCol="0" anchor="ctr"/>
+          <a:lstStyle/>
+          <a:p/>
+        </p:txBody>
+      </p:sp>
+      <p:sp>
+        <p:nvSpPr>
+          <p:cNvPr id="224" name="Text 213"/>
+          <p:cNvSpPr txBox="1"/>
+          <p:nvPr/>
+        </p:nvSpPr>
+        <p:spPr>
+          <a:xfrm>
+            <a:off x="8851392" y="5550408"/>
+            <a:ext cx="640080" cy="384048"/>
           </a:xfrm>
           <a:prstGeom prst="rect">
             <a:avLst/>
@@ -11955,13 +12084,13 @@
       </p:sp>
       <p:sp>
         <p:nvSpPr>
-          <p:cNvPr id="222" name="Shape 211"/>
+          <p:cNvPr id="225" name="Shape 214"/>
           <p:cNvSpPr/>
           <p:nvPr/>
         </p:nvSpPr>
         <p:spPr>
           <a:xfrm>
-            <a:off x="8741664" y="5980176"/>
+            <a:off x="8961120" y="5980176"/>
             <a:ext cx="420624" cy="146304"/>
           </a:xfrm>
           <a:prstGeom prst="roundRect">
@@ -12001,13 +12130,13 @@
       </p:sp>
       <p:sp>
         <p:nvSpPr>
-          <p:cNvPr id="223" name="Text 212"/>
+          <p:cNvPr id="226" name="Text 215"/>
           <p:cNvSpPr txBox="1"/>
           <p:nvPr/>
         </p:nvSpPr>
         <p:spPr>
           <a:xfrm>
-            <a:off x="8741664" y="5980176"/>
+            <a:off x="8961120" y="5980176"/>
             <a:ext cx="420624" cy="146304"/>
           </a:xfrm>
           <a:prstGeom prst="rect">
@@ -12036,13 +12165,13 @@
       </p:sp>
       <p:cxnSp>
         <p:nvCxnSpPr>
-          <p:cNvPr id="224" name="Arrow 213"/>
+          <p:cNvPr id="227" name="Arrow 216"/>
           <p:cNvCxnSpPr/>
           <p:nvPr/>
         </p:nvCxnSpPr>
         <p:spPr>
           <a:xfrm>
-            <a:off x="9326880" y="5742432"/>
+            <a:off x="9518904" y="5742432"/>
             <a:ext cx="45720" cy="0"/>
           </a:xfrm>
           <a:prstGeom prst="line">
@@ -12072,14 +12201,14 @@
       </p:cxnSp>
       <p:sp>
         <p:nvSpPr>
-          <p:cNvPr id="225" name="Shape 214"/>
+          <p:cNvPr id="228" name="Shape 217"/>
           <p:cNvSpPr/>
           <p:nvPr/>
         </p:nvSpPr>
         <p:spPr>
           <a:xfrm>
-            <a:off x="9372600" y="5550408"/>
-            <a:ext cx="749808" cy="384048"/>
+            <a:off x="9564624" y="5550408"/>
+            <a:ext cx="694944" cy="384048"/>
           </a:xfrm>
           <a:prstGeom prst="roundRect">
             <a:avLst>
@@ -12118,14 +12247,14 @@
       </p:sp>
       <p:sp>
         <p:nvSpPr>
-          <p:cNvPr id="226" name="Text 215"/>
+          <p:cNvPr id="229" name="Text 218"/>
           <p:cNvSpPr txBox="1"/>
           <p:nvPr/>
         </p:nvSpPr>
         <p:spPr>
           <a:xfrm>
-            <a:off x="9400032" y="5550408"/>
-            <a:ext cx="694944" cy="384048"/>
+            <a:off x="9592056" y="5550408"/>
+            <a:ext cx="640080" cy="384048"/>
           </a:xfrm>
           <a:prstGeom prst="rect">
             <a:avLst/>
@@ -12165,13 +12294,13 @@
       </p:sp>
       <p:cxnSp>
         <p:nvCxnSpPr>
-          <p:cNvPr id="227" name="Arrow 216"/>
+          <p:cNvPr id="230" name="Arrow 219"/>
           <p:cNvCxnSpPr/>
           <p:nvPr/>
         </p:nvCxnSpPr>
         <p:spPr>
           <a:xfrm>
-            <a:off x="10122408" y="5742432"/>
+            <a:off x="10259568" y="5742432"/>
             <a:ext cx="45720" cy="0"/>
           </a:xfrm>
           <a:prstGeom prst="line">
@@ -12201,14 +12330,14 @@
       </p:cxnSp>
       <p:sp>
         <p:nvSpPr>
-          <p:cNvPr id="228" name="Shape 217"/>
+          <p:cNvPr id="231" name="Shape 220"/>
           <p:cNvSpPr/>
           <p:nvPr/>
         </p:nvSpPr>
         <p:spPr>
           <a:xfrm>
-            <a:off x="10168128" y="5550408"/>
-            <a:ext cx="749808" cy="384048"/>
+            <a:off x="10305288" y="5550408"/>
+            <a:ext cx="694944" cy="384048"/>
           </a:xfrm>
           <a:prstGeom prst="roundRect">
             <a:avLst>
@@ -12248,14 +12377,14 @@
       </p:sp>
       <p:sp>
         <p:nvSpPr>
-          <p:cNvPr id="229" name="Text 218"/>
+          <p:cNvPr id="232" name="Text 221"/>
           <p:cNvSpPr txBox="1"/>
           <p:nvPr/>
         </p:nvSpPr>
         <p:spPr>
           <a:xfrm>
-            <a:off x="10195560" y="5550408"/>
-            <a:ext cx="694944" cy="384048"/>
+            <a:off x="10332720" y="5550408"/>
+            <a:ext cx="640080" cy="384048"/>
           </a:xfrm>
           <a:prstGeom prst="rect">
             <a:avLst/>
@@ -12295,13 +12424,13 @@
       </p:sp>
       <p:cxnSp>
         <p:nvCxnSpPr>
-          <p:cNvPr id="230" name="Arrow 219"/>
+          <p:cNvPr id="233" name="Arrow 222"/>
           <p:cNvCxnSpPr/>
           <p:nvPr/>
         </p:nvCxnSpPr>
         <p:spPr>
           <a:xfrm>
-            <a:off x="10917936" y="5742432"/>
+            <a:off x="11000232" y="5742432"/>
             <a:ext cx="45720" cy="0"/>
           </a:xfrm>
           <a:prstGeom prst="line">
@@ -12331,14 +12460,14 @@
       </p:cxnSp>
       <p:sp>
         <p:nvSpPr>
-          <p:cNvPr id="231" name="Shape 220"/>
+          <p:cNvPr id="234" name="Shape 223"/>
           <p:cNvSpPr/>
           <p:nvPr/>
         </p:nvSpPr>
         <p:spPr>
           <a:xfrm>
-            <a:off x="10963656" y="5550408"/>
-            <a:ext cx="749808" cy="384048"/>
+            <a:off x="11045952" y="5550408"/>
+            <a:ext cx="694944" cy="384048"/>
           </a:xfrm>
           <a:prstGeom prst="roundRect">
             <a:avLst>
@@ -12377,14 +12506,14 @@
       </p:sp>
       <p:sp>
         <p:nvSpPr>
-          <p:cNvPr id="232" name="Text 221"/>
+          <p:cNvPr id="235" name="Text 224"/>
           <p:cNvSpPr txBox="1"/>
           <p:nvPr/>
         </p:nvSpPr>
         <p:spPr>
           <a:xfrm>
-            <a:off x="10991088" y="5550408"/>
-            <a:ext cx="694944" cy="384048"/>
+            <a:off x="11073384" y="5550408"/>
+            <a:ext cx="640080" cy="384048"/>
           </a:xfrm>
           <a:prstGeom prst="rect">
             <a:avLst/>
@@ -12424,7 +12553,7 @@
       </p:sp>
       <p:sp>
         <p:nvSpPr>
-          <p:cNvPr id="233" name="Text 222"/>
+          <p:cNvPr id="236" name="Text 225"/>
           <p:cNvSpPr txBox="1"/>
           <p:nvPr/>
         </p:nvSpPr>
@@ -12458,7 +12587,7 @@
       </p:sp>
       <p:sp>
         <p:nvSpPr>
-          <p:cNvPr id="234" name="Text 223"/>
+          <p:cNvPr id="237" name="Text 226"/>
           <p:cNvSpPr txBox="1"/>
           <p:nvPr/>
         </p:nvSpPr>
@@ -12492,7 +12621,7 @@
       </p:sp>
       <p:grpSp>
         <p:nvGrpSpPr>
-          <p:cNvPr id="235" name="Step 1 highlight"/>
+          <p:cNvPr id="238" name="Step 1 highlight"/>
           <p:cNvGrpSpPr/>
           <p:nvPr/>
         </p:nvGrpSpPr>
@@ -12506,7 +12635,7 @@
         </p:grpSpPr>
         <p:sp>
           <p:nvSpPr>
-            <p:cNvPr id="236" name="Shape 1"/>
+            <p:cNvPr id="239" name="Shape 1"/>
             <p:cNvSpPr/>
             <p:nvPr/>
           </p:nvSpPr>
@@ -12550,7 +12679,7 @@
         </p:sp>
         <p:sp>
           <p:nvSpPr>
-            <p:cNvPr id="237" name="Shape 2"/>
+            <p:cNvPr id="240" name="Shape 2"/>
             <p:cNvSpPr/>
             <p:nvPr/>
           </p:nvSpPr>
@@ -12594,7 +12723,7 @@
         </p:sp>
         <p:sp>
           <p:nvSpPr>
-            <p:cNvPr id="238" name="Shape 3"/>
+            <p:cNvPr id="241" name="Shape 3"/>
             <p:cNvSpPr/>
             <p:nvPr/>
           </p:nvSpPr>
@@ -12638,7 +12767,7 @@
         </p:sp>
         <p:sp>
           <p:nvSpPr>
-            <p:cNvPr id="239" name="Shape 4"/>
+            <p:cNvPr id="242" name="Shape 4"/>
             <p:cNvSpPr/>
             <p:nvPr/>
           </p:nvSpPr>
@@ -12682,7 +12811,7 @@
         </p:sp>
         <p:sp>
           <p:nvSpPr>
-            <p:cNvPr id="240" name="Shape 5"/>
+            <p:cNvPr id="243" name="Shape 5"/>
             <p:cNvSpPr/>
             <p:nvPr/>
           </p:nvSpPr>
@@ -12726,7 +12855,7 @@
         </p:sp>
         <p:sp>
           <p:nvSpPr>
-            <p:cNvPr id="241" name="Shape 6"/>
+            <p:cNvPr id="244" name="Shape 6"/>
             <p:cNvSpPr/>
             <p:nvPr/>
           </p:nvSpPr>
@@ -12770,7 +12899,7 @@
         </p:sp>
         <p:sp>
           <p:nvSpPr>
-            <p:cNvPr id="242" name="Shape 7"/>
+            <p:cNvPr id="245" name="Shape 7"/>
             <p:cNvSpPr/>
             <p:nvPr/>
           </p:nvSpPr>
@@ -12814,7 +12943,7 @@
         </p:sp>
         <p:sp>
           <p:nvSpPr>
-            <p:cNvPr id="243" name="Shape 8"/>
+            <p:cNvPr id="246" name="Shape 8"/>
             <p:cNvSpPr/>
             <p:nvPr/>
           </p:nvSpPr>
@@ -12858,7 +12987,7 @@
         </p:sp>
         <p:sp>
           <p:nvSpPr>
-            <p:cNvPr id="244" name="Shape 9"/>
+            <p:cNvPr id="247" name="Shape 9"/>
             <p:cNvSpPr/>
             <p:nvPr/>
           </p:nvSpPr>
@@ -12902,7 +13031,7 @@
         </p:sp>
         <p:sp>
           <p:nvSpPr>
-            <p:cNvPr id="245" name="Shape 10"/>
+            <p:cNvPr id="248" name="Shape 10"/>
             <p:cNvSpPr/>
             <p:nvPr/>
           </p:nvSpPr>
@@ -12946,7 +13075,7 @@
         </p:sp>
         <p:sp>
           <p:nvSpPr>
-            <p:cNvPr id="246" name="Shape 11"/>
+            <p:cNvPr id="249" name="Shape 11"/>
             <p:cNvSpPr/>
             <p:nvPr/>
           </p:nvSpPr>
@@ -12992,7 +13121,7 @@
         </p:sp>
         <p:sp>
           <p:nvSpPr>
-            <p:cNvPr id="247" name="Text 12"/>
+            <p:cNvPr id="250" name="Text 12"/>
             <p:cNvSpPr txBox="1"/>
             <p:nvPr/>
           </p:nvSpPr>
@@ -13057,7 +13186,7 @@
       </p:grpSp>
       <p:grpSp>
         <p:nvGrpSpPr>
-          <p:cNvPr id="248" name="Step 1 arrows"/>
+          <p:cNvPr id="251" name="Step 1 arrows"/>
           <p:cNvGrpSpPr/>
           <p:nvPr/>
         </p:nvGrpSpPr>
@@ -13071,7 +13200,7 @@
         </p:grpSpPr>
         <p:cxnSp>
           <p:nvCxnSpPr>
-            <p:cNvPr id="249" name="Arrow 1"/>
+            <p:cNvPr id="252" name="Arrow 1"/>
             <p:cNvCxnSpPr/>
             <p:nvPr/>
           </p:nvCxnSpPr>
@@ -13107,7 +13236,7 @@
         </p:cxnSp>
         <p:cxnSp>
           <p:nvCxnSpPr>
-            <p:cNvPr id="250" name="Arrow 2"/>
+            <p:cNvPr id="253" name="Arrow 2"/>
             <p:cNvCxnSpPr/>
             <p:nvPr/>
           </p:nvCxnSpPr>
@@ -13144,7 +13273,7 @@
       </p:grpSp>
       <p:grpSp>
         <p:nvGrpSpPr>
-          <p:cNvPr id="251" name="Step 2 highlight"/>
+          <p:cNvPr id="254" name="Step 2 highlight"/>
           <p:cNvGrpSpPr/>
           <p:nvPr/>
         </p:nvGrpSpPr>
@@ -13158,7 +13287,7 @@
         </p:grpSpPr>
         <p:sp>
           <p:nvSpPr>
-            <p:cNvPr id="252" name="Shape 1"/>
+            <p:cNvPr id="255" name="Shape 1"/>
             <p:cNvSpPr/>
             <p:nvPr/>
           </p:nvSpPr>
@@ -13202,7 +13331,7 @@
         </p:sp>
         <p:sp>
           <p:nvSpPr>
-            <p:cNvPr id="253" name="Shape 2"/>
+            <p:cNvPr id="256" name="Shape 2"/>
             <p:cNvSpPr/>
             <p:nvPr/>
           </p:nvSpPr>
@@ -13246,7 +13375,7 @@
         </p:sp>
         <p:sp>
           <p:nvSpPr>
-            <p:cNvPr id="254" name="Shape 3"/>
+            <p:cNvPr id="257" name="Shape 3"/>
             <p:cNvSpPr/>
             <p:nvPr/>
           </p:nvSpPr>
@@ -13290,7 +13419,7 @@
         </p:sp>
         <p:sp>
           <p:nvSpPr>
-            <p:cNvPr id="255" name="Shape 4"/>
+            <p:cNvPr id="258" name="Shape 4"/>
             <p:cNvSpPr/>
             <p:nvPr/>
           </p:nvSpPr>
@@ -13334,7 +13463,7 @@
         </p:sp>
         <p:sp>
           <p:nvSpPr>
-            <p:cNvPr id="256" name="Shape 5"/>
+            <p:cNvPr id="259" name="Shape 5"/>
             <p:cNvSpPr/>
             <p:nvPr/>
           </p:nvSpPr>
@@ -13378,7 +13507,7 @@
         </p:sp>
         <p:sp>
           <p:nvSpPr>
-            <p:cNvPr id="257" name="Shape 6"/>
+            <p:cNvPr id="260" name="Shape 6"/>
             <p:cNvSpPr/>
             <p:nvPr/>
           </p:nvSpPr>
@@ -13422,7 +13551,7 @@
         </p:sp>
         <p:sp>
           <p:nvSpPr>
-            <p:cNvPr id="258" name="Shape 7"/>
+            <p:cNvPr id="261" name="Shape 7"/>
             <p:cNvSpPr/>
             <p:nvPr/>
           </p:nvSpPr>
@@ -13466,7 +13595,7 @@
         </p:sp>
         <p:sp>
           <p:nvSpPr>
-            <p:cNvPr id="259" name="Shape 8"/>
+            <p:cNvPr id="262" name="Shape 8"/>
             <p:cNvSpPr/>
             <p:nvPr/>
           </p:nvSpPr>
@@ -13510,7 +13639,7 @@
         </p:sp>
         <p:sp>
           <p:nvSpPr>
-            <p:cNvPr id="260" name="Shape 9"/>
+            <p:cNvPr id="263" name="Shape 9"/>
             <p:cNvSpPr/>
             <p:nvPr/>
           </p:nvSpPr>
@@ -13554,7 +13683,7 @@
         </p:sp>
         <p:sp>
           <p:nvSpPr>
-            <p:cNvPr id="261" name="Shape 10"/>
+            <p:cNvPr id="264" name="Shape 10"/>
             <p:cNvSpPr/>
             <p:nvPr/>
           </p:nvSpPr>
@@ -13598,7 +13727,7 @@
         </p:sp>
         <p:sp>
           <p:nvSpPr>
-            <p:cNvPr id="262" name="Shape 11"/>
+            <p:cNvPr id="265" name="Shape 11"/>
             <p:cNvSpPr/>
             <p:nvPr/>
           </p:nvSpPr>
@@ -13642,7 +13771,7 @@
         </p:sp>
         <p:sp>
           <p:nvSpPr>
-            <p:cNvPr id="263" name="Shape 12"/>
+            <p:cNvPr id="266" name="Shape 12"/>
             <p:cNvSpPr/>
             <p:nvPr/>
           </p:nvSpPr>
@@ -13686,7 +13815,7 @@
         </p:sp>
         <p:sp>
           <p:nvSpPr>
-            <p:cNvPr id="264" name="Shape 13"/>
+            <p:cNvPr id="267" name="Shape 13"/>
             <p:cNvSpPr/>
             <p:nvPr/>
           </p:nvSpPr>
@@ -13730,7 +13859,7 @@
         </p:sp>
         <p:sp>
           <p:nvSpPr>
-            <p:cNvPr id="265" name="Shape 14"/>
+            <p:cNvPr id="268" name="Shape 14"/>
             <p:cNvSpPr/>
             <p:nvPr/>
           </p:nvSpPr>
@@ -13774,7 +13903,7 @@
         </p:sp>
         <p:sp>
           <p:nvSpPr>
-            <p:cNvPr id="266" name="Shape 15"/>
+            <p:cNvPr id="269" name="Shape 15"/>
             <p:cNvSpPr/>
             <p:nvPr/>
           </p:nvSpPr>
@@ -13818,7 +13947,7 @@
         </p:sp>
         <p:sp>
           <p:nvSpPr>
-            <p:cNvPr id="267" name="Shape 16"/>
+            <p:cNvPr id="270" name="Shape 16"/>
             <p:cNvSpPr/>
             <p:nvPr/>
           </p:nvSpPr>
@@ -13862,7 +13991,7 @@
         </p:sp>
         <p:sp>
           <p:nvSpPr>
-            <p:cNvPr id="268" name="Shape 17"/>
+            <p:cNvPr id="271" name="Shape 17"/>
             <p:cNvSpPr/>
             <p:nvPr/>
           </p:nvSpPr>
@@ -13906,7 +14035,7 @@
         </p:sp>
         <p:sp>
           <p:nvSpPr>
-            <p:cNvPr id="269" name="Shape 18"/>
+            <p:cNvPr id="272" name="Shape 18"/>
             <p:cNvSpPr/>
             <p:nvPr/>
           </p:nvSpPr>
@@ -13950,7 +14079,7 @@
         </p:sp>
         <p:sp>
           <p:nvSpPr>
-            <p:cNvPr id="270" name="Shape 19"/>
+            <p:cNvPr id="273" name="Shape 19"/>
             <p:cNvSpPr/>
             <p:nvPr/>
           </p:nvSpPr>
@@ -13996,7 +14125,7 @@
         </p:sp>
         <p:sp>
           <p:nvSpPr>
-            <p:cNvPr id="271" name="Text 20"/>
+            <p:cNvPr id="274" name="Text 20"/>
             <p:cNvSpPr txBox="1"/>
             <p:nvPr/>
           </p:nvSpPr>
@@ -14061,7 +14190,7 @@
       </p:grpSp>
       <p:grpSp>
         <p:nvGrpSpPr>
-          <p:cNvPr id="272" name="Step 2 arrows"/>
+          <p:cNvPr id="275" name="Step 2 arrows"/>
           <p:cNvGrpSpPr/>
           <p:nvPr/>
         </p:nvGrpSpPr>
@@ -14075,7 +14204,7 @@
         </p:grpSpPr>
         <p:cxnSp>
           <p:nvCxnSpPr>
-            <p:cNvPr id="273" name="Arrow 1"/>
+            <p:cNvPr id="276" name="Arrow 1"/>
             <p:cNvCxnSpPr/>
             <p:nvPr/>
           </p:nvCxnSpPr>
@@ -14111,7 +14240,7 @@
         </p:cxnSp>
         <p:cxnSp>
           <p:nvCxnSpPr>
-            <p:cNvPr id="274" name="Arrow 2"/>
+            <p:cNvPr id="277" name="Arrow 2"/>
             <p:cNvCxnSpPr/>
             <p:nvPr/>
           </p:nvCxnSpPr>
@@ -14148,7 +14277,7 @@
       </p:grpSp>
       <p:grpSp>
         <p:nvGrpSpPr>
-          <p:cNvPr id="275" name="Step 3 highlight"/>
+          <p:cNvPr id="278" name="Step 3 highlight"/>
           <p:cNvGrpSpPr/>
           <p:nvPr/>
         </p:nvGrpSpPr>
@@ -14162,7 +14291,7 @@
         </p:grpSpPr>
         <p:sp>
           <p:nvSpPr>
-            <p:cNvPr id="276" name="Shape 1"/>
+            <p:cNvPr id="279" name="Shape 1"/>
             <p:cNvSpPr/>
             <p:nvPr/>
           </p:nvSpPr>
@@ -14206,7 +14335,7 @@
         </p:sp>
         <p:sp>
           <p:nvSpPr>
-            <p:cNvPr id="277" name="Shape 2"/>
+            <p:cNvPr id="280" name="Shape 2"/>
             <p:cNvSpPr/>
             <p:nvPr/>
           </p:nvSpPr>
@@ -14250,7 +14379,7 @@
         </p:sp>
         <p:sp>
           <p:nvSpPr>
-            <p:cNvPr id="278" name="Shape 3"/>
+            <p:cNvPr id="281" name="Shape 3"/>
             <p:cNvSpPr/>
             <p:nvPr/>
           </p:nvSpPr>
@@ -14294,7 +14423,7 @@
         </p:sp>
         <p:sp>
           <p:nvSpPr>
-            <p:cNvPr id="279" name="Shape 4"/>
+            <p:cNvPr id="282" name="Shape 4"/>
             <p:cNvSpPr/>
             <p:nvPr/>
           </p:nvSpPr>
@@ -14338,7 +14467,7 @@
         </p:sp>
         <p:sp>
           <p:nvSpPr>
-            <p:cNvPr id="280" name="Shape 5"/>
+            <p:cNvPr id="283" name="Shape 5"/>
             <p:cNvSpPr/>
             <p:nvPr/>
           </p:nvSpPr>
@@ -14382,7 +14511,7 @@
         </p:sp>
         <p:sp>
           <p:nvSpPr>
-            <p:cNvPr id="281" name="Shape 6"/>
+            <p:cNvPr id="284" name="Shape 6"/>
             <p:cNvSpPr/>
             <p:nvPr/>
           </p:nvSpPr>
@@ -14426,7 +14555,7 @@
         </p:sp>
         <p:sp>
           <p:nvSpPr>
-            <p:cNvPr id="282" name="Shape 7"/>
+            <p:cNvPr id="285" name="Shape 7"/>
             <p:cNvSpPr/>
             <p:nvPr/>
           </p:nvSpPr>
@@ -14472,7 +14601,7 @@
         </p:sp>
         <p:sp>
           <p:nvSpPr>
-            <p:cNvPr id="283" name="Text 8"/>
+            <p:cNvPr id="286" name="Text 8"/>
             <p:cNvSpPr txBox="1"/>
             <p:nvPr/>
           </p:nvSpPr>
@@ -14537,7 +14666,7 @@
       </p:grpSp>
       <p:grpSp>
         <p:nvGrpSpPr>
-          <p:cNvPr id="284" name="Step 3 arrows"/>
+          <p:cNvPr id="287" name="Step 3 arrows"/>
           <p:cNvGrpSpPr/>
           <p:nvPr/>
         </p:nvGrpSpPr>
@@ -14551,7 +14680,7 @@
         </p:grpSpPr>
         <p:cxnSp>
           <p:nvCxnSpPr>
-            <p:cNvPr id="285" name="Arrow 1"/>
+            <p:cNvPr id="288" name="Arrow 1"/>
             <p:cNvCxnSpPr/>
             <p:nvPr/>
           </p:nvCxnSpPr>
@@ -14588,7 +14717,7 @@
       </p:grpSp>
       <p:grpSp>
         <p:nvGrpSpPr>
-          <p:cNvPr id="286" name="Step 4 highlight"/>
+          <p:cNvPr id="289" name="Step 4 highlight"/>
           <p:cNvGrpSpPr/>
           <p:nvPr/>
         </p:nvGrpSpPr>
@@ -14602,7 +14731,7 @@
         </p:grpSpPr>
         <p:sp>
           <p:nvSpPr>
-            <p:cNvPr id="287" name="Shape 1"/>
+            <p:cNvPr id="290" name="Shape 1"/>
             <p:cNvSpPr/>
             <p:nvPr/>
           </p:nvSpPr>
@@ -14646,7 +14775,7 @@
         </p:sp>
         <p:sp>
           <p:nvSpPr>
-            <p:cNvPr id="288" name="Shape 2"/>
+            <p:cNvPr id="291" name="Shape 2"/>
             <p:cNvSpPr/>
             <p:nvPr/>
           </p:nvSpPr>
@@ -14690,7 +14819,7 @@
         </p:sp>
         <p:sp>
           <p:nvSpPr>
-            <p:cNvPr id="289" name="Shape 3"/>
+            <p:cNvPr id="292" name="Shape 3"/>
             <p:cNvSpPr/>
             <p:nvPr/>
           </p:nvSpPr>
@@ -14734,7 +14863,7 @@
         </p:sp>
         <p:sp>
           <p:nvSpPr>
-            <p:cNvPr id="290" name="Shape 4"/>
+            <p:cNvPr id="293" name="Shape 4"/>
             <p:cNvSpPr/>
             <p:nvPr/>
           </p:nvSpPr>
@@ -14778,7 +14907,7 @@
         </p:sp>
         <p:sp>
           <p:nvSpPr>
-            <p:cNvPr id="291" name="Shape 5"/>
+            <p:cNvPr id="294" name="Shape 5"/>
             <p:cNvSpPr/>
             <p:nvPr/>
           </p:nvSpPr>
@@ -14822,7 +14951,7 @@
         </p:sp>
         <p:sp>
           <p:nvSpPr>
-            <p:cNvPr id="292" name="Shape 6"/>
+            <p:cNvPr id="295" name="Shape 6"/>
             <p:cNvSpPr/>
             <p:nvPr/>
           </p:nvSpPr>
@@ -14866,7 +14995,7 @@
         </p:sp>
         <p:sp>
           <p:nvSpPr>
-            <p:cNvPr id="293" name="Shape 7"/>
+            <p:cNvPr id="296" name="Shape 7"/>
             <p:cNvSpPr/>
             <p:nvPr/>
           </p:nvSpPr>
@@ -14910,7 +15039,7 @@
         </p:sp>
         <p:sp>
           <p:nvSpPr>
-            <p:cNvPr id="294" name="Shape 8"/>
+            <p:cNvPr id="297" name="Shape 8"/>
             <p:cNvSpPr/>
             <p:nvPr/>
           </p:nvSpPr>
@@ -14954,7 +15083,7 @@
         </p:sp>
         <p:sp>
           <p:nvSpPr>
-            <p:cNvPr id="295" name="Shape 9"/>
+            <p:cNvPr id="298" name="Shape 9"/>
             <p:cNvSpPr/>
             <p:nvPr/>
           </p:nvSpPr>
@@ -14998,7 +15127,7 @@
         </p:sp>
         <p:sp>
           <p:nvSpPr>
-            <p:cNvPr id="296" name="Shape 10"/>
+            <p:cNvPr id="299" name="Shape 10"/>
             <p:cNvSpPr/>
             <p:nvPr/>
           </p:nvSpPr>
@@ -15042,7 +15171,7 @@
         </p:sp>
         <p:sp>
           <p:nvSpPr>
-            <p:cNvPr id="297" name="Shape 11"/>
+            <p:cNvPr id="300" name="Shape 11"/>
             <p:cNvSpPr/>
             <p:nvPr/>
           </p:nvSpPr>
@@ -15086,7 +15215,7 @@
         </p:sp>
         <p:sp>
           <p:nvSpPr>
-            <p:cNvPr id="298" name="Shape 12"/>
+            <p:cNvPr id="301" name="Shape 12"/>
             <p:cNvSpPr/>
             <p:nvPr/>
           </p:nvSpPr>
@@ -15130,7 +15259,7 @@
         </p:sp>
         <p:sp>
           <p:nvSpPr>
-            <p:cNvPr id="299" name="Shape 13"/>
+            <p:cNvPr id="302" name="Shape 13"/>
             <p:cNvSpPr/>
             <p:nvPr/>
           </p:nvSpPr>
@@ -15174,7 +15303,7 @@
         </p:sp>
         <p:sp>
           <p:nvSpPr>
-            <p:cNvPr id="300" name="Shape 14"/>
+            <p:cNvPr id="303" name="Shape 14"/>
             <p:cNvSpPr/>
             <p:nvPr/>
           </p:nvSpPr>
@@ -15220,7 +15349,7 @@
         </p:sp>
         <p:sp>
           <p:nvSpPr>
-            <p:cNvPr id="301" name="Text 15"/>
+            <p:cNvPr id="304" name="Text 15"/>
             <p:cNvSpPr txBox="1"/>
             <p:nvPr/>
           </p:nvSpPr>
@@ -15285,7 +15414,7 @@
       </p:grpSp>
       <p:grpSp>
         <p:nvGrpSpPr>
-          <p:cNvPr id="302" name="Step 4 arrows"/>
+          <p:cNvPr id="305" name="Step 4 arrows"/>
           <p:cNvGrpSpPr/>
           <p:nvPr/>
         </p:nvGrpSpPr>
@@ -15299,7 +15428,7 @@
         </p:grpSpPr>
         <p:cxnSp>
           <p:nvCxnSpPr>
-            <p:cNvPr id="303" name="Arrow 1"/>
+            <p:cNvPr id="306" name="Arrow 1"/>
             <p:cNvCxnSpPr/>
             <p:nvPr/>
           </p:nvCxnSpPr>
@@ -15335,7 +15464,7 @@
         </p:cxnSp>
         <p:cxnSp>
           <p:nvCxnSpPr>
-            <p:cNvPr id="304" name="Arrow 2"/>
+            <p:cNvPr id="307" name="Arrow 2"/>
             <p:cNvCxnSpPr/>
             <p:nvPr/>
           </p:nvCxnSpPr>
@@ -15372,7 +15501,7 @@
       </p:grpSp>
       <p:grpSp>
         <p:nvGrpSpPr>
-          <p:cNvPr id="305" name="Step 5 highlight"/>
+          <p:cNvPr id="308" name="Step 5 highlight"/>
           <p:cNvGrpSpPr/>
           <p:nvPr/>
         </p:nvGrpSpPr>
@@ -15386,7 +15515,7 @@
         </p:grpSpPr>
         <p:sp>
           <p:nvSpPr>
-            <p:cNvPr id="306" name="Shape 1"/>
+            <p:cNvPr id="309" name="Shape 1"/>
             <p:cNvSpPr/>
             <p:nvPr/>
           </p:nvSpPr>
@@ -15430,7 +15559,7 @@
         </p:sp>
         <p:sp>
           <p:nvSpPr>
-            <p:cNvPr id="307" name="Shape 2"/>
+            <p:cNvPr id="310" name="Shape 2"/>
             <p:cNvSpPr/>
             <p:nvPr/>
           </p:nvSpPr>
@@ -15474,7 +15603,7 @@
         </p:sp>
         <p:sp>
           <p:nvSpPr>
-            <p:cNvPr id="308" name="Shape 3"/>
+            <p:cNvPr id="311" name="Shape 3"/>
             <p:cNvSpPr/>
             <p:nvPr/>
           </p:nvSpPr>
@@ -15518,7 +15647,7 @@
         </p:sp>
         <p:sp>
           <p:nvSpPr>
-            <p:cNvPr id="309" name="Shape 4"/>
+            <p:cNvPr id="312" name="Shape 4"/>
             <p:cNvSpPr/>
             <p:nvPr/>
           </p:nvSpPr>
@@ -15562,7 +15691,7 @@
         </p:sp>
         <p:sp>
           <p:nvSpPr>
-            <p:cNvPr id="310" name="Shape 5"/>
+            <p:cNvPr id="313" name="Shape 5"/>
             <p:cNvSpPr/>
             <p:nvPr/>
           </p:nvSpPr>
@@ -15606,7 +15735,7 @@
         </p:sp>
         <p:sp>
           <p:nvSpPr>
-            <p:cNvPr id="311" name="Shape 6"/>
+            <p:cNvPr id="314" name="Shape 6"/>
             <p:cNvSpPr/>
             <p:nvPr/>
           </p:nvSpPr>
@@ -15650,7 +15779,7 @@
         </p:sp>
         <p:sp>
           <p:nvSpPr>
-            <p:cNvPr id="312" name="Shape 7"/>
+            <p:cNvPr id="315" name="Shape 7"/>
             <p:cNvSpPr/>
             <p:nvPr/>
           </p:nvSpPr>
@@ -15696,7 +15825,7 @@
         </p:sp>
         <p:sp>
           <p:nvSpPr>
-            <p:cNvPr id="313" name="Text 8"/>
+            <p:cNvPr id="316" name="Text 8"/>
             <p:cNvSpPr txBox="1"/>
             <p:nvPr/>
           </p:nvSpPr>
@@ -15761,7 +15890,7 @@
       </p:grpSp>
       <p:grpSp>
         <p:nvGrpSpPr>
-          <p:cNvPr id="314" name="Step 5 arrows"/>
+          <p:cNvPr id="317" name="Step 5 arrows"/>
           <p:cNvGrpSpPr/>
           <p:nvPr/>
         </p:nvGrpSpPr>
@@ -15775,7 +15904,7 @@
         </p:grpSpPr>
         <p:cxnSp>
           <p:nvCxnSpPr>
-            <p:cNvPr id="315" name="Arrow 1"/>
+            <p:cNvPr id="318" name="Arrow 1"/>
             <p:cNvCxnSpPr/>
             <p:nvPr/>
           </p:nvCxnSpPr>
@@ -15811,7 +15940,7 @@
         </p:cxnSp>
         <p:cxnSp>
           <p:nvCxnSpPr>
-            <p:cNvPr id="316" name="Arrow 2"/>
+            <p:cNvPr id="319" name="Arrow 2"/>
             <p:cNvCxnSpPr/>
             <p:nvPr/>
           </p:nvCxnSpPr>
@@ -15847,7 +15976,7 @@
         </p:cxnSp>
         <p:sp>
           <p:nvSpPr>
-            <p:cNvPr id="317" name="Shape 3"/>
+            <p:cNvPr id="320" name="Shape 3"/>
             <p:cNvSpPr/>
             <p:nvPr/>
           </p:nvSpPr>
@@ -15891,7 +16020,7 @@
         </p:sp>
         <p:sp>
           <p:nvSpPr>
-            <p:cNvPr id="318" name="Text 4"/>
+            <p:cNvPr id="321" name="Text 4"/>
             <p:cNvSpPr txBox="1"/>
             <p:nvPr/>
           </p:nvSpPr>
@@ -15927,7 +16056,7 @@
       </p:grpSp>
       <p:grpSp>
         <p:nvGrpSpPr>
-          <p:cNvPr id="319" name="Step 6 highlight"/>
+          <p:cNvPr id="322" name="Step 6 highlight"/>
           <p:cNvGrpSpPr/>
           <p:nvPr/>
         </p:nvGrpSpPr>
@@ -15941,7 +16070,7 @@
         </p:grpSpPr>
         <p:sp>
           <p:nvSpPr>
-            <p:cNvPr id="320" name="Shape 1"/>
+            <p:cNvPr id="323" name="Shape 1"/>
             <p:cNvSpPr/>
             <p:nvPr/>
           </p:nvSpPr>
@@ -15985,7 +16114,7 @@
         </p:sp>
         <p:sp>
           <p:nvSpPr>
-            <p:cNvPr id="321" name="Shape 2"/>
+            <p:cNvPr id="324" name="Shape 2"/>
             <p:cNvSpPr/>
             <p:nvPr/>
           </p:nvSpPr>
@@ -16029,7 +16158,7 @@
         </p:sp>
         <p:sp>
           <p:nvSpPr>
-            <p:cNvPr id="322" name="Shape 3"/>
+            <p:cNvPr id="325" name="Shape 3"/>
             <p:cNvSpPr/>
             <p:nvPr/>
           </p:nvSpPr>
@@ -16073,7 +16202,7 @@
         </p:sp>
         <p:sp>
           <p:nvSpPr>
-            <p:cNvPr id="323" name="Shape 4"/>
+            <p:cNvPr id="326" name="Shape 4"/>
             <p:cNvSpPr/>
             <p:nvPr/>
           </p:nvSpPr>
@@ -16117,7 +16246,7 @@
         </p:sp>
         <p:sp>
           <p:nvSpPr>
-            <p:cNvPr id="324" name="Shape 5"/>
+            <p:cNvPr id="327" name="Shape 5"/>
             <p:cNvSpPr/>
             <p:nvPr/>
           </p:nvSpPr>
@@ -16161,7 +16290,7 @@
         </p:sp>
         <p:sp>
           <p:nvSpPr>
-            <p:cNvPr id="325" name="Shape 6"/>
+            <p:cNvPr id="328" name="Shape 6"/>
             <p:cNvSpPr/>
             <p:nvPr/>
           </p:nvSpPr>
@@ -16205,7 +16334,7 @@
         </p:sp>
         <p:sp>
           <p:nvSpPr>
-            <p:cNvPr id="326" name="Shape 7"/>
+            <p:cNvPr id="329" name="Shape 7"/>
             <p:cNvSpPr/>
             <p:nvPr/>
           </p:nvSpPr>
@@ -16251,7 +16380,7 @@
         </p:sp>
         <p:sp>
           <p:nvSpPr>
-            <p:cNvPr id="327" name="Text 8"/>
+            <p:cNvPr id="330" name="Text 8"/>
             <p:cNvSpPr txBox="1"/>
             <p:nvPr/>
           </p:nvSpPr>
@@ -16316,7 +16445,7 @@
       </p:grpSp>
       <p:grpSp>
         <p:nvGrpSpPr>
-          <p:cNvPr id="328" name="Step 6 arrows"/>
+          <p:cNvPr id="331" name="Step 6 arrows"/>
           <p:cNvGrpSpPr/>
           <p:nvPr/>
         </p:nvGrpSpPr>
@@ -16330,7 +16459,7 @@
         </p:grpSpPr>
         <p:cxnSp>
           <p:nvCxnSpPr>
-            <p:cNvPr id="329" name="Arrow 1"/>
+            <p:cNvPr id="332" name="Arrow 1"/>
             <p:cNvCxnSpPr/>
             <p:nvPr/>
           </p:nvCxnSpPr>
@@ -16365,7 +16494,7 @@
         </p:cxnSp>
         <p:cxnSp>
           <p:nvCxnSpPr>
-            <p:cNvPr id="330" name="Arrow 2"/>
+            <p:cNvPr id="333" name="Arrow 2"/>
             <p:cNvCxnSpPr/>
             <p:nvPr/>
           </p:nvCxnSpPr>
@@ -16400,7 +16529,7 @@
         </p:cxnSp>
         <p:cxnSp>
           <p:nvCxnSpPr>
-            <p:cNvPr id="331" name="Arrow 3"/>
+            <p:cNvPr id="334" name="Arrow 3"/>
             <p:cNvCxnSpPr/>
             <p:nvPr/>
           </p:nvCxnSpPr>
@@ -16436,7 +16565,7 @@
         </p:cxnSp>
         <p:cxnSp>
           <p:nvCxnSpPr>
-            <p:cNvPr id="332" name="Arrow 4"/>
+            <p:cNvPr id="335" name="Arrow 4"/>
             <p:cNvCxnSpPr/>
             <p:nvPr/>
           </p:nvCxnSpPr>
@@ -16472,7 +16601,7 @@
         </p:cxnSp>
         <p:sp>
           <p:nvSpPr>
-            <p:cNvPr id="333" name="Shape 5"/>
+            <p:cNvPr id="336" name="Shape 5"/>
             <p:cNvSpPr/>
             <p:nvPr/>
           </p:nvSpPr>
@@ -16516,7 +16645,7 @@
         </p:sp>
         <p:sp>
           <p:nvSpPr>
-            <p:cNvPr id="334" name="Text 6"/>
+            <p:cNvPr id="337" name="Text 6"/>
             <p:cNvSpPr txBox="1"/>
             <p:nvPr/>
           </p:nvSpPr>
@@ -16551,7 +16680,7 @@
         </p:sp>
         <p:sp>
           <p:nvSpPr>
-            <p:cNvPr id="335" name="Shape 7"/>
+            <p:cNvPr id="338" name="Shape 7"/>
             <p:cNvSpPr/>
             <p:nvPr/>
           </p:nvSpPr>
@@ -16595,7 +16724,7 @@
         </p:sp>
         <p:sp>
           <p:nvSpPr>
-            <p:cNvPr id="336" name="Text 8"/>
+            <p:cNvPr id="339" name="Text 8"/>
             <p:cNvSpPr txBox="1"/>
             <p:nvPr/>
           </p:nvSpPr>
@@ -16631,7 +16760,7 @@
       </p:grpSp>
       <p:grpSp>
         <p:nvGrpSpPr>
-          <p:cNvPr id="337" name="Step 7 highlight"/>
+          <p:cNvPr id="340" name="Step 7 highlight"/>
           <p:cNvGrpSpPr/>
           <p:nvPr/>
         </p:nvGrpSpPr>
@@ -16645,7 +16774,7 @@
         </p:grpSpPr>
         <p:sp>
           <p:nvSpPr>
-            <p:cNvPr id="338" name="Shape 1"/>
+            <p:cNvPr id="341" name="Shape 1"/>
             <p:cNvSpPr/>
             <p:nvPr/>
           </p:nvSpPr>
@@ -16689,7 +16818,7 @@
         </p:sp>
         <p:sp>
           <p:nvSpPr>
-            <p:cNvPr id="339" name="Shape 2"/>
+            <p:cNvPr id="342" name="Shape 2"/>
             <p:cNvSpPr/>
             <p:nvPr/>
           </p:nvSpPr>
@@ -16733,7 +16862,7 @@
         </p:sp>
         <p:sp>
           <p:nvSpPr>
-            <p:cNvPr id="340" name="Shape 3"/>
+            <p:cNvPr id="343" name="Shape 3"/>
             <p:cNvSpPr/>
             <p:nvPr/>
           </p:nvSpPr>
@@ -16777,7 +16906,7 @@
         </p:sp>
         <p:sp>
           <p:nvSpPr>
-            <p:cNvPr id="341" name="Shape 4"/>
+            <p:cNvPr id="344" name="Shape 4"/>
             <p:cNvSpPr/>
             <p:nvPr/>
           </p:nvSpPr>
@@ -16821,7 +16950,7 @@
         </p:sp>
         <p:sp>
           <p:nvSpPr>
-            <p:cNvPr id="342" name="Shape 5"/>
+            <p:cNvPr id="345" name="Shape 5"/>
             <p:cNvSpPr/>
             <p:nvPr/>
           </p:nvSpPr>
@@ -16865,7 +16994,7 @@
         </p:sp>
         <p:sp>
           <p:nvSpPr>
-            <p:cNvPr id="343" name="Shape 6"/>
+            <p:cNvPr id="346" name="Shape 6"/>
             <p:cNvSpPr/>
             <p:nvPr/>
           </p:nvSpPr>
@@ -16909,7 +17038,7 @@
         </p:sp>
         <p:sp>
           <p:nvSpPr>
-            <p:cNvPr id="344" name="Shape 7"/>
+            <p:cNvPr id="347" name="Shape 7"/>
             <p:cNvSpPr/>
             <p:nvPr/>
           </p:nvSpPr>
@@ -16953,7 +17082,7 @@
         </p:sp>
         <p:sp>
           <p:nvSpPr>
-            <p:cNvPr id="345" name="Shape 8"/>
+            <p:cNvPr id="348" name="Shape 8"/>
             <p:cNvSpPr/>
             <p:nvPr/>
           </p:nvSpPr>
@@ -16997,7 +17126,7 @@
         </p:sp>
         <p:sp>
           <p:nvSpPr>
-            <p:cNvPr id="346" name="Shape 9"/>
+            <p:cNvPr id="349" name="Shape 9"/>
             <p:cNvSpPr/>
             <p:nvPr/>
           </p:nvSpPr>
@@ -17041,7 +17170,7 @@
         </p:sp>
         <p:sp>
           <p:nvSpPr>
-            <p:cNvPr id="347" name="Shape 10"/>
+            <p:cNvPr id="350" name="Shape 10"/>
             <p:cNvSpPr/>
             <p:nvPr/>
           </p:nvSpPr>
@@ -17085,7 +17214,7 @@
         </p:sp>
         <p:sp>
           <p:nvSpPr>
-            <p:cNvPr id="348" name="Shape 11"/>
+            <p:cNvPr id="351" name="Shape 11"/>
             <p:cNvSpPr/>
             <p:nvPr/>
           </p:nvSpPr>
@@ -17129,14 +17258,14 @@
         </p:sp>
         <p:sp>
           <p:nvSpPr>
-            <p:cNvPr id="349" name="Shape 12"/>
+            <p:cNvPr id="352" name="Shape 12"/>
             <p:cNvSpPr/>
             <p:nvPr/>
           </p:nvSpPr>
           <p:spPr>
             <a:xfrm>
-              <a:off x="2990087" y="5513832"/>
-              <a:ext cx="8833104" cy="457200"/>
+              <a:off x="2880360" y="5513832"/>
+              <a:ext cx="8942832" cy="457200"/>
             </a:xfrm>
             <a:prstGeom prst="rect">
               <a:avLst/>
@@ -17173,7 +17302,7 @@
         </p:sp>
         <p:sp>
           <p:nvSpPr>
-            <p:cNvPr id="350" name="Shape 13"/>
+            <p:cNvPr id="353" name="Shape 13"/>
             <p:cNvSpPr/>
             <p:nvPr/>
           </p:nvSpPr>
@@ -17217,7 +17346,7 @@
         </p:sp>
         <p:sp>
           <p:nvSpPr>
-            <p:cNvPr id="351" name="Shape 14"/>
+            <p:cNvPr id="354" name="Shape 14"/>
             <p:cNvSpPr/>
             <p:nvPr/>
           </p:nvSpPr>
@@ -17261,7 +17390,7 @@
         </p:sp>
         <p:sp>
           <p:nvSpPr>
-            <p:cNvPr id="352" name="Shape 15"/>
+            <p:cNvPr id="355" name="Shape 15"/>
             <p:cNvSpPr/>
             <p:nvPr/>
           </p:nvSpPr>
@@ -17305,14 +17434,14 @@
         </p:sp>
         <p:sp>
           <p:nvSpPr>
-            <p:cNvPr id="353" name="Shape 16"/>
+            <p:cNvPr id="356" name="Shape 16"/>
             <p:cNvSpPr/>
             <p:nvPr/>
           </p:nvSpPr>
           <p:spPr>
             <a:xfrm>
               <a:off x="1417320" y="5550408"/>
-              <a:ext cx="1545336" cy="420624"/>
+              <a:ext cx="1435608" cy="420624"/>
             </a:xfrm>
             <a:prstGeom prst="roundRect">
               <a:avLst>
@@ -17349,7 +17478,7 @@
         </p:sp>
         <p:sp>
           <p:nvSpPr>
-            <p:cNvPr id="354" name="Shape 17"/>
+            <p:cNvPr id="357" name="Shape 17"/>
             <p:cNvSpPr/>
             <p:nvPr/>
           </p:nvSpPr>
@@ -17393,7 +17522,7 @@
         </p:sp>
         <p:sp>
           <p:nvSpPr>
-            <p:cNvPr id="355" name="Shape 18"/>
+            <p:cNvPr id="358" name="Shape 18"/>
             <p:cNvSpPr/>
             <p:nvPr/>
           </p:nvSpPr>
@@ -17439,7 +17568,7 @@
         </p:sp>
         <p:sp>
           <p:nvSpPr>
-            <p:cNvPr id="356" name="Text 19"/>
+            <p:cNvPr id="359" name="Text 19"/>
             <p:cNvSpPr txBox="1"/>
             <p:nvPr/>
           </p:nvSpPr>
@@ -17504,21 +17633,21 @@
       </p:grpSp>
       <p:grpSp>
         <p:nvGrpSpPr>
-          <p:cNvPr id="357" name="Step 7 arrows"/>
+          <p:cNvPr id="360" name="Step 7 arrows"/>
           <p:cNvGrpSpPr/>
           <p:nvPr/>
         </p:nvGrpSpPr>
         <p:grpSpPr>
           <a:xfrm>
-            <a:off x="1856232" y="4453128"/>
-            <a:ext cx="1764792" cy="1700784"/>
-            <a:chOff x="1856232" y="4453128"/>
-            <a:chExt cx="1764792" cy="1700784"/>
+            <a:off x="1773936" y="4453128"/>
+            <a:ext cx="1847088" cy="1700784"/>
+            <a:chOff x="1773936" y="4453128"/>
+            <a:chExt cx="1847088" cy="1700784"/>
           </a:xfrm>
         </p:grpSpPr>
         <p:cxnSp>
           <p:nvCxnSpPr>
-            <p:cNvPr id="358" name="Arrow 1"/>
+            <p:cNvPr id="361" name="Arrow 1"/>
             <p:cNvCxnSpPr/>
             <p:nvPr/>
           </p:nvCxnSpPr>
@@ -17553,14 +17682,14 @@
         </p:cxnSp>
         <p:cxnSp>
           <p:nvCxnSpPr>
-            <p:cNvPr id="359" name="Arrow 2"/>
+            <p:cNvPr id="362" name="Arrow 2"/>
             <p:cNvCxnSpPr/>
             <p:nvPr/>
           </p:nvCxnSpPr>
           <p:spPr>
             <a:xfrm flipH="1">
-              <a:off x="2587752" y="5449824"/>
-              <a:ext cx="1033272" cy="0"/>
+              <a:off x="2505456" y="5449824"/>
+              <a:ext cx="1115568" cy="0"/>
             </a:xfrm>
             <a:prstGeom prst="line">
               <a:avLst/>
@@ -17588,13 +17717,13 @@
         </p:cxnSp>
         <p:cxnSp>
           <p:nvCxnSpPr>
-            <p:cNvPr id="360" name="Arrow 3"/>
+            <p:cNvPr id="363" name="Arrow 3"/>
             <p:cNvCxnSpPr/>
             <p:nvPr/>
           </p:nvCxnSpPr>
           <p:spPr>
             <a:xfrm>
-              <a:off x="2587752" y="5449824"/>
+              <a:off x="2505456" y="5449824"/>
               <a:ext cx="0" cy="100584"/>
             </a:xfrm>
             <a:prstGeom prst="line">
@@ -17624,13 +17753,13 @@
         </p:cxnSp>
         <p:sp>
           <p:nvSpPr>
-            <p:cNvPr id="361" name="Shape 4"/>
+            <p:cNvPr id="364" name="Shape 4"/>
             <p:cNvSpPr/>
             <p:nvPr/>
           </p:nvSpPr>
           <p:spPr>
             <a:xfrm>
-              <a:off x="1856232" y="5971032"/>
+              <a:off x="1773936" y="5971032"/>
               <a:ext cx="1463040" cy="182880"/>
             </a:xfrm>
             <a:prstGeom prst="roundRect">
@@ -17668,13 +17797,13 @@
         </p:sp>
         <p:sp>
           <p:nvSpPr>
-            <p:cNvPr id="362" name="Text 5"/>
+            <p:cNvPr id="365" name="Text 5"/>
             <p:cNvSpPr txBox="1"/>
             <p:nvPr/>
           </p:nvSpPr>
           <p:spPr>
             <a:xfrm>
-              <a:off x="1856232" y="5971032"/>
+              <a:off x="1773936" y="5971032"/>
               <a:ext cx="1463040" cy="182880"/>
             </a:xfrm>
             <a:prstGeom prst="rect">
@@ -17704,7 +17833,7 @@
       </p:grpSp>
       <p:grpSp>
         <p:nvGrpSpPr>
-          <p:cNvPr id="363" name="Step 8 highlight"/>
+          <p:cNvPr id="366" name="Step 8 highlight"/>
           <p:cNvGrpSpPr/>
           <p:nvPr/>
         </p:nvGrpSpPr>
@@ -17718,7 +17847,7 @@
         </p:grpSpPr>
         <p:sp>
           <p:nvSpPr>
-            <p:cNvPr id="364" name="Shape 1"/>
+            <p:cNvPr id="367" name="Shape 1"/>
             <p:cNvSpPr/>
             <p:nvPr/>
           </p:nvSpPr>
@@ -17762,7 +17891,7 @@
         </p:sp>
         <p:sp>
           <p:nvSpPr>
-            <p:cNvPr id="365" name="Shape 2"/>
+            <p:cNvPr id="368" name="Shape 2"/>
             <p:cNvSpPr/>
             <p:nvPr/>
           </p:nvSpPr>
@@ -17806,7 +17935,7 @@
         </p:sp>
         <p:sp>
           <p:nvSpPr>
-            <p:cNvPr id="366" name="Shape 3"/>
+            <p:cNvPr id="369" name="Shape 3"/>
             <p:cNvSpPr/>
             <p:nvPr/>
           </p:nvSpPr>
@@ -17850,7 +17979,7 @@
         </p:sp>
         <p:sp>
           <p:nvSpPr>
-            <p:cNvPr id="367" name="Shape 4"/>
+            <p:cNvPr id="370" name="Shape 4"/>
             <p:cNvSpPr/>
             <p:nvPr/>
           </p:nvSpPr>
@@ -17894,7 +18023,7 @@
         </p:sp>
         <p:sp>
           <p:nvSpPr>
-            <p:cNvPr id="368" name="Shape 5"/>
+            <p:cNvPr id="371" name="Shape 5"/>
             <p:cNvSpPr/>
             <p:nvPr/>
           </p:nvSpPr>
@@ -17938,7 +18067,7 @@
         </p:sp>
         <p:sp>
           <p:nvSpPr>
-            <p:cNvPr id="369" name="Shape 6"/>
+            <p:cNvPr id="372" name="Shape 6"/>
             <p:cNvSpPr/>
             <p:nvPr/>
           </p:nvSpPr>
@@ -17982,7 +18111,7 @@
         </p:sp>
         <p:sp>
           <p:nvSpPr>
-            <p:cNvPr id="370" name="Shape 7"/>
+            <p:cNvPr id="373" name="Shape 7"/>
             <p:cNvSpPr/>
             <p:nvPr/>
           </p:nvSpPr>
@@ -18026,7 +18155,7 @@
         </p:sp>
         <p:sp>
           <p:nvSpPr>
-            <p:cNvPr id="371" name="Shape 8"/>
+            <p:cNvPr id="374" name="Shape 8"/>
             <p:cNvSpPr/>
             <p:nvPr/>
           </p:nvSpPr>
@@ -18070,7 +18199,7 @@
         </p:sp>
         <p:sp>
           <p:nvSpPr>
-            <p:cNvPr id="372" name="Shape 9"/>
+            <p:cNvPr id="375" name="Shape 9"/>
             <p:cNvSpPr/>
             <p:nvPr/>
           </p:nvSpPr>
@@ -18114,7 +18243,7 @@
         </p:sp>
         <p:sp>
           <p:nvSpPr>
-            <p:cNvPr id="373" name="Shape 10"/>
+            <p:cNvPr id="376" name="Shape 10"/>
             <p:cNvSpPr/>
             <p:nvPr/>
           </p:nvSpPr>
@@ -18158,7 +18287,7 @@
         </p:sp>
         <p:sp>
           <p:nvSpPr>
-            <p:cNvPr id="374" name="Shape 11"/>
+            <p:cNvPr id="377" name="Shape 11"/>
             <p:cNvSpPr/>
             <p:nvPr/>
           </p:nvSpPr>
@@ -18202,7 +18331,7 @@
         </p:sp>
         <p:sp>
           <p:nvSpPr>
-            <p:cNvPr id="375" name="Shape 12"/>
+            <p:cNvPr id="378" name="Shape 12"/>
             <p:cNvSpPr/>
             <p:nvPr/>
           </p:nvSpPr>
@@ -18246,7 +18375,7 @@
         </p:sp>
         <p:sp>
           <p:nvSpPr>
-            <p:cNvPr id="376" name="Shape 13"/>
+            <p:cNvPr id="379" name="Shape 13"/>
             <p:cNvSpPr/>
             <p:nvPr/>
           </p:nvSpPr>
@@ -18290,7 +18419,7 @@
         </p:sp>
         <p:sp>
           <p:nvSpPr>
-            <p:cNvPr id="377" name="Shape 14"/>
+            <p:cNvPr id="380" name="Shape 14"/>
             <p:cNvSpPr/>
             <p:nvPr/>
           </p:nvSpPr>
@@ -18334,7 +18463,7 @@
         </p:sp>
         <p:sp>
           <p:nvSpPr>
-            <p:cNvPr id="378" name="Shape 15"/>
+            <p:cNvPr id="381" name="Shape 15"/>
             <p:cNvSpPr/>
             <p:nvPr/>
           </p:nvSpPr>
@@ -18378,14 +18507,14 @@
         </p:sp>
         <p:sp>
           <p:nvSpPr>
-            <p:cNvPr id="379" name="Shape 16"/>
+            <p:cNvPr id="382" name="Shape 16"/>
             <p:cNvSpPr/>
             <p:nvPr/>
           </p:nvSpPr>
           <p:spPr>
             <a:xfrm>
               <a:off x="365760" y="5513832"/>
-              <a:ext cx="2615184" cy="457200"/>
+              <a:ext cx="2505456" cy="457200"/>
             </a:xfrm>
             <a:prstGeom prst="rect">
               <a:avLst/>
@@ -18422,14 +18551,14 @@
         </p:sp>
         <p:sp>
           <p:nvSpPr>
-            <p:cNvPr id="380" name="Shape 17"/>
+            <p:cNvPr id="383" name="Shape 17"/>
             <p:cNvSpPr/>
             <p:nvPr/>
           </p:nvSpPr>
           <p:spPr>
             <a:xfrm>
-              <a:off x="4581144" y="5513832"/>
-              <a:ext cx="7242047" cy="457200"/>
+              <a:off x="4361688" y="5513832"/>
+              <a:ext cx="7461504" cy="457200"/>
             </a:xfrm>
             <a:prstGeom prst="rect">
               <a:avLst/>
@@ -18466,7 +18595,7 @@
         </p:sp>
         <p:sp>
           <p:nvSpPr>
-            <p:cNvPr id="381" name="Shape 18"/>
+            <p:cNvPr id="384" name="Shape 18"/>
             <p:cNvSpPr/>
             <p:nvPr/>
           </p:nvSpPr>
@@ -18510,7 +18639,7 @@
         </p:sp>
         <p:sp>
           <p:nvSpPr>
-            <p:cNvPr id="382" name="Shape 19"/>
+            <p:cNvPr id="385" name="Shape 19"/>
             <p:cNvSpPr/>
             <p:nvPr/>
           </p:nvSpPr>
@@ -18554,7 +18683,7 @@
         </p:sp>
         <p:sp>
           <p:nvSpPr>
-            <p:cNvPr id="383" name="Shape 20"/>
+            <p:cNvPr id="386" name="Shape 20"/>
             <p:cNvSpPr/>
             <p:nvPr/>
           </p:nvSpPr>
@@ -18598,14 +18727,14 @@
         </p:sp>
         <p:sp>
           <p:nvSpPr>
-            <p:cNvPr id="384" name="Shape 21"/>
+            <p:cNvPr id="387" name="Shape 21"/>
             <p:cNvSpPr/>
             <p:nvPr/>
           </p:nvSpPr>
           <p:spPr>
             <a:xfrm>
-              <a:off x="3008376" y="5550408"/>
-              <a:ext cx="1545336" cy="420624"/>
+              <a:off x="2898648" y="5550408"/>
+              <a:ext cx="1435608" cy="420624"/>
             </a:xfrm>
             <a:prstGeom prst="roundRect">
               <a:avLst>
@@ -18642,7 +18771,7 @@
         </p:sp>
         <p:sp>
           <p:nvSpPr>
-            <p:cNvPr id="385" name="Shape 22"/>
+            <p:cNvPr id="388" name="Shape 22"/>
             <p:cNvSpPr/>
             <p:nvPr/>
           </p:nvSpPr>
@@ -18686,7 +18815,7 @@
         </p:sp>
         <p:sp>
           <p:nvSpPr>
-            <p:cNvPr id="386" name="Shape 23"/>
+            <p:cNvPr id="389" name="Shape 23"/>
             <p:cNvSpPr/>
             <p:nvPr/>
           </p:nvSpPr>
@@ -18730,7 +18859,7 @@
         </p:sp>
         <p:sp>
           <p:nvSpPr>
-            <p:cNvPr id="387" name="Shape 24"/>
+            <p:cNvPr id="390" name="Shape 24"/>
             <p:cNvSpPr/>
             <p:nvPr/>
           </p:nvSpPr>
@@ -18776,7 +18905,7 @@
         </p:sp>
         <p:sp>
           <p:nvSpPr>
-            <p:cNvPr id="388" name="Text 25"/>
+            <p:cNvPr id="391" name="Text 25"/>
             <p:cNvSpPr txBox="1"/>
             <p:nvPr/>
           </p:nvSpPr>
@@ -18841,21 +18970,21 @@
       </p:grpSp>
       <p:grpSp>
         <p:nvGrpSpPr>
-          <p:cNvPr id="389" name="Step 8 arrows"/>
+          <p:cNvPr id="392" name="Step 8 arrows"/>
           <p:cNvGrpSpPr/>
           <p:nvPr/>
         </p:nvGrpSpPr>
         <p:grpSpPr>
           <a:xfrm>
-            <a:off x="3447288" y="4453128"/>
+            <a:off x="3255264" y="4453128"/>
             <a:ext cx="1463040" cy="1700784"/>
-            <a:chOff x="3447288" y="4453128"/>
+            <a:chOff x="3255264" y="4453128"/>
             <a:chExt cx="1463040" cy="1700784"/>
           </a:xfrm>
         </p:grpSpPr>
         <p:cxnSp>
           <p:nvCxnSpPr>
-            <p:cNvPr id="390" name="Arrow 1"/>
+            <p:cNvPr id="393" name="Arrow 1"/>
             <p:cNvCxnSpPr/>
             <p:nvPr/>
           </p:nvCxnSpPr>
@@ -18890,14 +19019,14 @@
         </p:cxnSp>
         <p:cxnSp>
           <p:nvCxnSpPr>
-            <p:cNvPr id="391" name="Arrow 2"/>
+            <p:cNvPr id="394" name="Arrow 2"/>
             <p:cNvCxnSpPr/>
             <p:nvPr/>
           </p:nvCxnSpPr>
           <p:spPr>
             <a:xfrm>
               <a:off x="3621024" y="5449824"/>
-              <a:ext cx="557784" cy="0"/>
+              <a:ext cx="365760" cy="0"/>
             </a:xfrm>
             <a:prstGeom prst="line">
               <a:avLst/>
@@ -18925,13 +19054,13 @@
         </p:cxnSp>
         <p:cxnSp>
           <p:nvCxnSpPr>
-            <p:cNvPr id="392" name="Arrow 3"/>
+            <p:cNvPr id="395" name="Arrow 3"/>
             <p:cNvCxnSpPr/>
             <p:nvPr/>
           </p:nvCxnSpPr>
           <p:spPr>
             <a:xfrm>
-              <a:off x="4178808" y="5449824"/>
+              <a:off x="3986784" y="5449824"/>
               <a:ext cx="0" cy="100584"/>
             </a:xfrm>
             <a:prstGeom prst="line">
@@ -18961,13 +19090,13 @@
         </p:cxnSp>
         <p:sp>
           <p:nvSpPr>
-            <p:cNvPr id="393" name="Shape 4"/>
+            <p:cNvPr id="396" name="Shape 4"/>
             <p:cNvSpPr/>
             <p:nvPr/>
           </p:nvSpPr>
           <p:spPr>
             <a:xfrm>
-              <a:off x="3447288" y="5971032"/>
+              <a:off x="3255264" y="5971032"/>
               <a:ext cx="1463040" cy="182880"/>
             </a:xfrm>
             <a:prstGeom prst="roundRect">
@@ -19005,13 +19134,13 @@
         </p:sp>
         <p:sp>
           <p:nvSpPr>
-            <p:cNvPr id="394" name="Text 5"/>
+            <p:cNvPr id="397" name="Text 5"/>
             <p:cNvSpPr txBox="1"/>
             <p:nvPr/>
           </p:nvSpPr>
           <p:spPr>
             <a:xfrm>
-              <a:off x="3447288" y="5971032"/>
+              <a:off x="3255264" y="5971032"/>
               <a:ext cx="1463040" cy="182880"/>
             </a:xfrm>
             <a:prstGeom prst="rect">
@@ -19041,7 +19170,7 @@
       </p:grpSp>
       <p:grpSp>
         <p:nvGrpSpPr>
-          <p:cNvPr id="395" name="Step 9 highlight"/>
+          <p:cNvPr id="398" name="Step 9 highlight"/>
           <p:cNvGrpSpPr/>
           <p:nvPr/>
         </p:nvGrpSpPr>
@@ -19055,7 +19184,7 @@
         </p:grpSpPr>
         <p:sp>
           <p:nvSpPr>
-            <p:cNvPr id="396" name="Shape 1"/>
+            <p:cNvPr id="399" name="Shape 1"/>
             <p:cNvSpPr/>
             <p:nvPr/>
           </p:nvSpPr>
@@ -19099,7 +19228,7 @@
         </p:sp>
         <p:sp>
           <p:nvSpPr>
-            <p:cNvPr id="397" name="Shape 2"/>
+            <p:cNvPr id="400" name="Shape 2"/>
             <p:cNvSpPr/>
             <p:nvPr/>
           </p:nvSpPr>
@@ -19143,7 +19272,7 @@
         </p:sp>
         <p:sp>
           <p:nvSpPr>
-            <p:cNvPr id="398" name="Shape 3"/>
+            <p:cNvPr id="401" name="Shape 3"/>
             <p:cNvSpPr/>
             <p:nvPr/>
           </p:nvSpPr>
@@ -19187,7 +19316,7 @@
         </p:sp>
         <p:sp>
           <p:nvSpPr>
-            <p:cNvPr id="399" name="Shape 4"/>
+            <p:cNvPr id="402" name="Shape 4"/>
             <p:cNvSpPr/>
             <p:nvPr/>
           </p:nvSpPr>
@@ -19231,7 +19360,7 @@
         </p:sp>
         <p:sp>
           <p:nvSpPr>
-            <p:cNvPr id="400" name="Shape 5"/>
+            <p:cNvPr id="403" name="Shape 5"/>
             <p:cNvSpPr/>
             <p:nvPr/>
           </p:nvSpPr>
@@ -19275,7 +19404,7 @@
         </p:sp>
         <p:sp>
           <p:nvSpPr>
-            <p:cNvPr id="401" name="Shape 6"/>
+            <p:cNvPr id="404" name="Shape 6"/>
             <p:cNvSpPr/>
             <p:nvPr/>
           </p:nvSpPr>
@@ -19319,7 +19448,7 @@
         </p:sp>
         <p:sp>
           <p:nvSpPr>
-            <p:cNvPr id="402" name="Shape 7"/>
+            <p:cNvPr id="405" name="Shape 7"/>
             <p:cNvSpPr/>
             <p:nvPr/>
           </p:nvSpPr>
@@ -19363,7 +19492,7 @@
         </p:sp>
         <p:sp>
           <p:nvSpPr>
-            <p:cNvPr id="403" name="Shape 8"/>
+            <p:cNvPr id="406" name="Shape 8"/>
             <p:cNvSpPr/>
             <p:nvPr/>
           </p:nvSpPr>
@@ -19407,7 +19536,7 @@
         </p:sp>
         <p:sp>
           <p:nvSpPr>
-            <p:cNvPr id="404" name="Shape 9"/>
+            <p:cNvPr id="407" name="Shape 9"/>
             <p:cNvSpPr/>
             <p:nvPr/>
           </p:nvSpPr>
@@ -19451,7 +19580,7 @@
         </p:sp>
         <p:sp>
           <p:nvSpPr>
-            <p:cNvPr id="405" name="Shape 10"/>
+            <p:cNvPr id="408" name="Shape 10"/>
             <p:cNvSpPr/>
             <p:nvPr/>
           </p:nvSpPr>
@@ -19495,7 +19624,7 @@
         </p:sp>
         <p:sp>
           <p:nvSpPr>
-            <p:cNvPr id="406" name="Shape 11"/>
+            <p:cNvPr id="409" name="Shape 11"/>
             <p:cNvSpPr/>
             <p:nvPr/>
           </p:nvSpPr>
@@ -19539,7 +19668,7 @@
         </p:sp>
         <p:sp>
           <p:nvSpPr>
-            <p:cNvPr id="407" name="Shape 12"/>
+            <p:cNvPr id="410" name="Shape 12"/>
             <p:cNvSpPr/>
             <p:nvPr/>
           </p:nvSpPr>
@@ -19583,7 +19712,7 @@
         </p:sp>
         <p:sp>
           <p:nvSpPr>
-            <p:cNvPr id="408" name="Shape 13"/>
+            <p:cNvPr id="411" name="Shape 13"/>
             <p:cNvSpPr/>
             <p:nvPr/>
           </p:nvSpPr>
@@ -19627,7 +19756,7 @@
         </p:sp>
         <p:sp>
           <p:nvSpPr>
-            <p:cNvPr id="409" name="Shape 14"/>
+            <p:cNvPr id="412" name="Shape 14"/>
             <p:cNvSpPr/>
             <p:nvPr/>
           </p:nvSpPr>
@@ -19671,7 +19800,7 @@
         </p:sp>
         <p:sp>
           <p:nvSpPr>
-            <p:cNvPr id="410" name="Shape 15"/>
+            <p:cNvPr id="413" name="Shape 15"/>
             <p:cNvSpPr/>
             <p:nvPr/>
           </p:nvSpPr>
@@ -19715,7 +19844,7 @@
         </p:sp>
         <p:sp>
           <p:nvSpPr>
-            <p:cNvPr id="411" name="Shape 16"/>
+            <p:cNvPr id="414" name="Shape 16"/>
             <p:cNvSpPr/>
             <p:nvPr/>
           </p:nvSpPr>
@@ -19759,7 +19888,7 @@
         </p:sp>
         <p:sp>
           <p:nvSpPr>
-            <p:cNvPr id="412" name="Shape 17"/>
+            <p:cNvPr id="415" name="Shape 17"/>
             <p:cNvSpPr/>
             <p:nvPr/>
           </p:nvSpPr>
@@ -19803,7 +19932,7 @@
         </p:sp>
         <p:sp>
           <p:nvSpPr>
-            <p:cNvPr id="413" name="Shape 18"/>
+            <p:cNvPr id="416" name="Shape 18"/>
             <p:cNvSpPr/>
             <p:nvPr/>
           </p:nvSpPr>
@@ -19847,7 +19976,7 @@
         </p:sp>
         <p:sp>
           <p:nvSpPr>
-            <p:cNvPr id="414" name="Shape 19"/>
+            <p:cNvPr id="417" name="Shape 19"/>
             <p:cNvSpPr/>
             <p:nvPr/>
           </p:nvSpPr>
@@ -19891,7 +20020,7 @@
         </p:sp>
         <p:sp>
           <p:nvSpPr>
-            <p:cNvPr id="415" name="Shape 20"/>
+            <p:cNvPr id="418" name="Shape 20"/>
             <p:cNvSpPr/>
             <p:nvPr/>
           </p:nvSpPr>
@@ -19935,7 +20064,7 @@
         </p:sp>
         <p:sp>
           <p:nvSpPr>
-            <p:cNvPr id="416" name="Shape 21"/>
+            <p:cNvPr id="419" name="Shape 21"/>
             <p:cNvSpPr/>
             <p:nvPr/>
           </p:nvSpPr>
@@ -19979,14 +20108,14 @@
         </p:sp>
         <p:sp>
           <p:nvSpPr>
-            <p:cNvPr id="417" name="Shape 22"/>
+            <p:cNvPr id="420" name="Shape 22"/>
             <p:cNvSpPr/>
             <p:nvPr/>
           </p:nvSpPr>
           <p:spPr>
             <a:xfrm>
               <a:off x="365760" y="5513832"/>
-              <a:ext cx="4206240" cy="457200"/>
+              <a:ext cx="3986783" cy="457200"/>
             </a:xfrm>
             <a:prstGeom prst="rect">
               <a:avLst/>
@@ -20023,14 +20152,14 @@
         </p:sp>
         <p:sp>
           <p:nvSpPr>
-            <p:cNvPr id="418" name="Shape 23"/>
+            <p:cNvPr id="421" name="Shape 23"/>
             <p:cNvSpPr/>
             <p:nvPr/>
           </p:nvSpPr>
           <p:spPr>
             <a:xfrm>
-              <a:off x="6967727" y="5513832"/>
-              <a:ext cx="4855464" cy="457200"/>
+              <a:off x="6583679" y="5513832"/>
+              <a:ext cx="5239512" cy="457200"/>
             </a:xfrm>
             <a:prstGeom prst="rect">
               <a:avLst/>
@@ -20067,7 +20196,7 @@
         </p:sp>
         <p:sp>
           <p:nvSpPr>
-            <p:cNvPr id="419" name="Shape 24"/>
+            <p:cNvPr id="422" name="Shape 24"/>
             <p:cNvSpPr/>
             <p:nvPr/>
           </p:nvSpPr>
@@ -20111,7 +20240,7 @@
         </p:sp>
         <p:sp>
           <p:nvSpPr>
-            <p:cNvPr id="420" name="Shape 25"/>
+            <p:cNvPr id="423" name="Shape 25"/>
             <p:cNvSpPr/>
             <p:nvPr/>
           </p:nvSpPr>
@@ -20155,7 +20284,7 @@
         </p:sp>
         <p:sp>
           <p:nvSpPr>
-            <p:cNvPr id="421" name="Shape 26"/>
+            <p:cNvPr id="424" name="Shape 26"/>
             <p:cNvSpPr/>
             <p:nvPr/>
           </p:nvSpPr>
@@ -20199,7 +20328,7 @@
         </p:sp>
         <p:sp>
           <p:nvSpPr>
-            <p:cNvPr id="422" name="Shape 27"/>
+            <p:cNvPr id="425" name="Shape 27"/>
             <p:cNvSpPr/>
             <p:nvPr/>
           </p:nvSpPr>
@@ -20243,7 +20372,7 @@
         </p:sp>
         <p:sp>
           <p:nvSpPr>
-            <p:cNvPr id="423" name="Shape 28"/>
+            <p:cNvPr id="426" name="Shape 28"/>
             <p:cNvSpPr/>
             <p:nvPr/>
           </p:nvSpPr>
@@ -20287,14 +20416,14 @@
         </p:sp>
         <p:sp>
           <p:nvSpPr>
-            <p:cNvPr id="424" name="Shape 29"/>
+            <p:cNvPr id="427" name="Shape 29"/>
             <p:cNvSpPr/>
             <p:nvPr/>
           </p:nvSpPr>
           <p:spPr>
             <a:xfrm>
-              <a:off x="4599432" y="5550408"/>
-              <a:ext cx="2340863" cy="420624"/>
+              <a:off x="4379976" y="5550408"/>
+              <a:ext cx="2176272" cy="420624"/>
             </a:xfrm>
             <a:prstGeom prst="roundRect">
               <a:avLst>
@@ -20331,7 +20460,7 @@
         </p:sp>
         <p:sp>
           <p:nvSpPr>
-            <p:cNvPr id="425" name="Shape 30"/>
+            <p:cNvPr id="428" name="Shape 30"/>
             <p:cNvSpPr/>
             <p:nvPr/>
           </p:nvSpPr>
@@ -20375,7 +20504,7 @@
         </p:sp>
         <p:sp>
           <p:nvSpPr>
-            <p:cNvPr id="426" name="Shape 31"/>
+            <p:cNvPr id="429" name="Shape 31"/>
             <p:cNvSpPr/>
             <p:nvPr/>
           </p:nvSpPr>
@@ -20419,7 +20548,7 @@
         </p:sp>
         <p:sp>
           <p:nvSpPr>
-            <p:cNvPr id="427" name="Shape 32"/>
+            <p:cNvPr id="430" name="Shape 32"/>
             <p:cNvSpPr/>
             <p:nvPr/>
           </p:nvSpPr>
@@ -20465,7 +20594,7 @@
         </p:sp>
         <p:sp>
           <p:nvSpPr>
-            <p:cNvPr id="428" name="Text 33"/>
+            <p:cNvPr id="431" name="Text 33"/>
             <p:cNvSpPr txBox="1"/>
             <p:nvPr/>
           </p:nvSpPr>
@@ -20530,21 +20659,21 @@
       </p:grpSp>
       <p:grpSp>
         <p:nvGrpSpPr>
-          <p:cNvPr id="429" name="Step 9 arrows"/>
+          <p:cNvPr id="432" name="Step 9 arrows"/>
           <p:cNvGrpSpPr/>
           <p:nvPr/>
         </p:nvGrpSpPr>
         <p:grpSpPr>
           <a:xfrm>
             <a:off x="3621024" y="4453128"/>
-            <a:ext cx="3675888" cy="1700784"/>
+            <a:ext cx="3319272" cy="1700784"/>
             <a:chOff x="3621024" y="4453128"/>
-            <a:chExt cx="3675888" cy="1700784"/>
+            <a:chExt cx="3319272" cy="1700784"/>
           </a:xfrm>
         </p:grpSpPr>
         <p:cxnSp>
           <p:nvCxnSpPr>
-            <p:cNvPr id="430" name="Arrow 1"/>
+            <p:cNvPr id="433" name="Arrow 1"/>
             <p:cNvCxnSpPr/>
             <p:nvPr/>
           </p:nvCxnSpPr>
@@ -20579,14 +20708,14 @@
         </p:cxnSp>
         <p:cxnSp>
           <p:nvCxnSpPr>
-            <p:cNvPr id="431" name="Arrow 2"/>
+            <p:cNvPr id="434" name="Arrow 2"/>
             <p:cNvCxnSpPr/>
             <p:nvPr/>
           </p:nvCxnSpPr>
           <p:spPr>
             <a:xfrm>
               <a:off x="3621024" y="5449824"/>
-              <a:ext cx="2944368" cy="0"/>
+              <a:ext cx="2587752" cy="0"/>
             </a:xfrm>
             <a:prstGeom prst="line">
               <a:avLst/>
@@ -20614,13 +20743,13 @@
         </p:cxnSp>
         <p:cxnSp>
           <p:nvCxnSpPr>
-            <p:cNvPr id="432" name="Arrow 3"/>
+            <p:cNvPr id="435" name="Arrow 3"/>
             <p:cNvCxnSpPr/>
             <p:nvPr/>
           </p:nvCxnSpPr>
           <p:spPr>
             <a:xfrm>
-              <a:off x="6565392" y="5449824"/>
+              <a:off x="6208776" y="5449824"/>
               <a:ext cx="0" cy="100584"/>
             </a:xfrm>
             <a:prstGeom prst="line">
@@ -20650,13 +20779,13 @@
         </p:cxnSp>
         <p:sp>
           <p:nvSpPr>
-            <p:cNvPr id="433" name="Shape 4"/>
+            <p:cNvPr id="436" name="Shape 4"/>
             <p:cNvSpPr/>
             <p:nvPr/>
           </p:nvSpPr>
           <p:spPr>
             <a:xfrm>
-              <a:off x="5833872" y="5971032"/>
+              <a:off x="5477256" y="5971032"/>
               <a:ext cx="1463040" cy="182880"/>
             </a:xfrm>
             <a:prstGeom prst="roundRect">
@@ -20694,13 +20823,13 @@
         </p:sp>
         <p:sp>
           <p:nvSpPr>
-            <p:cNvPr id="434" name="Text 5"/>
+            <p:cNvPr id="437" name="Text 5"/>
             <p:cNvSpPr txBox="1"/>
             <p:nvPr/>
           </p:nvSpPr>
           <p:spPr>
             <a:xfrm>
-              <a:off x="5833872" y="5971032"/>
+              <a:off x="5477256" y="5971032"/>
               <a:ext cx="1463040" cy="182880"/>
             </a:xfrm>
             <a:prstGeom prst="rect">
@@ -20730,7 +20859,7 @@
       </p:grpSp>
       <p:grpSp>
         <p:nvGrpSpPr>
-          <p:cNvPr id="435" name="Step 10 highlight"/>
+          <p:cNvPr id="438" name="Step 10 highlight"/>
           <p:cNvGrpSpPr/>
           <p:nvPr/>
         </p:nvGrpSpPr>
@@ -20744,7 +20873,7 @@
         </p:grpSpPr>
         <p:sp>
           <p:nvSpPr>
-            <p:cNvPr id="436" name="Shape 1"/>
+            <p:cNvPr id="439" name="Shape 1"/>
             <p:cNvSpPr/>
             <p:nvPr/>
           </p:nvSpPr>
@@ -20788,7 +20917,7 @@
         </p:sp>
         <p:sp>
           <p:nvSpPr>
-            <p:cNvPr id="437" name="Shape 2"/>
+            <p:cNvPr id="440" name="Shape 2"/>
             <p:cNvSpPr/>
             <p:nvPr/>
           </p:nvSpPr>
@@ -20832,7 +20961,7 @@
         </p:sp>
         <p:sp>
           <p:nvSpPr>
-            <p:cNvPr id="438" name="Shape 3"/>
+            <p:cNvPr id="441" name="Shape 3"/>
             <p:cNvSpPr/>
             <p:nvPr/>
           </p:nvSpPr>
@@ -20876,7 +21005,7 @@
         </p:sp>
         <p:sp>
           <p:nvSpPr>
-            <p:cNvPr id="439" name="Shape 4"/>
+            <p:cNvPr id="442" name="Shape 4"/>
             <p:cNvSpPr/>
             <p:nvPr/>
           </p:nvSpPr>
@@ -20920,7 +21049,7 @@
         </p:sp>
         <p:sp>
           <p:nvSpPr>
-            <p:cNvPr id="440" name="Shape 5"/>
+            <p:cNvPr id="443" name="Shape 5"/>
             <p:cNvSpPr/>
             <p:nvPr/>
           </p:nvSpPr>
@@ -20964,7 +21093,7 @@
         </p:sp>
         <p:sp>
           <p:nvSpPr>
-            <p:cNvPr id="441" name="Shape 6"/>
+            <p:cNvPr id="444" name="Shape 6"/>
             <p:cNvSpPr/>
             <p:nvPr/>
           </p:nvSpPr>
@@ -21008,7 +21137,7 @@
         </p:sp>
         <p:sp>
           <p:nvSpPr>
-            <p:cNvPr id="442" name="Shape 7"/>
+            <p:cNvPr id="445" name="Shape 7"/>
             <p:cNvSpPr/>
             <p:nvPr/>
           </p:nvSpPr>
@@ -21052,7 +21181,7 @@
         </p:sp>
         <p:sp>
           <p:nvSpPr>
-            <p:cNvPr id="443" name="Shape 8"/>
+            <p:cNvPr id="446" name="Shape 8"/>
             <p:cNvSpPr/>
             <p:nvPr/>
           </p:nvSpPr>
@@ -21096,7 +21225,7 @@
         </p:sp>
         <p:sp>
           <p:nvSpPr>
-            <p:cNvPr id="444" name="Shape 9"/>
+            <p:cNvPr id="447" name="Shape 9"/>
             <p:cNvSpPr/>
             <p:nvPr/>
           </p:nvSpPr>
@@ -21140,7 +21269,7 @@
         </p:sp>
         <p:sp>
           <p:nvSpPr>
-            <p:cNvPr id="445" name="Shape 10"/>
+            <p:cNvPr id="448" name="Shape 10"/>
             <p:cNvSpPr/>
             <p:nvPr/>
           </p:nvSpPr>
@@ -21184,7 +21313,7 @@
         </p:sp>
         <p:sp>
           <p:nvSpPr>
-            <p:cNvPr id="446" name="Shape 11"/>
+            <p:cNvPr id="449" name="Shape 11"/>
             <p:cNvSpPr/>
             <p:nvPr/>
           </p:nvSpPr>
@@ -21228,7 +21357,7 @@
         </p:sp>
         <p:sp>
           <p:nvSpPr>
-            <p:cNvPr id="447" name="Shape 12"/>
+            <p:cNvPr id="450" name="Shape 12"/>
             <p:cNvSpPr/>
             <p:nvPr/>
           </p:nvSpPr>
@@ -21272,14 +21401,14 @@
         </p:sp>
         <p:sp>
           <p:nvSpPr>
-            <p:cNvPr id="448" name="Shape 13"/>
+            <p:cNvPr id="451" name="Shape 13"/>
             <p:cNvSpPr/>
             <p:nvPr/>
           </p:nvSpPr>
           <p:spPr>
             <a:xfrm>
               <a:off x="365760" y="5513832"/>
-              <a:ext cx="6592823" cy="457200"/>
+              <a:ext cx="6208775" cy="457200"/>
             </a:xfrm>
             <a:prstGeom prst="rect">
               <a:avLst/>
@@ -21316,14 +21445,14 @@
         </p:sp>
         <p:sp>
           <p:nvSpPr>
-            <p:cNvPr id="449" name="Shape 14"/>
+            <p:cNvPr id="452" name="Shape 14"/>
             <p:cNvSpPr/>
             <p:nvPr/>
           </p:nvSpPr>
           <p:spPr>
             <a:xfrm>
-              <a:off x="8558784" y="5513832"/>
-              <a:ext cx="3264408" cy="457200"/>
+              <a:off x="8805672" y="5513832"/>
+              <a:ext cx="3017519" cy="457200"/>
             </a:xfrm>
             <a:prstGeom prst="rect">
               <a:avLst/>
@@ -21360,7 +21489,7 @@
         </p:sp>
         <p:sp>
           <p:nvSpPr>
-            <p:cNvPr id="450" name="Shape 15"/>
+            <p:cNvPr id="453" name="Shape 15"/>
             <p:cNvSpPr/>
             <p:nvPr/>
           </p:nvSpPr>
@@ -21404,7 +21533,7 @@
         </p:sp>
         <p:sp>
           <p:nvSpPr>
-            <p:cNvPr id="451" name="Shape 16"/>
+            <p:cNvPr id="454" name="Shape 16"/>
             <p:cNvSpPr/>
             <p:nvPr/>
           </p:nvSpPr>
@@ -21448,7 +21577,7 @@
         </p:sp>
         <p:sp>
           <p:nvSpPr>
-            <p:cNvPr id="452" name="Shape 17"/>
+            <p:cNvPr id="455" name="Shape 17"/>
             <p:cNvSpPr/>
             <p:nvPr/>
           </p:nvSpPr>
@@ -21492,14 +21621,14 @@
         </p:sp>
         <p:sp>
           <p:nvSpPr>
-            <p:cNvPr id="453" name="Shape 18"/>
+            <p:cNvPr id="456" name="Shape 18"/>
             <p:cNvSpPr/>
             <p:nvPr/>
           </p:nvSpPr>
           <p:spPr>
             <a:xfrm>
-              <a:off x="6986016" y="5550408"/>
-              <a:ext cx="1545336" cy="420624"/>
+              <a:off x="6601968" y="5550408"/>
+              <a:ext cx="2176272" cy="420624"/>
             </a:xfrm>
             <a:prstGeom prst="roundRect">
               <a:avLst>
@@ -21536,7 +21665,7 @@
         </p:sp>
         <p:sp>
           <p:nvSpPr>
-            <p:cNvPr id="454" name="Shape 19"/>
+            <p:cNvPr id="457" name="Shape 19"/>
             <p:cNvSpPr/>
             <p:nvPr/>
           </p:nvSpPr>
@@ -21580,7 +21709,7 @@
         </p:sp>
         <p:sp>
           <p:nvSpPr>
-            <p:cNvPr id="455" name="Shape 20"/>
+            <p:cNvPr id="458" name="Shape 20"/>
             <p:cNvSpPr/>
             <p:nvPr/>
           </p:nvSpPr>
@@ -21626,7 +21755,7 @@
         </p:sp>
         <p:sp>
           <p:nvSpPr>
-            <p:cNvPr id="456" name="Text 21"/>
+            <p:cNvPr id="459" name="Text 21"/>
             <p:cNvSpPr txBox="1"/>
             <p:nvPr/>
           </p:nvSpPr>
@@ -21667,7 +21796,7 @@
                   </a:solidFill>
                   <a:latin typeface="Trenda IG Text"/>
                 </a:rPr>
-                <a:t>H4 · BUSINESS UAT SIGNED (STEP 06)</a:t>
+                <a:t>06 UAT, THEN H4 · BUSINESS SIGN-OFF</a:t>
               </a:r>
             </a:p>
             <a:p>
@@ -21691,21 +21820,21 @@
       </p:grpSp>
       <p:grpSp>
         <p:nvGrpSpPr>
-          <p:cNvPr id="457" name="Step 10 arrows"/>
+          <p:cNvPr id="460" name="Step 10 arrows"/>
           <p:cNvGrpSpPr/>
           <p:nvPr/>
         </p:nvGrpSpPr>
         <p:grpSpPr>
           <a:xfrm>
             <a:off x="3621024" y="4453128"/>
-            <a:ext cx="5266943" cy="1700784"/>
+            <a:ext cx="5541264" cy="1700784"/>
             <a:chOff x="3621024" y="4453128"/>
-            <a:chExt cx="5266943" cy="1700784"/>
+            <a:chExt cx="5541264" cy="1700784"/>
           </a:xfrm>
         </p:grpSpPr>
         <p:cxnSp>
           <p:nvCxnSpPr>
-            <p:cNvPr id="458" name="Arrow 1"/>
+            <p:cNvPr id="461" name="Arrow 1"/>
             <p:cNvCxnSpPr/>
             <p:nvPr/>
           </p:nvCxnSpPr>
@@ -21740,14 +21869,14 @@
         </p:cxnSp>
         <p:cxnSp>
           <p:nvCxnSpPr>
-            <p:cNvPr id="459" name="Arrow 2"/>
+            <p:cNvPr id="462" name="Arrow 2"/>
             <p:cNvCxnSpPr/>
             <p:nvPr/>
           </p:nvCxnSpPr>
           <p:spPr>
             <a:xfrm>
               <a:off x="3621024" y="5449824"/>
-              <a:ext cx="4535424" cy="0"/>
+              <a:ext cx="4809744" cy="0"/>
             </a:xfrm>
             <a:prstGeom prst="line">
               <a:avLst/>
@@ -21775,13 +21904,13 @@
         </p:cxnSp>
         <p:cxnSp>
           <p:nvCxnSpPr>
-            <p:cNvPr id="460" name="Arrow 3"/>
+            <p:cNvPr id="463" name="Arrow 3"/>
             <p:cNvCxnSpPr/>
             <p:nvPr/>
           </p:nvCxnSpPr>
           <p:spPr>
             <a:xfrm>
-              <a:off x="8156448" y="5449824"/>
+              <a:off x="8430768" y="5449824"/>
               <a:ext cx="0" cy="100584"/>
             </a:xfrm>
             <a:prstGeom prst="line">
@@ -21811,13 +21940,13 @@
         </p:cxnSp>
         <p:sp>
           <p:nvSpPr>
-            <p:cNvPr id="461" name="Shape 4"/>
+            <p:cNvPr id="464" name="Shape 4"/>
             <p:cNvSpPr/>
             <p:nvPr/>
           </p:nvSpPr>
           <p:spPr>
             <a:xfrm>
-              <a:off x="7424927" y="5971032"/>
+              <a:off x="7699248" y="5971032"/>
               <a:ext cx="1463040" cy="182880"/>
             </a:xfrm>
             <a:prstGeom prst="roundRect">
@@ -21855,13 +21984,13 @@
         </p:sp>
         <p:sp>
           <p:nvSpPr>
-            <p:cNvPr id="462" name="Text 5"/>
+            <p:cNvPr id="465" name="Text 5"/>
             <p:cNvSpPr txBox="1"/>
             <p:nvPr/>
           </p:nvSpPr>
           <p:spPr>
             <a:xfrm>
-              <a:off x="7424927" y="5971032"/>
+              <a:off x="7699248" y="5971032"/>
               <a:ext cx="1463040" cy="182880"/>
             </a:xfrm>
             <a:prstGeom prst="rect">
@@ -21891,7 +22020,7 @@
       </p:grpSp>
       <p:grpSp>
         <p:nvGrpSpPr>
-          <p:cNvPr id="463" name="Step 11 highlight"/>
+          <p:cNvPr id="466" name="Step 11 highlight"/>
           <p:cNvGrpSpPr/>
           <p:nvPr/>
         </p:nvGrpSpPr>
@@ -21905,7 +22034,7 @@
         </p:grpSpPr>
         <p:sp>
           <p:nvSpPr>
-            <p:cNvPr id="464" name="Shape 1"/>
+            <p:cNvPr id="467" name="Shape 1"/>
             <p:cNvSpPr/>
             <p:nvPr/>
           </p:nvSpPr>
@@ -21949,7 +22078,7 @@
         </p:sp>
         <p:sp>
           <p:nvSpPr>
-            <p:cNvPr id="465" name="Shape 2"/>
+            <p:cNvPr id="468" name="Shape 2"/>
             <p:cNvSpPr/>
             <p:nvPr/>
           </p:nvSpPr>
@@ -21993,7 +22122,7 @@
         </p:sp>
         <p:sp>
           <p:nvSpPr>
-            <p:cNvPr id="466" name="Shape 3"/>
+            <p:cNvPr id="469" name="Shape 3"/>
             <p:cNvSpPr/>
             <p:nvPr/>
           </p:nvSpPr>
@@ -22037,7 +22166,7 @@
         </p:sp>
         <p:sp>
           <p:nvSpPr>
-            <p:cNvPr id="467" name="Shape 4"/>
+            <p:cNvPr id="470" name="Shape 4"/>
             <p:cNvSpPr/>
             <p:nvPr/>
           </p:nvSpPr>
@@ -22081,7 +22210,7 @@
         </p:sp>
         <p:sp>
           <p:nvSpPr>
-            <p:cNvPr id="468" name="Shape 5"/>
+            <p:cNvPr id="471" name="Shape 5"/>
             <p:cNvSpPr/>
             <p:nvPr/>
           </p:nvSpPr>
@@ -22125,7 +22254,7 @@
         </p:sp>
         <p:sp>
           <p:nvSpPr>
-            <p:cNvPr id="469" name="Shape 6"/>
+            <p:cNvPr id="472" name="Shape 6"/>
             <p:cNvSpPr/>
             <p:nvPr/>
           </p:nvSpPr>
@@ -22169,7 +22298,7 @@
         </p:sp>
         <p:sp>
           <p:nvSpPr>
-            <p:cNvPr id="470" name="Shape 7"/>
+            <p:cNvPr id="473" name="Shape 7"/>
             <p:cNvSpPr/>
             <p:nvPr/>
           </p:nvSpPr>
@@ -22213,7 +22342,7 @@
         </p:sp>
         <p:sp>
           <p:nvSpPr>
-            <p:cNvPr id="471" name="Shape 8"/>
+            <p:cNvPr id="474" name="Shape 8"/>
             <p:cNvSpPr/>
             <p:nvPr/>
           </p:nvSpPr>
@@ -22257,7 +22386,7 @@
         </p:sp>
         <p:sp>
           <p:nvSpPr>
-            <p:cNvPr id="472" name="Shape 9"/>
+            <p:cNvPr id="475" name="Shape 9"/>
             <p:cNvSpPr/>
             <p:nvPr/>
           </p:nvSpPr>
@@ -22301,7 +22430,7 @@
         </p:sp>
         <p:sp>
           <p:nvSpPr>
-            <p:cNvPr id="473" name="Shape 10"/>
+            <p:cNvPr id="476" name="Shape 10"/>
             <p:cNvSpPr/>
             <p:nvPr/>
           </p:nvSpPr>
@@ -22345,14 +22474,14 @@
         </p:sp>
         <p:sp>
           <p:nvSpPr>
-            <p:cNvPr id="474" name="Shape 11"/>
+            <p:cNvPr id="477" name="Shape 11"/>
             <p:cNvSpPr/>
             <p:nvPr/>
           </p:nvSpPr>
           <p:spPr>
             <a:xfrm>
               <a:off x="365760" y="5513832"/>
-              <a:ext cx="8183880" cy="457200"/>
+              <a:ext cx="8430768" cy="457200"/>
             </a:xfrm>
             <a:prstGeom prst="rect">
               <a:avLst/>
@@ -22389,14 +22518,14 @@
         </p:sp>
         <p:sp>
           <p:nvSpPr>
-            <p:cNvPr id="475" name="Shape 12"/>
+            <p:cNvPr id="478" name="Shape 12"/>
             <p:cNvSpPr/>
             <p:nvPr/>
           </p:nvSpPr>
           <p:spPr>
             <a:xfrm>
-              <a:off x="10149840" y="5513832"/>
-              <a:ext cx="1673351" cy="457200"/>
+              <a:off x="10287000" y="5513832"/>
+              <a:ext cx="1536191" cy="457200"/>
             </a:xfrm>
             <a:prstGeom prst="rect">
               <a:avLst/>
@@ -22433,7 +22562,7 @@
         </p:sp>
         <p:sp>
           <p:nvSpPr>
-            <p:cNvPr id="476" name="Shape 13"/>
+            <p:cNvPr id="479" name="Shape 13"/>
             <p:cNvSpPr/>
             <p:nvPr/>
           </p:nvSpPr>
@@ -22477,7 +22606,7 @@
         </p:sp>
         <p:sp>
           <p:nvSpPr>
-            <p:cNvPr id="477" name="Shape 14"/>
+            <p:cNvPr id="480" name="Shape 14"/>
             <p:cNvSpPr/>
             <p:nvPr/>
           </p:nvSpPr>
@@ -22521,14 +22650,14 @@
         </p:sp>
         <p:sp>
           <p:nvSpPr>
-            <p:cNvPr id="478" name="Shape 15"/>
+            <p:cNvPr id="481" name="Shape 15"/>
             <p:cNvSpPr/>
             <p:nvPr/>
           </p:nvSpPr>
           <p:spPr>
             <a:xfrm>
-              <a:off x="8577072" y="5550408"/>
-              <a:ext cx="1545335" cy="420624"/>
+              <a:off x="8823960" y="5550408"/>
+              <a:ext cx="1435607" cy="420624"/>
             </a:xfrm>
             <a:prstGeom prst="roundRect">
               <a:avLst>
@@ -22565,7 +22694,7 @@
         </p:sp>
         <p:sp>
           <p:nvSpPr>
-            <p:cNvPr id="479" name="Shape 16"/>
+            <p:cNvPr id="482" name="Shape 16"/>
             <p:cNvSpPr/>
             <p:nvPr/>
           </p:nvSpPr>
@@ -22609,7 +22738,7 @@
         </p:sp>
         <p:sp>
           <p:nvSpPr>
-            <p:cNvPr id="480" name="Shape 17"/>
+            <p:cNvPr id="483" name="Shape 17"/>
             <p:cNvSpPr/>
             <p:nvPr/>
           </p:nvSpPr>
@@ -22653,7 +22782,7 @@
         </p:sp>
         <p:sp>
           <p:nvSpPr>
-            <p:cNvPr id="481" name="Shape 18"/>
+            <p:cNvPr id="484" name="Shape 18"/>
             <p:cNvSpPr/>
             <p:nvPr/>
           </p:nvSpPr>
@@ -22699,7 +22828,7 @@
         </p:sp>
         <p:sp>
           <p:nvSpPr>
-            <p:cNvPr id="482" name="Text 19"/>
+            <p:cNvPr id="485" name="Text 19"/>
             <p:cNvSpPr txBox="1"/>
             <p:nvPr/>
           </p:nvSpPr>
@@ -22764,21 +22893,21 @@
       </p:grpSp>
       <p:grpSp>
         <p:nvGrpSpPr>
-          <p:cNvPr id="483" name="Step 11 arrows"/>
+          <p:cNvPr id="486" name="Step 11 arrows"/>
           <p:cNvGrpSpPr/>
           <p:nvPr/>
         </p:nvGrpSpPr>
         <p:grpSpPr>
           <a:xfrm>
             <a:off x="3621024" y="4453128"/>
-            <a:ext cx="6858000" cy="1700784"/>
+            <a:ext cx="7022592" cy="1700784"/>
             <a:chOff x="3621024" y="4453128"/>
-            <a:chExt cx="6858000" cy="1700784"/>
+            <a:chExt cx="7022592" cy="1700784"/>
           </a:xfrm>
         </p:grpSpPr>
         <p:cxnSp>
           <p:nvCxnSpPr>
-            <p:cNvPr id="484" name="Arrow 1"/>
+            <p:cNvPr id="487" name="Arrow 1"/>
             <p:cNvCxnSpPr/>
             <p:nvPr/>
           </p:nvCxnSpPr>
@@ -22813,14 +22942,14 @@
         </p:cxnSp>
         <p:cxnSp>
           <p:nvCxnSpPr>
-            <p:cNvPr id="485" name="Arrow 2"/>
+            <p:cNvPr id="488" name="Arrow 2"/>
             <p:cNvCxnSpPr/>
             <p:nvPr/>
           </p:nvCxnSpPr>
           <p:spPr>
             <a:xfrm>
               <a:off x="3621024" y="5449824"/>
-              <a:ext cx="6126480" cy="0"/>
+              <a:ext cx="6291072" cy="0"/>
             </a:xfrm>
             <a:prstGeom prst="line">
               <a:avLst/>
@@ -22848,13 +22977,13 @@
         </p:cxnSp>
         <p:cxnSp>
           <p:nvCxnSpPr>
-            <p:cNvPr id="486" name="Arrow 3"/>
+            <p:cNvPr id="489" name="Arrow 3"/>
             <p:cNvCxnSpPr/>
             <p:nvPr/>
           </p:nvCxnSpPr>
           <p:spPr>
             <a:xfrm>
-              <a:off x="9747504" y="5449824"/>
+              <a:off x="9912096" y="5449824"/>
               <a:ext cx="0" cy="100584"/>
             </a:xfrm>
             <a:prstGeom prst="line">
@@ -22884,13 +23013,13 @@
         </p:cxnSp>
         <p:sp>
           <p:nvSpPr>
-            <p:cNvPr id="487" name="Shape 4"/>
+            <p:cNvPr id="490" name="Shape 4"/>
             <p:cNvSpPr/>
             <p:nvPr/>
           </p:nvSpPr>
           <p:spPr>
             <a:xfrm>
-              <a:off x="9015984" y="5971032"/>
+              <a:off x="9180576" y="5971032"/>
               <a:ext cx="1463040" cy="182880"/>
             </a:xfrm>
             <a:prstGeom prst="roundRect">
@@ -22928,13 +23057,13 @@
         </p:sp>
         <p:sp>
           <p:nvSpPr>
-            <p:cNvPr id="488" name="Text 5"/>
+            <p:cNvPr id="491" name="Text 5"/>
             <p:cNvSpPr txBox="1"/>
             <p:nvPr/>
           </p:nvSpPr>
           <p:spPr>
             <a:xfrm>
-              <a:off x="9015984" y="5971032"/>
+              <a:off x="9180576" y="5971032"/>
               <a:ext cx="1463040" cy="182880"/>
             </a:xfrm>
             <a:prstGeom prst="rect">
@@ -22964,7 +23093,7 @@
       </p:grpSp>
       <p:grpSp>
         <p:nvGrpSpPr>
-          <p:cNvPr id="489" name="Step 12 highlight"/>
+          <p:cNvPr id="492" name="Step 12 highlight"/>
           <p:cNvGrpSpPr/>
           <p:nvPr/>
         </p:nvGrpSpPr>
@@ -22978,7 +23107,7 @@
         </p:grpSpPr>
         <p:sp>
           <p:nvSpPr>
-            <p:cNvPr id="490" name="Shape 1"/>
+            <p:cNvPr id="493" name="Shape 1"/>
             <p:cNvSpPr/>
             <p:nvPr/>
           </p:nvSpPr>
@@ -23022,7 +23151,7 @@
         </p:sp>
         <p:sp>
           <p:nvSpPr>
-            <p:cNvPr id="491" name="Shape 2"/>
+            <p:cNvPr id="494" name="Shape 2"/>
             <p:cNvSpPr/>
             <p:nvPr/>
           </p:nvSpPr>
@@ -23066,7 +23195,7 @@
         </p:sp>
         <p:sp>
           <p:nvSpPr>
-            <p:cNvPr id="492" name="Shape 3"/>
+            <p:cNvPr id="495" name="Shape 3"/>
             <p:cNvSpPr/>
             <p:nvPr/>
           </p:nvSpPr>
@@ -23110,7 +23239,7 @@
         </p:sp>
         <p:sp>
           <p:nvSpPr>
-            <p:cNvPr id="493" name="Shape 4"/>
+            <p:cNvPr id="496" name="Shape 4"/>
             <p:cNvSpPr/>
             <p:nvPr/>
           </p:nvSpPr>
@@ -23154,7 +23283,7 @@
         </p:sp>
         <p:sp>
           <p:nvSpPr>
-            <p:cNvPr id="494" name="Shape 5"/>
+            <p:cNvPr id="497" name="Shape 5"/>
             <p:cNvSpPr/>
             <p:nvPr/>
           </p:nvSpPr>
@@ -23198,7 +23327,7 @@
         </p:sp>
         <p:sp>
           <p:nvSpPr>
-            <p:cNvPr id="495" name="Shape 6"/>
+            <p:cNvPr id="498" name="Shape 6"/>
             <p:cNvSpPr/>
             <p:nvPr/>
           </p:nvSpPr>
@@ -23242,7 +23371,7 @@
         </p:sp>
         <p:sp>
           <p:nvSpPr>
-            <p:cNvPr id="496" name="Shape 7"/>
+            <p:cNvPr id="499" name="Shape 7"/>
             <p:cNvSpPr/>
             <p:nvPr/>
           </p:nvSpPr>
@@ -23286,14 +23415,14 @@
         </p:sp>
         <p:sp>
           <p:nvSpPr>
-            <p:cNvPr id="497" name="Shape 8"/>
+            <p:cNvPr id="500" name="Shape 8"/>
             <p:cNvSpPr/>
             <p:nvPr/>
           </p:nvSpPr>
           <p:spPr>
             <a:xfrm>
               <a:off x="365760" y="5513832"/>
-              <a:ext cx="9774936" cy="457200"/>
+              <a:ext cx="9912096" cy="457200"/>
             </a:xfrm>
             <a:prstGeom prst="rect">
               <a:avLst/>
@@ -23330,14 +23459,14 @@
         </p:sp>
         <p:sp>
           <p:nvSpPr>
-            <p:cNvPr id="498" name="Shape 9"/>
+            <p:cNvPr id="501" name="Shape 9"/>
             <p:cNvSpPr/>
             <p:nvPr/>
           </p:nvSpPr>
           <p:spPr>
             <a:xfrm>
-              <a:off x="11740896" y="5513832"/>
-              <a:ext cx="82295" cy="457200"/>
+              <a:off x="11768328" y="5513832"/>
+              <a:ext cx="54863" cy="457200"/>
             </a:xfrm>
             <a:prstGeom prst="rect">
               <a:avLst/>
@@ -23374,7 +23503,7 @@
         </p:sp>
         <p:sp>
           <p:nvSpPr>
-            <p:cNvPr id="499" name="Shape 10"/>
+            <p:cNvPr id="502" name="Shape 10"/>
             <p:cNvSpPr/>
             <p:nvPr/>
           </p:nvSpPr>
@@ -23418,14 +23547,14 @@
         </p:sp>
         <p:sp>
           <p:nvSpPr>
-            <p:cNvPr id="500" name="Shape 11"/>
+            <p:cNvPr id="503" name="Shape 11"/>
             <p:cNvSpPr/>
             <p:nvPr/>
           </p:nvSpPr>
           <p:spPr>
             <a:xfrm>
-              <a:off x="10131552" y="5513832"/>
-              <a:ext cx="1618488" cy="457200"/>
+              <a:off x="10268712" y="5513832"/>
+              <a:ext cx="1508760" cy="457200"/>
             </a:xfrm>
             <a:prstGeom prst="roundRect">
               <a:avLst>
@@ -23462,7 +23591,7 @@
         </p:sp>
         <p:sp>
           <p:nvSpPr>
-            <p:cNvPr id="501" name="Shape 12"/>
+            <p:cNvPr id="504" name="Shape 12"/>
             <p:cNvSpPr/>
             <p:nvPr/>
           </p:nvSpPr>
@@ -23506,7 +23635,7 @@
         </p:sp>
         <p:sp>
           <p:nvSpPr>
-            <p:cNvPr id="502" name="Shape 13"/>
+            <p:cNvPr id="505" name="Shape 13"/>
             <p:cNvSpPr/>
             <p:nvPr/>
           </p:nvSpPr>
@@ -23550,7 +23679,7 @@
         </p:sp>
         <p:sp>
           <p:nvSpPr>
-            <p:cNvPr id="503" name="Shape 14"/>
+            <p:cNvPr id="506" name="Shape 14"/>
             <p:cNvSpPr/>
             <p:nvPr/>
           </p:nvSpPr>
@@ -23596,7 +23725,7 @@
         </p:sp>
         <p:sp>
           <p:nvSpPr>
-            <p:cNvPr id="504" name="Text 15"/>
+            <p:cNvPr id="507" name="Text 15"/>
             <p:cNvSpPr txBox="1"/>
             <p:nvPr/>
           </p:nvSpPr>
@@ -23661,27 +23790,27 @@
       </p:grpSp>
       <p:grpSp>
         <p:nvGrpSpPr>
-          <p:cNvPr id="505" name="Step 12 arrows"/>
+          <p:cNvPr id="508" name="Step 12 arrows"/>
           <p:cNvGrpSpPr/>
           <p:nvPr/>
         </p:nvGrpSpPr>
         <p:grpSpPr>
           <a:xfrm>
-            <a:off x="10543032" y="5404104"/>
+            <a:off x="10652760" y="5404104"/>
             <a:ext cx="0" cy="146304"/>
-            <a:chOff x="10543032" y="5404104"/>
+            <a:chOff x="10652760" y="5404104"/>
             <a:chExt cx="0" cy="146304"/>
           </a:xfrm>
         </p:grpSpPr>
         <p:cxnSp>
           <p:nvCxnSpPr>
-            <p:cNvPr id="506" name="Arrow 1"/>
+            <p:cNvPr id="509" name="Arrow 1"/>
             <p:cNvCxnSpPr/>
             <p:nvPr/>
           </p:nvCxnSpPr>
           <p:spPr>
             <a:xfrm flipV="1">
-              <a:off x="10543032" y="5404104"/>
+              <a:off x="10652760" y="5404104"/>
               <a:ext cx="0" cy="146304"/>
             </a:xfrm>
             <a:prstGeom prst="line">
@@ -23712,7 +23841,7 @@
       </p:grpSp>
       <p:grpSp>
         <p:nvGrpSpPr>
-          <p:cNvPr id="507" name="Step 13 highlight"/>
+          <p:cNvPr id="510" name="Step 13 highlight"/>
           <p:cNvGrpSpPr/>
           <p:nvPr/>
         </p:nvGrpSpPr>
@@ -23726,7 +23855,7 @@
         </p:grpSpPr>
         <p:sp>
           <p:nvSpPr>
-            <p:cNvPr id="508" name="Shape 1"/>
+            <p:cNvPr id="511" name="Shape 1"/>
             <p:cNvSpPr/>
             <p:nvPr/>
           </p:nvSpPr>
@@ -23770,7 +23899,7 @@
         </p:sp>
         <p:sp>
           <p:nvSpPr>
-            <p:cNvPr id="509" name="Shape 2"/>
+            <p:cNvPr id="512" name="Shape 2"/>
             <p:cNvSpPr/>
             <p:nvPr/>
           </p:nvSpPr>
@@ -23814,7 +23943,7 @@
         </p:sp>
         <p:sp>
           <p:nvSpPr>
-            <p:cNvPr id="510" name="Shape 3"/>
+            <p:cNvPr id="513" name="Shape 3"/>
             <p:cNvSpPr/>
             <p:nvPr/>
           </p:nvSpPr>
@@ -23858,7 +23987,7 @@
         </p:sp>
         <p:sp>
           <p:nvSpPr>
-            <p:cNvPr id="511" name="Shape 4"/>
+            <p:cNvPr id="514" name="Shape 4"/>
             <p:cNvSpPr/>
             <p:nvPr/>
           </p:nvSpPr>
@@ -23902,7 +24031,7 @@
         </p:sp>
         <p:sp>
           <p:nvSpPr>
-            <p:cNvPr id="512" name="Shape 5"/>
+            <p:cNvPr id="515" name="Shape 5"/>
             <p:cNvSpPr/>
             <p:nvPr/>
           </p:nvSpPr>
@@ -23946,7 +24075,7 @@
         </p:sp>
         <p:sp>
           <p:nvSpPr>
-            <p:cNvPr id="513" name="Shape 6"/>
+            <p:cNvPr id="516" name="Shape 6"/>
             <p:cNvSpPr/>
             <p:nvPr/>
           </p:nvSpPr>
@@ -23990,7 +24119,7 @@
         </p:sp>
         <p:sp>
           <p:nvSpPr>
-            <p:cNvPr id="514" name="Shape 7"/>
+            <p:cNvPr id="517" name="Shape 7"/>
             <p:cNvSpPr/>
             <p:nvPr/>
           </p:nvSpPr>
@@ -24036,7 +24165,7 @@
         </p:sp>
         <p:sp>
           <p:nvSpPr>
-            <p:cNvPr id="515" name="Text 8"/>
+            <p:cNvPr id="518" name="Text 8"/>
             <p:cNvSpPr txBox="1"/>
             <p:nvPr/>
           </p:nvSpPr>
@@ -24138,7 +24267,7 @@
                                           </p:stCondLst>
                                         </p:cTn>
                                         <p:tgtEl>
-                                          <p:spTgt spid="235"/>
+                                          <p:spTgt spid="238"/>
                                         </p:tgtEl>
                                         <p:attrNameLst>
                                           <p:attrName>style.visibility</p:attrName>
@@ -24152,7 +24281,7 @@
                                       <p:cBhvr>
                                         <p:cTn id="7" dur="350"/>
                                         <p:tgtEl>
-                                          <p:spTgt spid="235"/>
+                                          <p:spTgt spid="238"/>
                                         </p:tgtEl>
                                       </p:cBhvr>
                                     </p:animEffect>
@@ -24182,7 +24311,7 @@
                                           </p:stCondLst>
                                         </p:cTn>
                                         <p:tgtEl>
-                                          <p:spTgt spid="248"/>
+                                          <p:spTgt spid="251"/>
                                         </p:tgtEl>
                                         <p:attrNameLst>
                                           <p:attrName>style.visibility</p:attrName>
@@ -24196,7 +24325,7 @@
                                       <p:cBhvr>
                                         <p:cTn id="11" dur="600"/>
                                         <p:tgtEl>
-                                          <p:spTgt spid="248"/>
+                                          <p:spTgt spid="251"/>
                                         </p:tgtEl>
                                       </p:cBhvr>
                                     </p:animEffect>
@@ -24231,7 +24360,7 @@
                                       <p:cBhvr>
                                         <p:cTn id="15" dur="250"/>
                                         <p:tgtEl>
-                                          <p:spTgt spid="235"/>
+                                          <p:spTgt spid="238"/>
                                         </p:tgtEl>
                                       </p:cBhvr>
                                     </p:animEffect>
@@ -24243,7 +24372,7 @@
                                           </p:stCondLst>
                                         </p:cTn>
                                         <p:tgtEl>
-                                          <p:spTgt spid="235"/>
+                                          <p:spTgt spid="238"/>
                                         </p:tgtEl>
                                         <p:attrNameLst>
                                           <p:attrName>style.visibility</p:attrName>
@@ -24266,7 +24395,7 @@
                                       <p:cBhvr>
                                         <p:cTn id="18" dur="250"/>
                                         <p:tgtEl>
-                                          <p:spTgt spid="248"/>
+                                          <p:spTgt spid="251"/>
                                         </p:tgtEl>
                                       </p:cBhvr>
                                     </p:animEffect>
@@ -24278,7 +24407,7 @@
                                           </p:stCondLst>
                                         </p:cTn>
                                         <p:tgtEl>
-                                          <p:spTgt spid="248"/>
+                                          <p:spTgt spid="251"/>
                                         </p:tgtEl>
                                         <p:attrNameLst>
                                           <p:attrName>style.visibility</p:attrName>
@@ -24305,7 +24434,7 @@
                                           </p:stCondLst>
                                         </p:cTn>
                                         <p:tgtEl>
-                                          <p:spTgt spid="251"/>
+                                          <p:spTgt spid="254"/>
                                         </p:tgtEl>
                                         <p:attrNameLst>
                                           <p:attrName>style.visibility</p:attrName>
@@ -24319,7 +24448,7 @@
                                       <p:cBhvr>
                                         <p:cTn id="22" dur="350"/>
                                         <p:tgtEl>
-                                          <p:spTgt spid="251"/>
+                                          <p:spTgt spid="254"/>
                                         </p:tgtEl>
                                       </p:cBhvr>
                                     </p:animEffect>
@@ -24349,7 +24478,7 @@
                                           </p:stCondLst>
                                         </p:cTn>
                                         <p:tgtEl>
-                                          <p:spTgt spid="272"/>
+                                          <p:spTgt spid="275"/>
                                         </p:tgtEl>
                                         <p:attrNameLst>
                                           <p:attrName>style.visibility</p:attrName>
@@ -24363,7 +24492,7 @@
                                       <p:cBhvr>
                                         <p:cTn id="26" dur="600"/>
                                         <p:tgtEl>
-                                          <p:spTgt spid="272"/>
+                                          <p:spTgt spid="275"/>
                                         </p:tgtEl>
                                       </p:cBhvr>
                                     </p:animEffect>
@@ -24398,7 +24527,7 @@
                                       <p:cBhvr>
                                         <p:cTn id="30" dur="250"/>
                                         <p:tgtEl>
-                                          <p:spTgt spid="251"/>
+                                          <p:spTgt spid="254"/>
                                         </p:tgtEl>
                                       </p:cBhvr>
                                     </p:animEffect>
@@ -24410,7 +24539,7 @@
                                           </p:stCondLst>
                                         </p:cTn>
                                         <p:tgtEl>
-                                          <p:spTgt spid="251"/>
+                                          <p:spTgt spid="254"/>
                                         </p:tgtEl>
                                         <p:attrNameLst>
                                           <p:attrName>style.visibility</p:attrName>
@@ -24433,7 +24562,7 @@
                                       <p:cBhvr>
                                         <p:cTn id="33" dur="250"/>
                                         <p:tgtEl>
-                                          <p:spTgt spid="272"/>
+                                          <p:spTgt spid="275"/>
                                         </p:tgtEl>
                                       </p:cBhvr>
                                     </p:animEffect>
@@ -24445,7 +24574,7 @@
                                           </p:stCondLst>
                                         </p:cTn>
                                         <p:tgtEl>
-                                          <p:spTgt spid="272"/>
+                                          <p:spTgt spid="275"/>
                                         </p:tgtEl>
                                         <p:attrNameLst>
                                           <p:attrName>style.visibility</p:attrName>
@@ -24472,7 +24601,7 @@
                                           </p:stCondLst>
                                         </p:cTn>
                                         <p:tgtEl>
-                                          <p:spTgt spid="275"/>
+                                          <p:spTgt spid="278"/>
                                         </p:tgtEl>
                                         <p:attrNameLst>
                                           <p:attrName>style.visibility</p:attrName>
@@ -24486,7 +24615,7 @@
                                       <p:cBhvr>
                                         <p:cTn id="37" dur="350"/>
                                         <p:tgtEl>
-                                          <p:spTgt spid="275"/>
+                                          <p:spTgt spid="278"/>
                                         </p:tgtEl>
                                       </p:cBhvr>
                                     </p:animEffect>
@@ -24516,7 +24645,7 @@
                                           </p:stCondLst>
                                         </p:cTn>
                                         <p:tgtEl>
-                                          <p:spTgt spid="284"/>
+                                          <p:spTgt spid="287"/>
                                         </p:tgtEl>
                                         <p:attrNameLst>
                                           <p:attrName>style.visibility</p:attrName>
@@ -24530,7 +24659,7 @@
                                       <p:cBhvr>
                                         <p:cTn id="41" dur="600"/>
                                         <p:tgtEl>
-                                          <p:spTgt spid="284"/>
+                                          <p:spTgt spid="287"/>
                                         </p:tgtEl>
                                       </p:cBhvr>
                                     </p:animEffect>
@@ -24565,7 +24694,7 @@
                                       <p:cBhvr>
                                         <p:cTn id="45" dur="250"/>
                                         <p:tgtEl>
-                                          <p:spTgt spid="275"/>
+                                          <p:spTgt spid="278"/>
                                         </p:tgtEl>
                                       </p:cBhvr>
                                     </p:animEffect>
@@ -24577,7 +24706,7 @@
                                           </p:stCondLst>
                                         </p:cTn>
                                         <p:tgtEl>
-                                          <p:spTgt spid="275"/>
+                                          <p:spTgt spid="278"/>
                                         </p:tgtEl>
                                         <p:attrNameLst>
                                           <p:attrName>style.visibility</p:attrName>
@@ -24600,7 +24729,7 @@
                                       <p:cBhvr>
                                         <p:cTn id="48" dur="250"/>
                                         <p:tgtEl>
-                                          <p:spTgt spid="284"/>
+                                          <p:spTgt spid="287"/>
                                         </p:tgtEl>
                                       </p:cBhvr>
                                     </p:animEffect>
@@ -24612,7 +24741,7 @@
                                           </p:stCondLst>
                                         </p:cTn>
                                         <p:tgtEl>
-                                          <p:spTgt spid="284"/>
+                                          <p:spTgt spid="287"/>
                                         </p:tgtEl>
                                         <p:attrNameLst>
                                           <p:attrName>style.visibility</p:attrName>
@@ -24639,7 +24768,7 @@
                                           </p:stCondLst>
                                         </p:cTn>
                                         <p:tgtEl>
-                                          <p:spTgt spid="286"/>
+                                          <p:spTgt spid="289"/>
                                         </p:tgtEl>
                                         <p:attrNameLst>
                                           <p:attrName>style.visibility</p:attrName>
@@ -24653,7 +24782,7 @@
                                       <p:cBhvr>
                                         <p:cTn id="52" dur="350"/>
                                         <p:tgtEl>
-                                          <p:spTgt spid="286"/>
+                                          <p:spTgt spid="289"/>
                                         </p:tgtEl>
                                       </p:cBhvr>
                                     </p:animEffect>
@@ -24683,7 +24812,7 @@
                                           </p:stCondLst>
                                         </p:cTn>
                                         <p:tgtEl>
-                                          <p:spTgt spid="302"/>
+                                          <p:spTgt spid="305"/>
                                         </p:tgtEl>
                                         <p:attrNameLst>
                                           <p:attrName>style.visibility</p:attrName>
@@ -24697,7 +24826,7 @@
                                       <p:cBhvr>
                                         <p:cTn id="56" dur="600"/>
                                         <p:tgtEl>
-                                          <p:spTgt spid="302"/>
+                                          <p:spTgt spid="305"/>
                                         </p:tgtEl>
                                       </p:cBhvr>
                                     </p:animEffect>
@@ -24732,7 +24861,7 @@
                                       <p:cBhvr>
                                         <p:cTn id="60" dur="250"/>
                                         <p:tgtEl>
-                                          <p:spTgt spid="286"/>
+                                          <p:spTgt spid="289"/>
                                         </p:tgtEl>
                                       </p:cBhvr>
                                     </p:animEffect>
@@ -24744,7 +24873,7 @@
                                           </p:stCondLst>
                                         </p:cTn>
                                         <p:tgtEl>
-                                          <p:spTgt spid="286"/>
+                                          <p:spTgt spid="289"/>
                                         </p:tgtEl>
                                         <p:attrNameLst>
                                           <p:attrName>style.visibility</p:attrName>
@@ -24767,7 +24896,7 @@
                                       <p:cBhvr>
                                         <p:cTn id="63" dur="250"/>
                                         <p:tgtEl>
-                                          <p:spTgt spid="302"/>
+                                          <p:spTgt spid="305"/>
                                         </p:tgtEl>
                                       </p:cBhvr>
                                     </p:animEffect>
@@ -24779,7 +24908,7 @@
                                           </p:stCondLst>
                                         </p:cTn>
                                         <p:tgtEl>
-                                          <p:spTgt spid="302"/>
+                                          <p:spTgt spid="305"/>
                                         </p:tgtEl>
                                         <p:attrNameLst>
                                           <p:attrName>style.visibility</p:attrName>
@@ -24806,7 +24935,7 @@
                                           </p:stCondLst>
                                         </p:cTn>
                                         <p:tgtEl>
-                                          <p:spTgt spid="305"/>
+                                          <p:spTgt spid="308"/>
                                         </p:tgtEl>
                                         <p:attrNameLst>
                                           <p:attrName>style.visibility</p:attrName>
@@ -24820,7 +24949,7 @@
                                       <p:cBhvr>
                                         <p:cTn id="67" dur="350"/>
                                         <p:tgtEl>
-                                          <p:spTgt spid="305"/>
+                                          <p:spTgt spid="308"/>
                                         </p:tgtEl>
                                       </p:cBhvr>
                                     </p:animEffect>
@@ -24850,7 +24979,7 @@
                                           </p:stCondLst>
                                         </p:cTn>
                                         <p:tgtEl>
-                                          <p:spTgt spid="314"/>
+                                          <p:spTgt spid="317"/>
                                         </p:tgtEl>
                                         <p:attrNameLst>
                                           <p:attrName>style.visibility</p:attrName>
@@ -24864,7 +24993,7 @@
                                       <p:cBhvr>
                                         <p:cTn id="71" dur="600"/>
                                         <p:tgtEl>
-                                          <p:spTgt spid="314"/>
+                                          <p:spTgt spid="317"/>
                                         </p:tgtEl>
                                       </p:cBhvr>
                                     </p:animEffect>
@@ -24899,7 +25028,7 @@
                                       <p:cBhvr>
                                         <p:cTn id="75" dur="250"/>
                                         <p:tgtEl>
-                                          <p:spTgt spid="305"/>
+                                          <p:spTgt spid="308"/>
                                         </p:tgtEl>
                                       </p:cBhvr>
                                     </p:animEffect>
@@ -24911,7 +25040,7 @@
                                           </p:stCondLst>
                                         </p:cTn>
                                         <p:tgtEl>
-                                          <p:spTgt spid="305"/>
+                                          <p:spTgt spid="308"/>
                                         </p:tgtEl>
                                         <p:attrNameLst>
                                           <p:attrName>style.visibility</p:attrName>
@@ -24934,7 +25063,7 @@
                                       <p:cBhvr>
                                         <p:cTn id="78" dur="250"/>
                                         <p:tgtEl>
-                                          <p:spTgt spid="314"/>
+                                          <p:spTgt spid="317"/>
                                         </p:tgtEl>
                                       </p:cBhvr>
                                     </p:animEffect>
@@ -24946,7 +25075,7 @@
                                           </p:stCondLst>
                                         </p:cTn>
                                         <p:tgtEl>
-                                          <p:spTgt spid="314"/>
+                                          <p:spTgt spid="317"/>
                                         </p:tgtEl>
                                         <p:attrNameLst>
                                           <p:attrName>style.visibility</p:attrName>
@@ -24973,7 +25102,7 @@
                                           </p:stCondLst>
                                         </p:cTn>
                                         <p:tgtEl>
-                                          <p:spTgt spid="319"/>
+                                          <p:spTgt spid="322"/>
                                         </p:tgtEl>
                                         <p:attrNameLst>
                                           <p:attrName>style.visibility</p:attrName>
@@ -24987,7 +25116,7 @@
                                       <p:cBhvr>
                                         <p:cTn id="82" dur="350"/>
                                         <p:tgtEl>
-                                          <p:spTgt spid="319"/>
+                                          <p:spTgt spid="322"/>
                                         </p:tgtEl>
                                       </p:cBhvr>
                                     </p:animEffect>
@@ -25017,7 +25146,7 @@
                                           </p:stCondLst>
                                         </p:cTn>
                                         <p:tgtEl>
-                                          <p:spTgt spid="328"/>
+                                          <p:spTgt spid="331"/>
                                         </p:tgtEl>
                                         <p:attrNameLst>
                                           <p:attrName>style.visibility</p:attrName>
@@ -25031,7 +25160,7 @@
                                       <p:cBhvr>
                                         <p:cTn id="86" dur="600"/>
                                         <p:tgtEl>
-                                          <p:spTgt spid="328"/>
+                                          <p:spTgt spid="331"/>
                                         </p:tgtEl>
                                       </p:cBhvr>
                                     </p:animEffect>
@@ -25066,7 +25195,7 @@
                                       <p:cBhvr>
                                         <p:cTn id="90" dur="250"/>
                                         <p:tgtEl>
-                                          <p:spTgt spid="319"/>
+                                          <p:spTgt spid="322"/>
                                         </p:tgtEl>
                                       </p:cBhvr>
                                     </p:animEffect>
@@ -25078,7 +25207,7 @@
                                           </p:stCondLst>
                                         </p:cTn>
                                         <p:tgtEl>
-                                          <p:spTgt spid="319"/>
+                                          <p:spTgt spid="322"/>
                                         </p:tgtEl>
                                         <p:attrNameLst>
                                           <p:attrName>style.visibility</p:attrName>
@@ -25101,7 +25230,7 @@
                                       <p:cBhvr>
                                         <p:cTn id="93" dur="250"/>
                                         <p:tgtEl>
-                                          <p:spTgt spid="328"/>
+                                          <p:spTgt spid="331"/>
                                         </p:tgtEl>
                                       </p:cBhvr>
                                     </p:animEffect>
@@ -25113,7 +25242,7 @@
                                           </p:stCondLst>
                                         </p:cTn>
                                         <p:tgtEl>
-                                          <p:spTgt spid="328"/>
+                                          <p:spTgt spid="331"/>
                                         </p:tgtEl>
                                         <p:attrNameLst>
                                           <p:attrName>style.visibility</p:attrName>
@@ -25140,7 +25269,7 @@
                                           </p:stCondLst>
                                         </p:cTn>
                                         <p:tgtEl>
-                                          <p:spTgt spid="337"/>
+                                          <p:spTgt spid="340"/>
                                         </p:tgtEl>
                                         <p:attrNameLst>
                                           <p:attrName>style.visibility</p:attrName>
@@ -25154,7 +25283,7 @@
                                       <p:cBhvr>
                                         <p:cTn id="97" dur="350"/>
                                         <p:tgtEl>
-                                          <p:spTgt spid="337"/>
+                                          <p:spTgt spid="340"/>
                                         </p:tgtEl>
                                       </p:cBhvr>
                                     </p:animEffect>
@@ -25184,7 +25313,7 @@
                                           </p:stCondLst>
                                         </p:cTn>
                                         <p:tgtEl>
-                                          <p:spTgt spid="357"/>
+                                          <p:spTgt spid="360"/>
                                         </p:tgtEl>
                                         <p:attrNameLst>
                                           <p:attrName>style.visibility</p:attrName>
@@ -25198,7 +25327,7 @@
                                       <p:cBhvr>
                                         <p:cTn id="101" dur="600"/>
                                         <p:tgtEl>
-                                          <p:spTgt spid="357"/>
+                                          <p:spTgt spid="360"/>
                                         </p:tgtEl>
                                       </p:cBhvr>
                                     </p:animEffect>
@@ -25233,7 +25362,7 @@
                                       <p:cBhvr>
                                         <p:cTn id="105" dur="250"/>
                                         <p:tgtEl>
-                                          <p:spTgt spid="337"/>
+                                          <p:spTgt spid="340"/>
                                         </p:tgtEl>
                                       </p:cBhvr>
                                     </p:animEffect>
@@ -25245,7 +25374,7 @@
                                           </p:stCondLst>
                                         </p:cTn>
                                         <p:tgtEl>
-                                          <p:spTgt spid="337"/>
+                                          <p:spTgt spid="340"/>
                                         </p:tgtEl>
                                         <p:attrNameLst>
                                           <p:attrName>style.visibility</p:attrName>
@@ -25268,7 +25397,7 @@
                                       <p:cBhvr>
                                         <p:cTn id="108" dur="250"/>
                                         <p:tgtEl>
-                                          <p:spTgt spid="357"/>
+                                          <p:spTgt spid="360"/>
                                         </p:tgtEl>
                                       </p:cBhvr>
                                     </p:animEffect>
@@ -25280,7 +25409,7 @@
                                           </p:stCondLst>
                                         </p:cTn>
                                         <p:tgtEl>
-                                          <p:spTgt spid="357"/>
+                                          <p:spTgt spid="360"/>
                                         </p:tgtEl>
                                         <p:attrNameLst>
                                           <p:attrName>style.visibility</p:attrName>
@@ -25307,7 +25436,7 @@
                                           </p:stCondLst>
                                         </p:cTn>
                                         <p:tgtEl>
-                                          <p:spTgt spid="363"/>
+                                          <p:spTgt spid="366"/>
                                         </p:tgtEl>
                                         <p:attrNameLst>
                                           <p:attrName>style.visibility</p:attrName>
@@ -25321,7 +25450,7 @@
                                       <p:cBhvr>
                                         <p:cTn id="112" dur="350"/>
                                         <p:tgtEl>
-                                          <p:spTgt spid="363"/>
+                                          <p:spTgt spid="366"/>
                                         </p:tgtEl>
                                       </p:cBhvr>
                                     </p:animEffect>
@@ -25351,7 +25480,7 @@
                                           </p:stCondLst>
                                         </p:cTn>
                                         <p:tgtEl>
-                                          <p:spTgt spid="389"/>
+                                          <p:spTgt spid="392"/>
                                         </p:tgtEl>
                                         <p:attrNameLst>
                                           <p:attrName>style.visibility</p:attrName>
@@ -25365,7 +25494,7 @@
                                       <p:cBhvr>
                                         <p:cTn id="116" dur="600"/>
                                         <p:tgtEl>
-                                          <p:spTgt spid="389"/>
+                                          <p:spTgt spid="392"/>
                                         </p:tgtEl>
                                       </p:cBhvr>
                                     </p:animEffect>
@@ -25400,7 +25529,7 @@
                                       <p:cBhvr>
                                         <p:cTn id="120" dur="250"/>
                                         <p:tgtEl>
-                                          <p:spTgt spid="363"/>
+                                          <p:spTgt spid="366"/>
                                         </p:tgtEl>
                                       </p:cBhvr>
                                     </p:animEffect>
@@ -25412,7 +25541,7 @@
                                           </p:stCondLst>
                                         </p:cTn>
                                         <p:tgtEl>
-                                          <p:spTgt spid="363"/>
+                                          <p:spTgt spid="366"/>
                                         </p:tgtEl>
                                         <p:attrNameLst>
                                           <p:attrName>style.visibility</p:attrName>
@@ -25435,7 +25564,7 @@
                                       <p:cBhvr>
                                         <p:cTn id="123" dur="250"/>
                                         <p:tgtEl>
-                                          <p:spTgt spid="389"/>
+                                          <p:spTgt spid="392"/>
                                         </p:tgtEl>
                                       </p:cBhvr>
                                     </p:animEffect>
@@ -25447,7 +25576,7 @@
                                           </p:stCondLst>
                                         </p:cTn>
                                         <p:tgtEl>
-                                          <p:spTgt spid="389"/>
+                                          <p:spTgt spid="392"/>
                                         </p:tgtEl>
                                         <p:attrNameLst>
                                           <p:attrName>style.visibility</p:attrName>
@@ -25474,7 +25603,7 @@
                                           </p:stCondLst>
                                         </p:cTn>
                                         <p:tgtEl>
-                                          <p:spTgt spid="395"/>
+                                          <p:spTgt spid="398"/>
                                         </p:tgtEl>
                                         <p:attrNameLst>
                                           <p:attrName>style.visibility</p:attrName>
@@ -25488,7 +25617,7 @@
                                       <p:cBhvr>
                                         <p:cTn id="127" dur="350"/>
                                         <p:tgtEl>
-                                          <p:spTgt spid="395"/>
+                                          <p:spTgt spid="398"/>
                                         </p:tgtEl>
                                       </p:cBhvr>
                                     </p:animEffect>
@@ -25518,7 +25647,7 @@
                                           </p:stCondLst>
                                         </p:cTn>
                                         <p:tgtEl>
-                                          <p:spTgt spid="429"/>
+                                          <p:spTgt spid="432"/>
                                         </p:tgtEl>
                                         <p:attrNameLst>
                                           <p:attrName>style.visibility</p:attrName>
@@ -25532,7 +25661,7 @@
                                       <p:cBhvr>
                                         <p:cTn id="131" dur="600"/>
                                         <p:tgtEl>
-                                          <p:spTgt spid="429"/>
+                                          <p:spTgt spid="432"/>
                                         </p:tgtEl>
                                       </p:cBhvr>
                                     </p:animEffect>
@@ -25567,7 +25696,7 @@
                                       <p:cBhvr>
                                         <p:cTn id="135" dur="250"/>
                                         <p:tgtEl>
-                                          <p:spTgt spid="395"/>
+                                          <p:spTgt spid="398"/>
                                         </p:tgtEl>
                                       </p:cBhvr>
                                     </p:animEffect>
@@ -25579,7 +25708,7 @@
                                           </p:stCondLst>
                                         </p:cTn>
                                         <p:tgtEl>
-                                          <p:spTgt spid="395"/>
+                                          <p:spTgt spid="398"/>
                                         </p:tgtEl>
                                         <p:attrNameLst>
                                           <p:attrName>style.visibility</p:attrName>
@@ -25602,7 +25731,7 @@
                                       <p:cBhvr>
                                         <p:cTn id="138" dur="250"/>
                                         <p:tgtEl>
-                                          <p:spTgt spid="429"/>
+                                          <p:spTgt spid="432"/>
                                         </p:tgtEl>
                                       </p:cBhvr>
                                     </p:animEffect>
@@ -25614,7 +25743,7 @@
                                           </p:stCondLst>
                                         </p:cTn>
                                         <p:tgtEl>
-                                          <p:spTgt spid="429"/>
+                                          <p:spTgt spid="432"/>
                                         </p:tgtEl>
                                         <p:attrNameLst>
                                           <p:attrName>style.visibility</p:attrName>
@@ -25641,7 +25770,7 @@
                                           </p:stCondLst>
                                         </p:cTn>
                                         <p:tgtEl>
-                                          <p:spTgt spid="435"/>
+                                          <p:spTgt spid="438"/>
                                         </p:tgtEl>
                                         <p:attrNameLst>
                                           <p:attrName>style.visibility</p:attrName>
@@ -25655,7 +25784,7 @@
                                       <p:cBhvr>
                                         <p:cTn id="142" dur="350"/>
                                         <p:tgtEl>
-                                          <p:spTgt spid="435"/>
+                                          <p:spTgt spid="438"/>
                                         </p:tgtEl>
                                       </p:cBhvr>
                                     </p:animEffect>
@@ -25685,7 +25814,7 @@
                                           </p:stCondLst>
                                         </p:cTn>
                                         <p:tgtEl>
-                                          <p:spTgt spid="457"/>
+                                          <p:spTgt spid="460"/>
                                         </p:tgtEl>
                                         <p:attrNameLst>
                                           <p:attrName>style.visibility</p:attrName>
@@ -25699,7 +25828,7 @@
                                       <p:cBhvr>
                                         <p:cTn id="146" dur="600"/>
                                         <p:tgtEl>
-                                          <p:spTgt spid="457"/>
+                                          <p:spTgt spid="460"/>
                                         </p:tgtEl>
                                       </p:cBhvr>
                                     </p:animEffect>
@@ -25734,7 +25863,7 @@
                                       <p:cBhvr>
                                         <p:cTn id="150" dur="250"/>
                                         <p:tgtEl>
-                                          <p:spTgt spid="435"/>
+                                          <p:spTgt spid="438"/>
                                         </p:tgtEl>
                                       </p:cBhvr>
                                     </p:animEffect>
@@ -25746,7 +25875,7 @@
                                           </p:stCondLst>
                                         </p:cTn>
                                         <p:tgtEl>
-                                          <p:spTgt spid="435"/>
+                                          <p:spTgt spid="438"/>
                                         </p:tgtEl>
                                         <p:attrNameLst>
                                           <p:attrName>style.visibility</p:attrName>
@@ -25769,7 +25898,7 @@
                                       <p:cBhvr>
                                         <p:cTn id="153" dur="250"/>
                                         <p:tgtEl>
-                                          <p:spTgt spid="457"/>
+                                          <p:spTgt spid="460"/>
                                         </p:tgtEl>
                                       </p:cBhvr>
                                     </p:animEffect>
@@ -25781,7 +25910,7 @@
                                           </p:stCondLst>
                                         </p:cTn>
                                         <p:tgtEl>
-                                          <p:spTgt spid="457"/>
+                                          <p:spTgt spid="460"/>
                                         </p:tgtEl>
                                         <p:attrNameLst>
                                           <p:attrName>style.visibility</p:attrName>
@@ -25808,7 +25937,7 @@
                                           </p:stCondLst>
                                         </p:cTn>
                                         <p:tgtEl>
-                                          <p:spTgt spid="463"/>
+                                          <p:spTgt spid="466"/>
                                         </p:tgtEl>
                                         <p:attrNameLst>
                                           <p:attrName>style.visibility</p:attrName>
@@ -25822,7 +25951,7 @@
                                       <p:cBhvr>
                                         <p:cTn id="157" dur="350"/>
                                         <p:tgtEl>
-                                          <p:spTgt spid="463"/>
+                                          <p:spTgt spid="466"/>
                                         </p:tgtEl>
                                       </p:cBhvr>
                                     </p:animEffect>
@@ -25852,7 +25981,7 @@
                                           </p:stCondLst>
                                         </p:cTn>
                                         <p:tgtEl>
-                                          <p:spTgt spid="483"/>
+                                          <p:spTgt spid="486"/>
                                         </p:tgtEl>
                                         <p:attrNameLst>
                                           <p:attrName>style.visibility</p:attrName>
@@ -25866,7 +25995,7 @@
                                       <p:cBhvr>
                                         <p:cTn id="161" dur="600"/>
                                         <p:tgtEl>
-                                          <p:spTgt spid="483"/>
+                                          <p:spTgt spid="486"/>
                                         </p:tgtEl>
                                       </p:cBhvr>
                                     </p:animEffect>
@@ -25901,7 +26030,7 @@
                                       <p:cBhvr>
                                         <p:cTn id="165" dur="250"/>
                                         <p:tgtEl>
-                                          <p:spTgt spid="463"/>
+                                          <p:spTgt spid="466"/>
                                         </p:tgtEl>
                                       </p:cBhvr>
                                     </p:animEffect>
@@ -25913,7 +26042,7 @@
                                           </p:stCondLst>
                                         </p:cTn>
                                         <p:tgtEl>
-                                          <p:spTgt spid="463"/>
+                                          <p:spTgt spid="466"/>
                                         </p:tgtEl>
                                         <p:attrNameLst>
                                           <p:attrName>style.visibility</p:attrName>
@@ -25936,7 +26065,7 @@
                                       <p:cBhvr>
                                         <p:cTn id="168" dur="250"/>
                                         <p:tgtEl>
-                                          <p:spTgt spid="483"/>
+                                          <p:spTgt spid="486"/>
                                         </p:tgtEl>
                                       </p:cBhvr>
                                     </p:animEffect>
@@ -25948,7 +26077,7 @@
                                           </p:stCondLst>
                                         </p:cTn>
                                         <p:tgtEl>
-                                          <p:spTgt spid="483"/>
+                                          <p:spTgt spid="486"/>
                                         </p:tgtEl>
                                         <p:attrNameLst>
                                           <p:attrName>style.visibility</p:attrName>
@@ -25975,7 +26104,7 @@
                                           </p:stCondLst>
                                         </p:cTn>
                                         <p:tgtEl>
-                                          <p:spTgt spid="489"/>
+                                          <p:spTgt spid="492"/>
                                         </p:tgtEl>
                                         <p:attrNameLst>
                                           <p:attrName>style.visibility</p:attrName>
@@ -25989,7 +26118,7 @@
                                       <p:cBhvr>
                                         <p:cTn id="172" dur="350"/>
                                         <p:tgtEl>
-                                          <p:spTgt spid="489"/>
+                                          <p:spTgt spid="492"/>
                                         </p:tgtEl>
                                       </p:cBhvr>
                                     </p:animEffect>
@@ -26019,7 +26148,7 @@
                                           </p:stCondLst>
                                         </p:cTn>
                                         <p:tgtEl>
-                                          <p:spTgt spid="505"/>
+                                          <p:spTgt spid="508"/>
                                         </p:tgtEl>
                                         <p:attrNameLst>
                                           <p:attrName>style.visibility</p:attrName>
@@ -26033,7 +26162,7 @@
                                       <p:cBhvr>
                                         <p:cTn id="176" dur="600"/>
                                         <p:tgtEl>
-                                          <p:spTgt spid="505"/>
+                                          <p:spTgt spid="508"/>
                                         </p:tgtEl>
                                       </p:cBhvr>
                                     </p:animEffect>
@@ -26068,7 +26197,7 @@
                                       <p:cBhvr>
                                         <p:cTn id="180" dur="250"/>
                                         <p:tgtEl>
-                                          <p:spTgt spid="489"/>
+                                          <p:spTgt spid="492"/>
                                         </p:tgtEl>
                                       </p:cBhvr>
                                     </p:animEffect>
@@ -26080,7 +26209,7 @@
                                           </p:stCondLst>
                                         </p:cTn>
                                         <p:tgtEl>
-                                          <p:spTgt spid="489"/>
+                                          <p:spTgt spid="492"/>
                                         </p:tgtEl>
                                         <p:attrNameLst>
                                           <p:attrName>style.visibility</p:attrName>
@@ -26103,7 +26232,7 @@
                                       <p:cBhvr>
                                         <p:cTn id="183" dur="250"/>
                                         <p:tgtEl>
-                                          <p:spTgt spid="505"/>
+                                          <p:spTgt spid="508"/>
                                         </p:tgtEl>
                                       </p:cBhvr>
                                     </p:animEffect>
@@ -26115,7 +26244,7 @@
                                           </p:stCondLst>
                                         </p:cTn>
                                         <p:tgtEl>
-                                          <p:spTgt spid="505"/>
+                                          <p:spTgt spid="508"/>
                                         </p:tgtEl>
                                         <p:attrNameLst>
                                           <p:attrName>style.visibility</p:attrName>
@@ -26142,7 +26271,7 @@
                                           </p:stCondLst>
                                         </p:cTn>
                                         <p:tgtEl>
-                                          <p:spTgt spid="507"/>
+                                          <p:spTgt spid="510"/>
                                         </p:tgtEl>
                                         <p:attrNameLst>
                                           <p:attrName>style.visibility</p:attrName>
@@ -26156,7 +26285,7 @@
                                       <p:cBhvr>
                                         <p:cTn id="187" dur="350"/>
                                         <p:tgtEl>
-                                          <p:spTgt spid="507"/>
+                                          <p:spTgt spid="510"/>
                                         </p:tgtEl>
                                       </p:cBhvr>
                                     </p:animEffect>
@@ -26191,7 +26320,7 @@
                                       <p:cBhvr>
                                         <p:cTn id="191" dur="250"/>
                                         <p:tgtEl>
-                                          <p:spTgt spid="507"/>
+                                          <p:spTgt spid="510"/>
                                         </p:tgtEl>
                                       </p:cBhvr>
                                     </p:animEffect>
@@ -26203,7 +26332,7 @@
                                           </p:stCondLst>
                                         </p:cTn>
                                         <p:tgtEl>
-                                          <p:spTgt spid="507"/>
+                                          <p:spTgt spid="510"/>
                                         </p:tgtEl>
                                         <p:attrNameLst>
                                           <p:attrName>style.visibility</p:attrName>

</xml_diff>

<commit_message>
Slide 4: evals clicks highlight the EVALS tags on the run strip, with a scoring note
Co-Authored-By: Claude Opus 5.5 <noreply@anthropic.com>
Claude-Session: https://claude.ai/code/session_01Hf94kqMzSofkkrQm7kpNba
</commit_message>
<xml_diff>
--- a/poc/deck/assets/review/Slide 4 interactive - test.pptx
+++ b/poc/deck/assets/review/Slide 4 interactive - test.pptx
@@ -1459,7 +1459,7 @@
           <a:p/>
           <a:p>
             <a:r>
-              <a:t>[CLICK 5  Evals: pass] Every output is scored before it moves on. A pass goes to the gate, with the evidence.</a:t>
+              <a:t>[CLICK 5  Evals: pass] Every output is scored before it moves on. Look at the EVALS tags along the bottom: each agent step is evaluated and its score updated, run by run. A pass goes to the gate, with the evidence.</a:t>
             </a:r>
           </a:p>
           <a:p/>
@@ -15508,9 +15508,9 @@
         <p:grpSpPr>
           <a:xfrm>
             <a:off x="365760" y="1115568"/>
-            <a:ext cx="11457432" cy="5239512"/>
+            <a:ext cx="11457432" cy="5239511"/>
             <a:chOff x="365760" y="1115568"/>
-            <a:chExt cx="11457432" cy="5239512"/>
+            <a:chExt cx="11457432" cy="5239511"/>
           </a:xfrm>
         </p:grpSpPr>
         <p:sp>
@@ -15654,7 +15654,7 @@
           <p:spPr>
             <a:xfrm>
               <a:off x="365760" y="4498848"/>
-              <a:ext cx="11457432" cy="1856232"/>
+              <a:ext cx="11457432" cy="1426464"/>
             </a:xfrm>
             <a:prstGeom prst="rect">
               <a:avLst/>
@@ -15692,6 +15692,314 @@
         <p:sp>
           <p:nvSpPr>
             <p:cNvPr id="313" name="Shape 5"/>
+            <p:cNvSpPr/>
+            <p:nvPr/>
+          </p:nvSpPr>
+          <p:spPr>
+            <a:xfrm>
+              <a:off x="365760" y="5925312"/>
+              <a:ext cx="9198864" cy="9143"/>
+            </a:xfrm>
+            <a:prstGeom prst="rect">
+              <a:avLst/>
+            </a:prstGeom>
+            <a:solidFill>
+              <a:srgbClr val="FFFFFF">
+                <a:alpha val="72000"/>
+              </a:srgbClr>
+            </a:solidFill>
+            <a:ln>
+              <a:noFill/>
+            </a:ln>
+            <a:effectLst/>
+          </p:spPr>
+          <p:style>
+            <a:lnRef idx="1">
+              <a:schemeClr val="accent1"/>
+            </a:lnRef>
+            <a:fillRef idx="3">
+              <a:schemeClr val="accent1"/>
+            </a:fillRef>
+            <a:effectRef idx="2">
+              <a:schemeClr val="accent1"/>
+            </a:effectRef>
+            <a:fontRef idx="minor">
+              <a:schemeClr val="lt1"/>
+            </a:fontRef>
+          </p:style>
+          <p:txBody>
+            <a:bodyPr rtlCol="0" anchor="ctr"/>
+            <a:lstStyle/>
+            <a:p/>
+          </p:txBody>
+        </p:sp>
+        <p:sp>
+          <p:nvSpPr>
+            <p:cNvPr id="314" name="Shape 6"/>
+            <p:cNvSpPr/>
+            <p:nvPr/>
+          </p:nvSpPr>
+          <p:spPr>
+            <a:xfrm>
+              <a:off x="11786616" y="5925312"/>
+              <a:ext cx="36575" cy="9143"/>
+            </a:xfrm>
+            <a:prstGeom prst="rect">
+              <a:avLst/>
+            </a:prstGeom>
+            <a:solidFill>
+              <a:srgbClr val="FFFFFF">
+                <a:alpha val="72000"/>
+              </a:srgbClr>
+            </a:solidFill>
+            <a:ln>
+              <a:noFill/>
+            </a:ln>
+            <a:effectLst/>
+          </p:spPr>
+          <p:style>
+            <a:lnRef idx="1">
+              <a:schemeClr val="accent1"/>
+            </a:lnRef>
+            <a:fillRef idx="3">
+              <a:schemeClr val="accent1"/>
+            </a:fillRef>
+            <a:effectRef idx="2">
+              <a:schemeClr val="accent1"/>
+            </a:effectRef>
+            <a:fontRef idx="minor">
+              <a:schemeClr val="lt1"/>
+            </a:fontRef>
+          </p:style>
+          <p:txBody>
+            <a:bodyPr rtlCol="0" anchor="ctr"/>
+            <a:lstStyle/>
+            <a:p/>
+          </p:txBody>
+        </p:sp>
+        <p:sp>
+          <p:nvSpPr>
+            <p:cNvPr id="315" name="Shape 7"/>
+            <p:cNvSpPr/>
+            <p:nvPr/>
+          </p:nvSpPr>
+          <p:spPr>
+            <a:xfrm>
+              <a:off x="365760" y="5934456"/>
+              <a:ext cx="1005840" cy="246887"/>
+            </a:xfrm>
+            <a:prstGeom prst="rect">
+              <a:avLst/>
+            </a:prstGeom>
+            <a:solidFill>
+              <a:srgbClr val="FFFFFF">
+                <a:alpha val="72000"/>
+              </a:srgbClr>
+            </a:solidFill>
+            <a:ln>
+              <a:noFill/>
+            </a:ln>
+            <a:effectLst/>
+          </p:spPr>
+          <p:style>
+            <a:lnRef idx="1">
+              <a:schemeClr val="accent1"/>
+            </a:lnRef>
+            <a:fillRef idx="3">
+              <a:schemeClr val="accent1"/>
+            </a:fillRef>
+            <a:effectRef idx="2">
+              <a:schemeClr val="accent1"/>
+            </a:effectRef>
+            <a:fontRef idx="minor">
+              <a:schemeClr val="lt1"/>
+            </a:fontRef>
+          </p:style>
+          <p:txBody>
+            <a:bodyPr rtlCol="0" anchor="ctr"/>
+            <a:lstStyle/>
+            <a:p/>
+          </p:txBody>
+        </p:sp>
+        <p:sp>
+          <p:nvSpPr>
+            <p:cNvPr id="316" name="Shape 8"/>
+            <p:cNvSpPr/>
+            <p:nvPr/>
+          </p:nvSpPr>
+          <p:spPr>
+            <a:xfrm>
+              <a:off x="11786616" y="5934456"/>
+              <a:ext cx="36575" cy="246887"/>
+            </a:xfrm>
+            <a:prstGeom prst="rect">
+              <a:avLst/>
+            </a:prstGeom>
+            <a:solidFill>
+              <a:srgbClr val="FFFFFF">
+                <a:alpha val="72000"/>
+              </a:srgbClr>
+            </a:solidFill>
+            <a:ln>
+              <a:noFill/>
+            </a:ln>
+            <a:effectLst/>
+          </p:spPr>
+          <p:style>
+            <a:lnRef idx="1">
+              <a:schemeClr val="accent1"/>
+            </a:lnRef>
+            <a:fillRef idx="3">
+              <a:schemeClr val="accent1"/>
+            </a:fillRef>
+            <a:effectRef idx="2">
+              <a:schemeClr val="accent1"/>
+            </a:effectRef>
+            <a:fontRef idx="minor">
+              <a:schemeClr val="lt1"/>
+            </a:fontRef>
+          </p:style>
+          <p:txBody>
+            <a:bodyPr rtlCol="0" anchor="ctr"/>
+            <a:lstStyle/>
+            <a:p/>
+          </p:txBody>
+        </p:sp>
+        <p:sp>
+          <p:nvSpPr>
+            <p:cNvPr id="317" name="Shape 9"/>
+            <p:cNvSpPr/>
+            <p:nvPr/>
+          </p:nvSpPr>
+          <p:spPr>
+            <a:xfrm>
+              <a:off x="365760" y="6181344"/>
+              <a:ext cx="1005840" cy="0"/>
+            </a:xfrm>
+            <a:prstGeom prst="rect">
+              <a:avLst/>
+            </a:prstGeom>
+            <a:solidFill>
+              <a:srgbClr val="FFFFFF">
+                <a:alpha val="72000"/>
+              </a:srgbClr>
+            </a:solidFill>
+            <a:ln>
+              <a:noFill/>
+            </a:ln>
+            <a:effectLst/>
+          </p:spPr>
+          <p:style>
+            <a:lnRef idx="1">
+              <a:schemeClr val="accent1"/>
+            </a:lnRef>
+            <a:fillRef idx="3">
+              <a:schemeClr val="accent1"/>
+            </a:fillRef>
+            <a:effectRef idx="2">
+              <a:schemeClr val="accent1"/>
+            </a:effectRef>
+            <a:fontRef idx="minor">
+              <a:schemeClr val="lt1"/>
+            </a:fontRef>
+          </p:style>
+          <p:txBody>
+            <a:bodyPr rtlCol="0" anchor="ctr"/>
+            <a:lstStyle/>
+            <a:p/>
+          </p:txBody>
+        </p:sp>
+        <p:sp>
+          <p:nvSpPr>
+            <p:cNvPr id="318" name="Shape 10"/>
+            <p:cNvSpPr/>
+            <p:nvPr/>
+          </p:nvSpPr>
+          <p:spPr>
+            <a:xfrm>
+              <a:off x="11786616" y="6181344"/>
+              <a:ext cx="36575" cy="0"/>
+            </a:xfrm>
+            <a:prstGeom prst="rect">
+              <a:avLst/>
+            </a:prstGeom>
+            <a:solidFill>
+              <a:srgbClr val="FFFFFF">
+                <a:alpha val="72000"/>
+              </a:srgbClr>
+            </a:solidFill>
+            <a:ln>
+              <a:noFill/>
+            </a:ln>
+            <a:effectLst/>
+          </p:spPr>
+          <p:style>
+            <a:lnRef idx="1">
+              <a:schemeClr val="accent1"/>
+            </a:lnRef>
+            <a:fillRef idx="3">
+              <a:schemeClr val="accent1"/>
+            </a:fillRef>
+            <a:effectRef idx="2">
+              <a:schemeClr val="accent1"/>
+            </a:effectRef>
+            <a:fontRef idx="minor">
+              <a:schemeClr val="lt1"/>
+            </a:fontRef>
+          </p:style>
+          <p:txBody>
+            <a:bodyPr rtlCol="0" anchor="ctr"/>
+            <a:lstStyle/>
+            <a:p/>
+          </p:txBody>
+        </p:sp>
+        <p:sp>
+          <p:nvSpPr>
+            <p:cNvPr id="319" name="Shape 11"/>
+            <p:cNvSpPr/>
+            <p:nvPr/>
+          </p:nvSpPr>
+          <p:spPr>
+            <a:xfrm>
+              <a:off x="365760" y="6181344"/>
+              <a:ext cx="11457432" cy="173735"/>
+            </a:xfrm>
+            <a:prstGeom prst="rect">
+              <a:avLst/>
+            </a:prstGeom>
+            <a:solidFill>
+              <a:srgbClr val="FFFFFF">
+                <a:alpha val="72000"/>
+              </a:srgbClr>
+            </a:solidFill>
+            <a:ln>
+              <a:noFill/>
+            </a:ln>
+            <a:effectLst/>
+          </p:spPr>
+          <p:style>
+            <a:lnRef idx="1">
+              <a:schemeClr val="accent1"/>
+            </a:lnRef>
+            <a:fillRef idx="3">
+              <a:schemeClr val="accent1"/>
+            </a:fillRef>
+            <a:effectRef idx="2">
+              <a:schemeClr val="accent1"/>
+            </a:effectRef>
+            <a:fontRef idx="minor">
+              <a:schemeClr val="lt1"/>
+            </a:fontRef>
+          </p:style>
+          <p:txBody>
+            <a:bodyPr rtlCol="0" anchor="ctr"/>
+            <a:lstStyle/>
+            <a:p/>
+          </p:txBody>
+        </p:sp>
+        <p:sp>
+          <p:nvSpPr>
+            <p:cNvPr id="320" name="Shape 12"/>
             <p:cNvSpPr/>
             <p:nvPr/>
           </p:nvSpPr>
@@ -15735,7 +16043,7 @@
         </p:sp>
         <p:sp>
           <p:nvSpPr>
-            <p:cNvPr id="314" name="Shape 6"/>
+            <p:cNvPr id="321" name="Shape 13"/>
             <p:cNvSpPr/>
             <p:nvPr/>
           </p:nvSpPr>
@@ -15779,7 +16087,271 @@
         </p:sp>
         <p:sp>
           <p:nvSpPr>
-            <p:cNvPr id="315" name="Shape 7"/>
+            <p:cNvPr id="322" name="Shape 14"/>
+            <p:cNvSpPr/>
+            <p:nvPr/>
+          </p:nvSpPr>
+          <p:spPr>
+            <a:xfrm>
+              <a:off x="1517904" y="5943600"/>
+              <a:ext cx="493776" cy="219456"/>
+            </a:xfrm>
+            <a:prstGeom prst="roundRect">
+              <a:avLst>
+                <a:gd name="adj" fmla="val 8000"/>
+              </a:avLst>
+            </a:prstGeom>
+            <a:noFill/>
+            <a:ln w="38100">
+              <a:solidFill>
+                <a:srgbClr val="FA8B35"/>
+              </a:solidFill>
+            </a:ln>
+            <a:effectLst/>
+          </p:spPr>
+          <p:style>
+            <a:lnRef idx="1">
+              <a:schemeClr val="accent1"/>
+            </a:lnRef>
+            <a:fillRef idx="3">
+              <a:schemeClr val="accent1"/>
+            </a:fillRef>
+            <a:effectRef idx="2">
+              <a:schemeClr val="accent1"/>
+            </a:effectRef>
+            <a:fontRef idx="minor">
+              <a:schemeClr val="lt1"/>
+            </a:fontRef>
+          </p:style>
+          <p:txBody>
+            <a:bodyPr rtlCol="0" anchor="ctr"/>
+            <a:lstStyle/>
+            <a:p/>
+          </p:txBody>
+        </p:sp>
+        <p:sp>
+          <p:nvSpPr>
+            <p:cNvPr id="323" name="Shape 15"/>
+            <p:cNvSpPr/>
+            <p:nvPr/>
+          </p:nvSpPr>
+          <p:spPr>
+            <a:xfrm>
+              <a:off x="2999232" y="5943600"/>
+              <a:ext cx="493776" cy="219456"/>
+            </a:xfrm>
+            <a:prstGeom prst="roundRect">
+              <a:avLst>
+                <a:gd name="adj" fmla="val 8000"/>
+              </a:avLst>
+            </a:prstGeom>
+            <a:noFill/>
+            <a:ln w="38100">
+              <a:solidFill>
+                <a:srgbClr val="FA8B35"/>
+              </a:solidFill>
+            </a:ln>
+            <a:effectLst/>
+          </p:spPr>
+          <p:style>
+            <a:lnRef idx="1">
+              <a:schemeClr val="accent1"/>
+            </a:lnRef>
+            <a:fillRef idx="3">
+              <a:schemeClr val="accent1"/>
+            </a:fillRef>
+            <a:effectRef idx="2">
+              <a:schemeClr val="accent1"/>
+            </a:effectRef>
+            <a:fontRef idx="minor">
+              <a:schemeClr val="lt1"/>
+            </a:fontRef>
+          </p:style>
+          <p:txBody>
+            <a:bodyPr rtlCol="0" anchor="ctr"/>
+            <a:lstStyle/>
+            <a:p/>
+          </p:txBody>
+        </p:sp>
+        <p:sp>
+          <p:nvSpPr>
+            <p:cNvPr id="324" name="Shape 16"/>
+            <p:cNvSpPr/>
+            <p:nvPr/>
+          </p:nvSpPr>
+          <p:spPr>
+            <a:xfrm>
+              <a:off x="4480560" y="5943600"/>
+              <a:ext cx="493776" cy="219456"/>
+            </a:xfrm>
+            <a:prstGeom prst="roundRect">
+              <a:avLst>
+                <a:gd name="adj" fmla="val 8000"/>
+              </a:avLst>
+            </a:prstGeom>
+            <a:noFill/>
+            <a:ln w="38100">
+              <a:solidFill>
+                <a:srgbClr val="FA8B35"/>
+              </a:solidFill>
+            </a:ln>
+            <a:effectLst/>
+          </p:spPr>
+          <p:style>
+            <a:lnRef idx="1">
+              <a:schemeClr val="accent1"/>
+            </a:lnRef>
+            <a:fillRef idx="3">
+              <a:schemeClr val="accent1"/>
+            </a:fillRef>
+            <a:effectRef idx="2">
+              <a:schemeClr val="accent1"/>
+            </a:effectRef>
+            <a:fontRef idx="minor">
+              <a:schemeClr val="lt1"/>
+            </a:fontRef>
+          </p:style>
+          <p:txBody>
+            <a:bodyPr rtlCol="0" anchor="ctr"/>
+            <a:lstStyle/>
+            <a:p/>
+          </p:txBody>
+        </p:sp>
+        <p:sp>
+          <p:nvSpPr>
+            <p:cNvPr id="325" name="Shape 17"/>
+            <p:cNvSpPr/>
+            <p:nvPr/>
+          </p:nvSpPr>
+          <p:spPr>
+            <a:xfrm>
+              <a:off x="5221224" y="5943600"/>
+              <a:ext cx="493776" cy="219456"/>
+            </a:xfrm>
+            <a:prstGeom prst="roundRect">
+              <a:avLst>
+                <a:gd name="adj" fmla="val 8000"/>
+              </a:avLst>
+            </a:prstGeom>
+            <a:noFill/>
+            <a:ln w="38100">
+              <a:solidFill>
+                <a:srgbClr val="FA8B35"/>
+              </a:solidFill>
+            </a:ln>
+            <a:effectLst/>
+          </p:spPr>
+          <p:style>
+            <a:lnRef idx="1">
+              <a:schemeClr val="accent1"/>
+            </a:lnRef>
+            <a:fillRef idx="3">
+              <a:schemeClr val="accent1"/>
+            </a:fillRef>
+            <a:effectRef idx="2">
+              <a:schemeClr val="accent1"/>
+            </a:effectRef>
+            <a:fontRef idx="minor">
+              <a:schemeClr val="lt1"/>
+            </a:fontRef>
+          </p:style>
+          <p:txBody>
+            <a:bodyPr rtlCol="0" anchor="ctr"/>
+            <a:lstStyle/>
+            <a:p/>
+          </p:txBody>
+        </p:sp>
+        <p:sp>
+          <p:nvSpPr>
+            <p:cNvPr id="326" name="Shape 18"/>
+            <p:cNvSpPr/>
+            <p:nvPr/>
+          </p:nvSpPr>
+          <p:spPr>
+            <a:xfrm>
+              <a:off x="6702552" y="5943600"/>
+              <a:ext cx="493776" cy="219456"/>
+            </a:xfrm>
+            <a:prstGeom prst="roundRect">
+              <a:avLst>
+                <a:gd name="adj" fmla="val 8000"/>
+              </a:avLst>
+            </a:prstGeom>
+            <a:noFill/>
+            <a:ln w="38100">
+              <a:solidFill>
+                <a:srgbClr val="FA8B35"/>
+              </a:solidFill>
+            </a:ln>
+            <a:effectLst/>
+          </p:spPr>
+          <p:style>
+            <a:lnRef idx="1">
+              <a:schemeClr val="accent1"/>
+            </a:lnRef>
+            <a:fillRef idx="3">
+              <a:schemeClr val="accent1"/>
+            </a:fillRef>
+            <a:effectRef idx="2">
+              <a:schemeClr val="accent1"/>
+            </a:effectRef>
+            <a:fontRef idx="minor">
+              <a:schemeClr val="lt1"/>
+            </a:fontRef>
+          </p:style>
+          <p:txBody>
+            <a:bodyPr rtlCol="0" anchor="ctr"/>
+            <a:lstStyle/>
+            <a:p/>
+          </p:txBody>
+        </p:sp>
+        <p:sp>
+          <p:nvSpPr>
+            <p:cNvPr id="327" name="Shape 19"/>
+            <p:cNvSpPr/>
+            <p:nvPr/>
+          </p:nvSpPr>
+          <p:spPr>
+            <a:xfrm>
+              <a:off x="8924544" y="5943600"/>
+              <a:ext cx="493776" cy="219456"/>
+            </a:xfrm>
+            <a:prstGeom prst="roundRect">
+              <a:avLst>
+                <a:gd name="adj" fmla="val 8000"/>
+              </a:avLst>
+            </a:prstGeom>
+            <a:noFill/>
+            <a:ln w="38100">
+              <a:solidFill>
+                <a:srgbClr val="FA8B35"/>
+              </a:solidFill>
+            </a:ln>
+            <a:effectLst/>
+          </p:spPr>
+          <p:style>
+            <a:lnRef idx="1">
+              <a:schemeClr val="accent1"/>
+            </a:lnRef>
+            <a:fillRef idx="3">
+              <a:schemeClr val="accent1"/>
+            </a:fillRef>
+            <a:effectRef idx="2">
+              <a:schemeClr val="accent1"/>
+            </a:effectRef>
+            <a:fontRef idx="minor">
+              <a:schemeClr val="lt1"/>
+            </a:fontRef>
+          </p:style>
+          <p:txBody>
+            <a:bodyPr rtlCol="0" anchor="ctr"/>
+            <a:lstStyle/>
+            <a:p/>
+          </p:txBody>
+        </p:sp>
+        <p:sp>
+          <p:nvSpPr>
+            <p:cNvPr id="328" name="Shape 20"/>
             <p:cNvSpPr/>
             <p:nvPr/>
           </p:nvSpPr>
@@ -15825,7 +16397,7 @@
         </p:sp>
         <p:sp>
           <p:nvSpPr>
-            <p:cNvPr id="316" name="Text 8"/>
+            <p:cNvPr id="329" name="Text 21"/>
             <p:cNvSpPr txBox="1"/>
             <p:nvPr/>
           </p:nvSpPr>
@@ -15882,7 +16454,7 @@
                   </a:solidFill>
                   <a:latin typeface="Trenda IG Text"/>
                 </a:rPr>
-                <a:t>Every output is scored before it moves on: does the journey match the brief, is every field real, are consent and STOP checks in place. A pass goes to the gate with the evidence.</a:t>
+                <a:t>Every output is scored before it moves on: does the journey match the brief, is every field real, are consent and STOP checks in place. Each step is evaluated and its score updated (the EVALS tags below); a pass goes to the gate with the evidence.</a:t>
               </a:r>
             </a:p>
           </p:txBody>
@@ -15890,21 +16462,21 @@
       </p:grpSp>
       <p:grpSp>
         <p:nvGrpSpPr>
-          <p:cNvPr id="317" name="Step 5 arrows"/>
+          <p:cNvPr id="330" name="Step 5 arrows"/>
           <p:cNvGrpSpPr/>
           <p:nvPr/>
         </p:nvGrpSpPr>
         <p:grpSpPr>
           <a:xfrm>
             <a:off x="4069080" y="3685032"/>
-            <a:ext cx="1801368" cy="484631"/>
+            <a:ext cx="7680960" cy="2459736"/>
             <a:chOff x="4069080" y="3685032"/>
-            <a:chExt cx="1801368" cy="484631"/>
+            <a:chExt cx="7680960" cy="2459736"/>
           </a:xfrm>
         </p:grpSpPr>
         <p:cxnSp>
           <p:nvCxnSpPr>
-            <p:cNvPr id="318" name="Arrow 1"/>
+            <p:cNvPr id="331" name="Arrow 1"/>
             <p:cNvCxnSpPr/>
             <p:nvPr/>
           </p:nvCxnSpPr>
@@ -15940,7 +16512,7 @@
         </p:cxnSp>
         <p:cxnSp>
           <p:nvCxnSpPr>
-            <p:cNvPr id="319" name="Arrow 2"/>
+            <p:cNvPr id="332" name="Arrow 2"/>
             <p:cNvCxnSpPr/>
             <p:nvPr/>
           </p:nvCxnSpPr>
@@ -15976,7 +16548,7 @@
         </p:cxnSp>
         <p:sp>
           <p:nvSpPr>
-            <p:cNvPr id="320" name="Shape 3"/>
+            <p:cNvPr id="333" name="Shape 3"/>
             <p:cNvSpPr/>
             <p:nvPr/>
           </p:nvSpPr>
@@ -16020,7 +16592,7 @@
         </p:sp>
         <p:sp>
           <p:nvSpPr>
-            <p:cNvPr id="321" name="Text 4"/>
+            <p:cNvPr id="334" name="Text 4"/>
             <p:cNvSpPr txBox="1"/>
             <p:nvPr/>
           </p:nvSpPr>
@@ -16053,24 +16625,103 @@
             </a:p>
           </p:txBody>
         </p:sp>
+        <p:sp>
+          <p:nvSpPr>
+            <p:cNvPr id="335" name="Shape 5"/>
+            <p:cNvSpPr/>
+            <p:nvPr/>
+          </p:nvSpPr>
+          <p:spPr>
+            <a:xfrm>
+              <a:off x="9601200" y="5961888"/>
+              <a:ext cx="2148840" cy="182880"/>
+            </a:xfrm>
+            <a:prstGeom prst="roundRect">
+              <a:avLst>
+                <a:gd name="adj" fmla="val 50000"/>
+              </a:avLst>
+            </a:prstGeom>
+            <a:solidFill>
+              <a:srgbClr val="000000"/>
+            </a:solidFill>
+            <a:ln>
+              <a:noFill/>
+            </a:ln>
+            <a:effectLst/>
+          </p:spPr>
+          <p:style>
+            <a:lnRef idx="1">
+              <a:schemeClr val="accent1"/>
+            </a:lnRef>
+            <a:fillRef idx="3">
+              <a:schemeClr val="accent1"/>
+            </a:fillRef>
+            <a:effectRef idx="2">
+              <a:schemeClr val="accent1"/>
+            </a:effectRef>
+            <a:fontRef idx="minor">
+              <a:schemeClr val="lt1"/>
+            </a:fontRef>
+          </p:style>
+          <p:txBody>
+            <a:bodyPr rtlCol="0" anchor="ctr"/>
+            <a:lstStyle/>
+            <a:p/>
+          </p:txBody>
+        </p:sp>
+        <p:sp>
+          <p:nvSpPr>
+            <p:cNvPr id="336" name="Text 6"/>
+            <p:cNvSpPr txBox="1"/>
+            <p:nvPr/>
+          </p:nvSpPr>
+          <p:spPr>
+            <a:xfrm>
+              <a:off x="9601200" y="5961888"/>
+              <a:ext cx="2148840" cy="182880"/>
+            </a:xfrm>
+            <a:prstGeom prst="rect">
+              <a:avLst/>
+            </a:prstGeom>
+            <a:noFill/>
+          </p:spPr>
+          <p:txBody>
+            <a:bodyPr wrap="square" lIns="0" rIns="0" tIns="0" bIns="0" anchor="ctr">
+              <a:spAutoFit/>
+            </a:bodyPr>
+            <a:lstStyle/>
+            <a:p>
+              <a:pPr algn="ctr"/>
+              <a:r>
+                <a:rPr sz="650" b="1" i="0" spc="60">
+                  <a:solidFill>
+                    <a:srgbClr val="FFFFFF"/>
+                  </a:solidFill>
+                  <a:latin typeface="Trenda IG Text"/>
+                </a:rPr>
+                <a:t>EVERY STEP SCORED · SCORE UPDATED</a:t>
+              </a:r>
+            </a:p>
+          </p:txBody>
+        </p:sp>
       </p:grpSp>
       <p:grpSp>
         <p:nvGrpSpPr>
-          <p:cNvPr id="322" name="Step 6 highlight"/>
+          <p:cNvPr id="337" name="Step 6 highlight"/>
           <p:cNvGrpSpPr/>
           <p:nvPr/>
         </p:nvGrpSpPr>
         <p:grpSpPr>
           <a:xfrm>
             <a:off x="365760" y="1115568"/>
-            <a:ext cx="11457432" cy="5239512"/>
+            <a:ext cx="11457432" cy="5239511"/>
             <a:chOff x="365760" y="1115568"/>
-            <a:chExt cx="11457432" cy="5239512"/>
+            <a:chExt cx="11457432" cy="5239511"/>
           </a:xfrm>
         </p:grpSpPr>
         <p:sp>
           <p:nvSpPr>
-            <p:cNvPr id="323" name="Shape 1"/>
+            <p:cNvPr id="338" name="Shape 1"/>
             <p:cNvSpPr/>
             <p:nvPr/>
           </p:nvSpPr>
@@ -16114,7 +16765,7 @@
         </p:sp>
         <p:sp>
           <p:nvSpPr>
-            <p:cNvPr id="324" name="Shape 2"/>
+            <p:cNvPr id="339" name="Shape 2"/>
             <p:cNvSpPr/>
             <p:nvPr/>
           </p:nvSpPr>
@@ -16158,7 +16809,7 @@
         </p:sp>
         <p:sp>
           <p:nvSpPr>
-            <p:cNvPr id="325" name="Shape 3"/>
+            <p:cNvPr id="340" name="Shape 3"/>
             <p:cNvSpPr/>
             <p:nvPr/>
           </p:nvSpPr>
@@ -16202,14 +16853,14 @@
         </p:sp>
         <p:sp>
           <p:nvSpPr>
-            <p:cNvPr id="326" name="Shape 4"/>
+            <p:cNvPr id="341" name="Shape 4"/>
             <p:cNvSpPr/>
             <p:nvPr/>
           </p:nvSpPr>
           <p:spPr>
             <a:xfrm>
               <a:off x="365760" y="4498848"/>
-              <a:ext cx="11457432" cy="1856232"/>
+              <a:ext cx="11457432" cy="1426464"/>
             </a:xfrm>
             <a:prstGeom prst="rect">
               <a:avLst/>
@@ -16246,7 +16897,315 @@
         </p:sp>
         <p:sp>
           <p:nvSpPr>
-            <p:cNvPr id="327" name="Shape 5"/>
+            <p:cNvPr id="342" name="Shape 5"/>
+            <p:cNvSpPr/>
+            <p:nvPr/>
+          </p:nvSpPr>
+          <p:spPr>
+            <a:xfrm>
+              <a:off x="365760" y="5925312"/>
+              <a:ext cx="9198864" cy="9143"/>
+            </a:xfrm>
+            <a:prstGeom prst="rect">
+              <a:avLst/>
+            </a:prstGeom>
+            <a:solidFill>
+              <a:srgbClr val="FFFFFF">
+                <a:alpha val="72000"/>
+              </a:srgbClr>
+            </a:solidFill>
+            <a:ln>
+              <a:noFill/>
+            </a:ln>
+            <a:effectLst/>
+          </p:spPr>
+          <p:style>
+            <a:lnRef idx="1">
+              <a:schemeClr val="accent1"/>
+            </a:lnRef>
+            <a:fillRef idx="3">
+              <a:schemeClr val="accent1"/>
+            </a:fillRef>
+            <a:effectRef idx="2">
+              <a:schemeClr val="accent1"/>
+            </a:effectRef>
+            <a:fontRef idx="minor">
+              <a:schemeClr val="lt1"/>
+            </a:fontRef>
+          </p:style>
+          <p:txBody>
+            <a:bodyPr rtlCol="0" anchor="ctr"/>
+            <a:lstStyle/>
+            <a:p/>
+          </p:txBody>
+        </p:sp>
+        <p:sp>
+          <p:nvSpPr>
+            <p:cNvPr id="343" name="Shape 6"/>
+            <p:cNvSpPr/>
+            <p:nvPr/>
+          </p:nvSpPr>
+          <p:spPr>
+            <a:xfrm>
+              <a:off x="11786616" y="5925312"/>
+              <a:ext cx="36575" cy="9143"/>
+            </a:xfrm>
+            <a:prstGeom prst="rect">
+              <a:avLst/>
+            </a:prstGeom>
+            <a:solidFill>
+              <a:srgbClr val="FFFFFF">
+                <a:alpha val="72000"/>
+              </a:srgbClr>
+            </a:solidFill>
+            <a:ln>
+              <a:noFill/>
+            </a:ln>
+            <a:effectLst/>
+          </p:spPr>
+          <p:style>
+            <a:lnRef idx="1">
+              <a:schemeClr val="accent1"/>
+            </a:lnRef>
+            <a:fillRef idx="3">
+              <a:schemeClr val="accent1"/>
+            </a:fillRef>
+            <a:effectRef idx="2">
+              <a:schemeClr val="accent1"/>
+            </a:effectRef>
+            <a:fontRef idx="minor">
+              <a:schemeClr val="lt1"/>
+            </a:fontRef>
+          </p:style>
+          <p:txBody>
+            <a:bodyPr rtlCol="0" anchor="ctr"/>
+            <a:lstStyle/>
+            <a:p/>
+          </p:txBody>
+        </p:sp>
+        <p:sp>
+          <p:nvSpPr>
+            <p:cNvPr id="344" name="Shape 7"/>
+            <p:cNvSpPr/>
+            <p:nvPr/>
+          </p:nvSpPr>
+          <p:spPr>
+            <a:xfrm>
+              <a:off x="365760" y="5934456"/>
+              <a:ext cx="1005840" cy="246887"/>
+            </a:xfrm>
+            <a:prstGeom prst="rect">
+              <a:avLst/>
+            </a:prstGeom>
+            <a:solidFill>
+              <a:srgbClr val="FFFFFF">
+                <a:alpha val="72000"/>
+              </a:srgbClr>
+            </a:solidFill>
+            <a:ln>
+              <a:noFill/>
+            </a:ln>
+            <a:effectLst/>
+          </p:spPr>
+          <p:style>
+            <a:lnRef idx="1">
+              <a:schemeClr val="accent1"/>
+            </a:lnRef>
+            <a:fillRef idx="3">
+              <a:schemeClr val="accent1"/>
+            </a:fillRef>
+            <a:effectRef idx="2">
+              <a:schemeClr val="accent1"/>
+            </a:effectRef>
+            <a:fontRef idx="minor">
+              <a:schemeClr val="lt1"/>
+            </a:fontRef>
+          </p:style>
+          <p:txBody>
+            <a:bodyPr rtlCol="0" anchor="ctr"/>
+            <a:lstStyle/>
+            <a:p/>
+          </p:txBody>
+        </p:sp>
+        <p:sp>
+          <p:nvSpPr>
+            <p:cNvPr id="345" name="Shape 8"/>
+            <p:cNvSpPr/>
+            <p:nvPr/>
+          </p:nvSpPr>
+          <p:spPr>
+            <a:xfrm>
+              <a:off x="11786616" y="5934456"/>
+              <a:ext cx="36575" cy="246887"/>
+            </a:xfrm>
+            <a:prstGeom prst="rect">
+              <a:avLst/>
+            </a:prstGeom>
+            <a:solidFill>
+              <a:srgbClr val="FFFFFF">
+                <a:alpha val="72000"/>
+              </a:srgbClr>
+            </a:solidFill>
+            <a:ln>
+              <a:noFill/>
+            </a:ln>
+            <a:effectLst/>
+          </p:spPr>
+          <p:style>
+            <a:lnRef idx="1">
+              <a:schemeClr val="accent1"/>
+            </a:lnRef>
+            <a:fillRef idx="3">
+              <a:schemeClr val="accent1"/>
+            </a:fillRef>
+            <a:effectRef idx="2">
+              <a:schemeClr val="accent1"/>
+            </a:effectRef>
+            <a:fontRef idx="minor">
+              <a:schemeClr val="lt1"/>
+            </a:fontRef>
+          </p:style>
+          <p:txBody>
+            <a:bodyPr rtlCol="0" anchor="ctr"/>
+            <a:lstStyle/>
+            <a:p/>
+          </p:txBody>
+        </p:sp>
+        <p:sp>
+          <p:nvSpPr>
+            <p:cNvPr id="346" name="Shape 9"/>
+            <p:cNvSpPr/>
+            <p:nvPr/>
+          </p:nvSpPr>
+          <p:spPr>
+            <a:xfrm>
+              <a:off x="365760" y="6181344"/>
+              <a:ext cx="1005840" cy="0"/>
+            </a:xfrm>
+            <a:prstGeom prst="rect">
+              <a:avLst/>
+            </a:prstGeom>
+            <a:solidFill>
+              <a:srgbClr val="FFFFFF">
+                <a:alpha val="72000"/>
+              </a:srgbClr>
+            </a:solidFill>
+            <a:ln>
+              <a:noFill/>
+            </a:ln>
+            <a:effectLst/>
+          </p:spPr>
+          <p:style>
+            <a:lnRef idx="1">
+              <a:schemeClr val="accent1"/>
+            </a:lnRef>
+            <a:fillRef idx="3">
+              <a:schemeClr val="accent1"/>
+            </a:fillRef>
+            <a:effectRef idx="2">
+              <a:schemeClr val="accent1"/>
+            </a:effectRef>
+            <a:fontRef idx="minor">
+              <a:schemeClr val="lt1"/>
+            </a:fontRef>
+          </p:style>
+          <p:txBody>
+            <a:bodyPr rtlCol="0" anchor="ctr"/>
+            <a:lstStyle/>
+            <a:p/>
+          </p:txBody>
+        </p:sp>
+        <p:sp>
+          <p:nvSpPr>
+            <p:cNvPr id="347" name="Shape 10"/>
+            <p:cNvSpPr/>
+            <p:nvPr/>
+          </p:nvSpPr>
+          <p:spPr>
+            <a:xfrm>
+              <a:off x="11786616" y="6181344"/>
+              <a:ext cx="36575" cy="0"/>
+            </a:xfrm>
+            <a:prstGeom prst="rect">
+              <a:avLst/>
+            </a:prstGeom>
+            <a:solidFill>
+              <a:srgbClr val="FFFFFF">
+                <a:alpha val="72000"/>
+              </a:srgbClr>
+            </a:solidFill>
+            <a:ln>
+              <a:noFill/>
+            </a:ln>
+            <a:effectLst/>
+          </p:spPr>
+          <p:style>
+            <a:lnRef idx="1">
+              <a:schemeClr val="accent1"/>
+            </a:lnRef>
+            <a:fillRef idx="3">
+              <a:schemeClr val="accent1"/>
+            </a:fillRef>
+            <a:effectRef idx="2">
+              <a:schemeClr val="accent1"/>
+            </a:effectRef>
+            <a:fontRef idx="minor">
+              <a:schemeClr val="lt1"/>
+            </a:fontRef>
+          </p:style>
+          <p:txBody>
+            <a:bodyPr rtlCol="0" anchor="ctr"/>
+            <a:lstStyle/>
+            <a:p/>
+          </p:txBody>
+        </p:sp>
+        <p:sp>
+          <p:nvSpPr>
+            <p:cNvPr id="348" name="Shape 11"/>
+            <p:cNvSpPr/>
+            <p:nvPr/>
+          </p:nvSpPr>
+          <p:spPr>
+            <a:xfrm>
+              <a:off x="365760" y="6181344"/>
+              <a:ext cx="11457432" cy="173735"/>
+            </a:xfrm>
+            <a:prstGeom prst="rect">
+              <a:avLst/>
+            </a:prstGeom>
+            <a:solidFill>
+              <a:srgbClr val="FFFFFF">
+                <a:alpha val="72000"/>
+              </a:srgbClr>
+            </a:solidFill>
+            <a:ln>
+              <a:noFill/>
+            </a:ln>
+            <a:effectLst/>
+          </p:spPr>
+          <p:style>
+            <a:lnRef idx="1">
+              <a:schemeClr val="accent1"/>
+            </a:lnRef>
+            <a:fillRef idx="3">
+              <a:schemeClr val="accent1"/>
+            </a:fillRef>
+            <a:effectRef idx="2">
+              <a:schemeClr val="accent1"/>
+            </a:effectRef>
+            <a:fontRef idx="minor">
+              <a:schemeClr val="lt1"/>
+            </a:fontRef>
+          </p:style>
+          <p:txBody>
+            <a:bodyPr rtlCol="0" anchor="ctr"/>
+            <a:lstStyle/>
+            <a:p/>
+          </p:txBody>
+        </p:sp>
+        <p:sp>
+          <p:nvSpPr>
+            <p:cNvPr id="349" name="Shape 12"/>
             <p:cNvSpPr/>
             <p:nvPr/>
           </p:nvSpPr>
@@ -16290,7 +17249,7 @@
         </p:sp>
         <p:sp>
           <p:nvSpPr>
-            <p:cNvPr id="328" name="Shape 6"/>
+            <p:cNvPr id="350" name="Shape 13"/>
             <p:cNvSpPr/>
             <p:nvPr/>
           </p:nvSpPr>
@@ -16334,7 +17293,271 @@
         </p:sp>
         <p:sp>
           <p:nvSpPr>
-            <p:cNvPr id="329" name="Shape 7"/>
+            <p:cNvPr id="351" name="Shape 14"/>
+            <p:cNvSpPr/>
+            <p:nvPr/>
+          </p:nvSpPr>
+          <p:spPr>
+            <a:xfrm>
+              <a:off x="1517904" y="5943600"/>
+              <a:ext cx="493776" cy="219456"/>
+            </a:xfrm>
+            <a:prstGeom prst="roundRect">
+              <a:avLst>
+                <a:gd name="adj" fmla="val 8000"/>
+              </a:avLst>
+            </a:prstGeom>
+            <a:noFill/>
+            <a:ln w="38100">
+              <a:solidFill>
+                <a:srgbClr val="FA8B35"/>
+              </a:solidFill>
+            </a:ln>
+            <a:effectLst/>
+          </p:spPr>
+          <p:style>
+            <a:lnRef idx="1">
+              <a:schemeClr val="accent1"/>
+            </a:lnRef>
+            <a:fillRef idx="3">
+              <a:schemeClr val="accent1"/>
+            </a:fillRef>
+            <a:effectRef idx="2">
+              <a:schemeClr val="accent1"/>
+            </a:effectRef>
+            <a:fontRef idx="minor">
+              <a:schemeClr val="lt1"/>
+            </a:fontRef>
+          </p:style>
+          <p:txBody>
+            <a:bodyPr rtlCol="0" anchor="ctr"/>
+            <a:lstStyle/>
+            <a:p/>
+          </p:txBody>
+        </p:sp>
+        <p:sp>
+          <p:nvSpPr>
+            <p:cNvPr id="352" name="Shape 15"/>
+            <p:cNvSpPr/>
+            <p:nvPr/>
+          </p:nvSpPr>
+          <p:spPr>
+            <a:xfrm>
+              <a:off x="2999232" y="5943600"/>
+              <a:ext cx="493776" cy="219456"/>
+            </a:xfrm>
+            <a:prstGeom prst="roundRect">
+              <a:avLst>
+                <a:gd name="adj" fmla="val 8000"/>
+              </a:avLst>
+            </a:prstGeom>
+            <a:noFill/>
+            <a:ln w="38100">
+              <a:solidFill>
+                <a:srgbClr val="FA8B35"/>
+              </a:solidFill>
+            </a:ln>
+            <a:effectLst/>
+          </p:spPr>
+          <p:style>
+            <a:lnRef idx="1">
+              <a:schemeClr val="accent1"/>
+            </a:lnRef>
+            <a:fillRef idx="3">
+              <a:schemeClr val="accent1"/>
+            </a:fillRef>
+            <a:effectRef idx="2">
+              <a:schemeClr val="accent1"/>
+            </a:effectRef>
+            <a:fontRef idx="minor">
+              <a:schemeClr val="lt1"/>
+            </a:fontRef>
+          </p:style>
+          <p:txBody>
+            <a:bodyPr rtlCol="0" anchor="ctr"/>
+            <a:lstStyle/>
+            <a:p/>
+          </p:txBody>
+        </p:sp>
+        <p:sp>
+          <p:nvSpPr>
+            <p:cNvPr id="353" name="Shape 16"/>
+            <p:cNvSpPr/>
+            <p:nvPr/>
+          </p:nvSpPr>
+          <p:spPr>
+            <a:xfrm>
+              <a:off x="4480560" y="5943600"/>
+              <a:ext cx="493776" cy="219456"/>
+            </a:xfrm>
+            <a:prstGeom prst="roundRect">
+              <a:avLst>
+                <a:gd name="adj" fmla="val 8000"/>
+              </a:avLst>
+            </a:prstGeom>
+            <a:noFill/>
+            <a:ln w="38100">
+              <a:solidFill>
+                <a:srgbClr val="FA8B35"/>
+              </a:solidFill>
+            </a:ln>
+            <a:effectLst/>
+          </p:spPr>
+          <p:style>
+            <a:lnRef idx="1">
+              <a:schemeClr val="accent1"/>
+            </a:lnRef>
+            <a:fillRef idx="3">
+              <a:schemeClr val="accent1"/>
+            </a:fillRef>
+            <a:effectRef idx="2">
+              <a:schemeClr val="accent1"/>
+            </a:effectRef>
+            <a:fontRef idx="minor">
+              <a:schemeClr val="lt1"/>
+            </a:fontRef>
+          </p:style>
+          <p:txBody>
+            <a:bodyPr rtlCol="0" anchor="ctr"/>
+            <a:lstStyle/>
+            <a:p/>
+          </p:txBody>
+        </p:sp>
+        <p:sp>
+          <p:nvSpPr>
+            <p:cNvPr id="354" name="Shape 17"/>
+            <p:cNvSpPr/>
+            <p:nvPr/>
+          </p:nvSpPr>
+          <p:spPr>
+            <a:xfrm>
+              <a:off x="5221224" y="5943600"/>
+              <a:ext cx="493776" cy="219456"/>
+            </a:xfrm>
+            <a:prstGeom prst="roundRect">
+              <a:avLst>
+                <a:gd name="adj" fmla="val 8000"/>
+              </a:avLst>
+            </a:prstGeom>
+            <a:noFill/>
+            <a:ln w="38100">
+              <a:solidFill>
+                <a:srgbClr val="FA8B35"/>
+              </a:solidFill>
+            </a:ln>
+            <a:effectLst/>
+          </p:spPr>
+          <p:style>
+            <a:lnRef idx="1">
+              <a:schemeClr val="accent1"/>
+            </a:lnRef>
+            <a:fillRef idx="3">
+              <a:schemeClr val="accent1"/>
+            </a:fillRef>
+            <a:effectRef idx="2">
+              <a:schemeClr val="accent1"/>
+            </a:effectRef>
+            <a:fontRef idx="minor">
+              <a:schemeClr val="lt1"/>
+            </a:fontRef>
+          </p:style>
+          <p:txBody>
+            <a:bodyPr rtlCol="0" anchor="ctr"/>
+            <a:lstStyle/>
+            <a:p/>
+          </p:txBody>
+        </p:sp>
+        <p:sp>
+          <p:nvSpPr>
+            <p:cNvPr id="355" name="Shape 18"/>
+            <p:cNvSpPr/>
+            <p:nvPr/>
+          </p:nvSpPr>
+          <p:spPr>
+            <a:xfrm>
+              <a:off x="6702552" y="5943600"/>
+              <a:ext cx="493776" cy="219456"/>
+            </a:xfrm>
+            <a:prstGeom prst="roundRect">
+              <a:avLst>
+                <a:gd name="adj" fmla="val 8000"/>
+              </a:avLst>
+            </a:prstGeom>
+            <a:noFill/>
+            <a:ln w="38100">
+              <a:solidFill>
+                <a:srgbClr val="FA8B35"/>
+              </a:solidFill>
+            </a:ln>
+            <a:effectLst/>
+          </p:spPr>
+          <p:style>
+            <a:lnRef idx="1">
+              <a:schemeClr val="accent1"/>
+            </a:lnRef>
+            <a:fillRef idx="3">
+              <a:schemeClr val="accent1"/>
+            </a:fillRef>
+            <a:effectRef idx="2">
+              <a:schemeClr val="accent1"/>
+            </a:effectRef>
+            <a:fontRef idx="minor">
+              <a:schemeClr val="lt1"/>
+            </a:fontRef>
+          </p:style>
+          <p:txBody>
+            <a:bodyPr rtlCol="0" anchor="ctr"/>
+            <a:lstStyle/>
+            <a:p/>
+          </p:txBody>
+        </p:sp>
+        <p:sp>
+          <p:nvSpPr>
+            <p:cNvPr id="356" name="Shape 19"/>
+            <p:cNvSpPr/>
+            <p:nvPr/>
+          </p:nvSpPr>
+          <p:spPr>
+            <a:xfrm>
+              <a:off x="8924544" y="5943600"/>
+              <a:ext cx="493776" cy="219456"/>
+            </a:xfrm>
+            <a:prstGeom prst="roundRect">
+              <a:avLst>
+                <a:gd name="adj" fmla="val 8000"/>
+              </a:avLst>
+            </a:prstGeom>
+            <a:noFill/>
+            <a:ln w="38100">
+              <a:solidFill>
+                <a:srgbClr val="FA8B35"/>
+              </a:solidFill>
+            </a:ln>
+            <a:effectLst/>
+          </p:spPr>
+          <p:style>
+            <a:lnRef idx="1">
+              <a:schemeClr val="accent1"/>
+            </a:lnRef>
+            <a:fillRef idx="3">
+              <a:schemeClr val="accent1"/>
+            </a:fillRef>
+            <a:effectRef idx="2">
+              <a:schemeClr val="accent1"/>
+            </a:effectRef>
+            <a:fontRef idx="minor">
+              <a:schemeClr val="lt1"/>
+            </a:fontRef>
+          </p:style>
+          <p:txBody>
+            <a:bodyPr rtlCol="0" anchor="ctr"/>
+            <a:lstStyle/>
+            <a:p/>
+          </p:txBody>
+        </p:sp>
+        <p:sp>
+          <p:nvSpPr>
+            <p:cNvPr id="357" name="Shape 20"/>
             <p:cNvSpPr/>
             <p:nvPr/>
           </p:nvSpPr>
@@ -16380,7 +17603,7 @@
         </p:sp>
         <p:sp>
           <p:nvSpPr>
-            <p:cNvPr id="330" name="Text 8"/>
+            <p:cNvPr id="358" name="Text 21"/>
             <p:cNvSpPr txBox="1"/>
             <p:nvPr/>
           </p:nvSpPr>
@@ -16445,21 +17668,21 @@
       </p:grpSp>
       <p:grpSp>
         <p:nvGrpSpPr>
-          <p:cNvPr id="331" name="Step 6 arrows"/>
+          <p:cNvPr id="359" name="Step 6 arrows"/>
           <p:cNvGrpSpPr/>
           <p:nvPr/>
         </p:nvGrpSpPr>
         <p:grpSpPr>
           <a:xfrm>
             <a:off x="4892040" y="3310128"/>
-            <a:ext cx="3959352" cy="1499616"/>
+            <a:ext cx="6858000" cy="2834640"/>
             <a:chOff x="4892040" y="3310128"/>
-            <a:chExt cx="3959352" cy="1499616"/>
+            <a:chExt cx="6858000" cy="2834640"/>
           </a:xfrm>
         </p:grpSpPr>
         <p:cxnSp>
           <p:nvCxnSpPr>
-            <p:cNvPr id="332" name="Arrow 1"/>
+            <p:cNvPr id="360" name="Arrow 1"/>
             <p:cNvCxnSpPr/>
             <p:nvPr/>
           </p:nvCxnSpPr>
@@ -16494,7 +17717,7 @@
         </p:cxnSp>
         <p:cxnSp>
           <p:nvCxnSpPr>
-            <p:cNvPr id="333" name="Arrow 2"/>
+            <p:cNvPr id="361" name="Arrow 2"/>
             <p:cNvCxnSpPr/>
             <p:nvPr/>
           </p:nvCxnSpPr>
@@ -16529,7 +17752,7 @@
         </p:cxnSp>
         <p:cxnSp>
           <p:nvCxnSpPr>
-            <p:cNvPr id="334" name="Arrow 3"/>
+            <p:cNvPr id="362" name="Arrow 3"/>
             <p:cNvCxnSpPr/>
             <p:nvPr/>
           </p:nvCxnSpPr>
@@ -16565,7 +17788,7 @@
         </p:cxnSp>
         <p:cxnSp>
           <p:nvCxnSpPr>
-            <p:cNvPr id="335" name="Arrow 4"/>
+            <p:cNvPr id="363" name="Arrow 4"/>
             <p:cNvCxnSpPr/>
             <p:nvPr/>
           </p:nvCxnSpPr>
@@ -16601,7 +17824,7 @@
         </p:cxnSp>
         <p:sp>
           <p:nvSpPr>
-            <p:cNvPr id="336" name="Shape 5"/>
+            <p:cNvPr id="364" name="Shape 5"/>
             <p:cNvSpPr/>
             <p:nvPr/>
           </p:nvSpPr>
@@ -16645,7 +17868,7 @@
         </p:sp>
         <p:sp>
           <p:nvSpPr>
-            <p:cNvPr id="337" name="Text 6"/>
+            <p:cNvPr id="365" name="Text 6"/>
             <p:cNvSpPr txBox="1"/>
             <p:nvPr/>
           </p:nvSpPr>
@@ -16680,7 +17903,7 @@
         </p:sp>
         <p:sp>
           <p:nvSpPr>
-            <p:cNvPr id="338" name="Shape 7"/>
+            <p:cNvPr id="366" name="Shape 7"/>
             <p:cNvSpPr/>
             <p:nvPr/>
           </p:nvSpPr>
@@ -16724,7 +17947,7 @@
         </p:sp>
         <p:sp>
           <p:nvSpPr>
-            <p:cNvPr id="339" name="Text 8"/>
+            <p:cNvPr id="367" name="Text 8"/>
             <p:cNvSpPr txBox="1"/>
             <p:nvPr/>
           </p:nvSpPr>
@@ -16757,10 +17980,89 @@
             </a:p>
           </p:txBody>
         </p:sp>
+        <p:sp>
+          <p:nvSpPr>
+            <p:cNvPr id="368" name="Shape 9"/>
+            <p:cNvSpPr/>
+            <p:nvPr/>
+          </p:nvSpPr>
+          <p:spPr>
+            <a:xfrm>
+              <a:off x="9601200" y="5961888"/>
+              <a:ext cx="2148840" cy="182880"/>
+            </a:xfrm>
+            <a:prstGeom prst="roundRect">
+              <a:avLst>
+                <a:gd name="adj" fmla="val 50000"/>
+              </a:avLst>
+            </a:prstGeom>
+            <a:solidFill>
+              <a:srgbClr val="000000"/>
+            </a:solidFill>
+            <a:ln>
+              <a:noFill/>
+            </a:ln>
+            <a:effectLst/>
+          </p:spPr>
+          <p:style>
+            <a:lnRef idx="1">
+              <a:schemeClr val="accent1"/>
+            </a:lnRef>
+            <a:fillRef idx="3">
+              <a:schemeClr val="accent1"/>
+            </a:fillRef>
+            <a:effectRef idx="2">
+              <a:schemeClr val="accent1"/>
+            </a:effectRef>
+            <a:fontRef idx="minor">
+              <a:schemeClr val="lt1"/>
+            </a:fontRef>
+          </p:style>
+          <p:txBody>
+            <a:bodyPr rtlCol="0" anchor="ctr"/>
+            <a:lstStyle/>
+            <a:p/>
+          </p:txBody>
+        </p:sp>
+        <p:sp>
+          <p:nvSpPr>
+            <p:cNvPr id="369" name="Text 10"/>
+            <p:cNvSpPr txBox="1"/>
+            <p:nvPr/>
+          </p:nvSpPr>
+          <p:spPr>
+            <a:xfrm>
+              <a:off x="9601200" y="5961888"/>
+              <a:ext cx="2148840" cy="182880"/>
+            </a:xfrm>
+            <a:prstGeom prst="rect">
+              <a:avLst/>
+            </a:prstGeom>
+            <a:noFill/>
+          </p:spPr>
+          <p:txBody>
+            <a:bodyPr wrap="square" lIns="0" rIns="0" tIns="0" bIns="0" anchor="ctr">
+              <a:spAutoFit/>
+            </a:bodyPr>
+            <a:lstStyle/>
+            <a:p>
+              <a:pPr algn="ctr"/>
+              <a:r>
+                <a:rPr sz="650" b="1" i="0" spc="60">
+                  <a:solidFill>
+                    <a:srgbClr val="FFFFFF"/>
+                  </a:solidFill>
+                  <a:latin typeface="Trenda IG Text"/>
+                </a:rPr>
+                <a:t>FAIL SCORED · RETRY RE-SCORED</a:t>
+              </a:r>
+            </a:p>
+          </p:txBody>
+        </p:sp>
       </p:grpSp>
       <p:grpSp>
         <p:nvGrpSpPr>
-          <p:cNvPr id="340" name="Step 7 highlight"/>
+          <p:cNvPr id="370" name="Step 7 highlight"/>
           <p:cNvGrpSpPr/>
           <p:nvPr/>
         </p:nvGrpSpPr>
@@ -16774,7 +18076,7 @@
         </p:grpSpPr>
         <p:sp>
           <p:nvSpPr>
-            <p:cNvPr id="341" name="Shape 1"/>
+            <p:cNvPr id="371" name="Shape 1"/>
             <p:cNvSpPr/>
             <p:nvPr/>
           </p:nvSpPr>
@@ -16818,7 +18120,7 @@
         </p:sp>
         <p:sp>
           <p:nvSpPr>
-            <p:cNvPr id="342" name="Shape 2"/>
+            <p:cNvPr id="372" name="Shape 2"/>
             <p:cNvSpPr/>
             <p:nvPr/>
           </p:nvSpPr>
@@ -16862,7 +18164,7 @@
         </p:sp>
         <p:sp>
           <p:nvSpPr>
-            <p:cNvPr id="343" name="Shape 3"/>
+            <p:cNvPr id="373" name="Shape 3"/>
             <p:cNvSpPr/>
             <p:nvPr/>
           </p:nvSpPr>
@@ -16906,7 +18208,7 @@
         </p:sp>
         <p:sp>
           <p:nvSpPr>
-            <p:cNvPr id="344" name="Shape 4"/>
+            <p:cNvPr id="374" name="Shape 4"/>
             <p:cNvSpPr/>
             <p:nvPr/>
           </p:nvSpPr>
@@ -16950,7 +18252,7 @@
         </p:sp>
         <p:sp>
           <p:nvSpPr>
-            <p:cNvPr id="345" name="Shape 5"/>
+            <p:cNvPr id="375" name="Shape 5"/>
             <p:cNvSpPr/>
             <p:nvPr/>
           </p:nvSpPr>
@@ -16994,7 +18296,7 @@
         </p:sp>
         <p:sp>
           <p:nvSpPr>
-            <p:cNvPr id="346" name="Shape 6"/>
+            <p:cNvPr id="376" name="Shape 6"/>
             <p:cNvSpPr/>
             <p:nvPr/>
           </p:nvSpPr>
@@ -17038,7 +18340,7 @@
         </p:sp>
         <p:sp>
           <p:nvSpPr>
-            <p:cNvPr id="347" name="Shape 7"/>
+            <p:cNvPr id="377" name="Shape 7"/>
             <p:cNvSpPr/>
             <p:nvPr/>
           </p:nvSpPr>
@@ -17082,7 +18384,7 @@
         </p:sp>
         <p:sp>
           <p:nvSpPr>
-            <p:cNvPr id="348" name="Shape 8"/>
+            <p:cNvPr id="378" name="Shape 8"/>
             <p:cNvSpPr/>
             <p:nvPr/>
           </p:nvSpPr>
@@ -17126,7 +18428,7 @@
         </p:sp>
         <p:sp>
           <p:nvSpPr>
-            <p:cNvPr id="349" name="Shape 9"/>
+            <p:cNvPr id="379" name="Shape 9"/>
             <p:cNvSpPr/>
             <p:nvPr/>
           </p:nvSpPr>
@@ -17170,7 +18472,7 @@
         </p:sp>
         <p:sp>
           <p:nvSpPr>
-            <p:cNvPr id="350" name="Shape 10"/>
+            <p:cNvPr id="380" name="Shape 10"/>
             <p:cNvSpPr/>
             <p:nvPr/>
           </p:nvSpPr>
@@ -17214,7 +18516,7 @@
         </p:sp>
         <p:sp>
           <p:nvSpPr>
-            <p:cNvPr id="351" name="Shape 11"/>
+            <p:cNvPr id="381" name="Shape 11"/>
             <p:cNvSpPr/>
             <p:nvPr/>
           </p:nvSpPr>
@@ -17258,7 +18560,7 @@
         </p:sp>
         <p:sp>
           <p:nvSpPr>
-            <p:cNvPr id="352" name="Shape 12"/>
+            <p:cNvPr id="382" name="Shape 12"/>
             <p:cNvSpPr/>
             <p:nvPr/>
           </p:nvSpPr>
@@ -17302,7 +18604,7 @@
         </p:sp>
         <p:sp>
           <p:nvSpPr>
-            <p:cNvPr id="353" name="Shape 13"/>
+            <p:cNvPr id="383" name="Shape 13"/>
             <p:cNvSpPr/>
             <p:nvPr/>
           </p:nvSpPr>
@@ -17346,7 +18648,7 @@
         </p:sp>
         <p:sp>
           <p:nvSpPr>
-            <p:cNvPr id="354" name="Shape 14"/>
+            <p:cNvPr id="384" name="Shape 14"/>
             <p:cNvSpPr/>
             <p:nvPr/>
           </p:nvSpPr>
@@ -17390,7 +18692,7 @@
         </p:sp>
         <p:sp>
           <p:nvSpPr>
-            <p:cNvPr id="355" name="Shape 15"/>
+            <p:cNvPr id="385" name="Shape 15"/>
             <p:cNvSpPr/>
             <p:nvPr/>
           </p:nvSpPr>
@@ -17434,7 +18736,7 @@
         </p:sp>
         <p:sp>
           <p:nvSpPr>
-            <p:cNvPr id="356" name="Shape 16"/>
+            <p:cNvPr id="386" name="Shape 16"/>
             <p:cNvSpPr/>
             <p:nvPr/>
           </p:nvSpPr>
@@ -17478,7 +18780,7 @@
         </p:sp>
         <p:sp>
           <p:nvSpPr>
-            <p:cNvPr id="357" name="Shape 17"/>
+            <p:cNvPr id="387" name="Shape 17"/>
             <p:cNvSpPr/>
             <p:nvPr/>
           </p:nvSpPr>
@@ -17522,7 +18824,7 @@
         </p:sp>
         <p:sp>
           <p:nvSpPr>
-            <p:cNvPr id="358" name="Shape 18"/>
+            <p:cNvPr id="388" name="Shape 18"/>
             <p:cNvSpPr/>
             <p:nvPr/>
           </p:nvSpPr>
@@ -17568,7 +18870,7 @@
         </p:sp>
         <p:sp>
           <p:nvSpPr>
-            <p:cNvPr id="359" name="Text 19"/>
+            <p:cNvPr id="389" name="Text 19"/>
             <p:cNvSpPr txBox="1"/>
             <p:nvPr/>
           </p:nvSpPr>
@@ -17633,7 +18935,7 @@
       </p:grpSp>
       <p:grpSp>
         <p:nvGrpSpPr>
-          <p:cNvPr id="360" name="Step 7 arrows"/>
+          <p:cNvPr id="390" name="Step 7 arrows"/>
           <p:cNvGrpSpPr/>
           <p:nvPr/>
         </p:nvGrpSpPr>
@@ -17647,7 +18949,7 @@
         </p:grpSpPr>
         <p:cxnSp>
           <p:nvCxnSpPr>
-            <p:cNvPr id="361" name="Arrow 1"/>
+            <p:cNvPr id="391" name="Arrow 1"/>
             <p:cNvCxnSpPr/>
             <p:nvPr/>
           </p:nvCxnSpPr>
@@ -17682,7 +18984,7 @@
         </p:cxnSp>
         <p:cxnSp>
           <p:nvCxnSpPr>
-            <p:cNvPr id="362" name="Arrow 2"/>
+            <p:cNvPr id="392" name="Arrow 2"/>
             <p:cNvCxnSpPr/>
             <p:nvPr/>
           </p:nvCxnSpPr>
@@ -17717,7 +19019,7 @@
         </p:cxnSp>
         <p:cxnSp>
           <p:nvCxnSpPr>
-            <p:cNvPr id="363" name="Arrow 3"/>
+            <p:cNvPr id="393" name="Arrow 3"/>
             <p:cNvCxnSpPr/>
             <p:nvPr/>
           </p:nvCxnSpPr>
@@ -17753,7 +19055,7 @@
         </p:cxnSp>
         <p:sp>
           <p:nvSpPr>
-            <p:cNvPr id="364" name="Shape 4"/>
+            <p:cNvPr id="394" name="Shape 4"/>
             <p:cNvSpPr/>
             <p:nvPr/>
           </p:nvSpPr>
@@ -17797,7 +19099,7 @@
         </p:sp>
         <p:sp>
           <p:nvSpPr>
-            <p:cNvPr id="365" name="Text 5"/>
+            <p:cNvPr id="395" name="Text 5"/>
             <p:cNvSpPr txBox="1"/>
             <p:nvPr/>
           </p:nvSpPr>
@@ -17833,7 +19135,7 @@
       </p:grpSp>
       <p:grpSp>
         <p:nvGrpSpPr>
-          <p:cNvPr id="366" name="Step 8 highlight"/>
+          <p:cNvPr id="396" name="Step 8 highlight"/>
           <p:cNvGrpSpPr/>
           <p:nvPr/>
         </p:nvGrpSpPr>
@@ -17847,7 +19149,7 @@
         </p:grpSpPr>
         <p:sp>
           <p:nvSpPr>
-            <p:cNvPr id="367" name="Shape 1"/>
+            <p:cNvPr id="397" name="Shape 1"/>
             <p:cNvSpPr/>
             <p:nvPr/>
           </p:nvSpPr>
@@ -17891,7 +19193,7 @@
         </p:sp>
         <p:sp>
           <p:nvSpPr>
-            <p:cNvPr id="368" name="Shape 2"/>
+            <p:cNvPr id="398" name="Shape 2"/>
             <p:cNvSpPr/>
             <p:nvPr/>
           </p:nvSpPr>
@@ -17935,7 +19237,7 @@
         </p:sp>
         <p:sp>
           <p:nvSpPr>
-            <p:cNvPr id="369" name="Shape 3"/>
+            <p:cNvPr id="399" name="Shape 3"/>
             <p:cNvSpPr/>
             <p:nvPr/>
           </p:nvSpPr>
@@ -17979,7 +19281,7 @@
         </p:sp>
         <p:sp>
           <p:nvSpPr>
-            <p:cNvPr id="370" name="Shape 4"/>
+            <p:cNvPr id="400" name="Shape 4"/>
             <p:cNvSpPr/>
             <p:nvPr/>
           </p:nvSpPr>
@@ -18023,7 +19325,7 @@
         </p:sp>
         <p:sp>
           <p:nvSpPr>
-            <p:cNvPr id="371" name="Shape 5"/>
+            <p:cNvPr id="401" name="Shape 5"/>
             <p:cNvSpPr/>
             <p:nvPr/>
           </p:nvSpPr>
@@ -18067,7 +19369,7 @@
         </p:sp>
         <p:sp>
           <p:nvSpPr>
-            <p:cNvPr id="372" name="Shape 6"/>
+            <p:cNvPr id="402" name="Shape 6"/>
             <p:cNvSpPr/>
             <p:nvPr/>
           </p:nvSpPr>
@@ -18111,7 +19413,7 @@
         </p:sp>
         <p:sp>
           <p:nvSpPr>
-            <p:cNvPr id="373" name="Shape 7"/>
+            <p:cNvPr id="403" name="Shape 7"/>
             <p:cNvSpPr/>
             <p:nvPr/>
           </p:nvSpPr>
@@ -18155,7 +19457,7 @@
         </p:sp>
         <p:sp>
           <p:nvSpPr>
-            <p:cNvPr id="374" name="Shape 8"/>
+            <p:cNvPr id="404" name="Shape 8"/>
             <p:cNvSpPr/>
             <p:nvPr/>
           </p:nvSpPr>
@@ -18199,7 +19501,7 @@
         </p:sp>
         <p:sp>
           <p:nvSpPr>
-            <p:cNvPr id="375" name="Shape 9"/>
+            <p:cNvPr id="405" name="Shape 9"/>
             <p:cNvSpPr/>
             <p:nvPr/>
           </p:nvSpPr>
@@ -18243,7 +19545,7 @@
         </p:sp>
         <p:sp>
           <p:nvSpPr>
-            <p:cNvPr id="376" name="Shape 10"/>
+            <p:cNvPr id="406" name="Shape 10"/>
             <p:cNvSpPr/>
             <p:nvPr/>
           </p:nvSpPr>
@@ -18287,7 +19589,7 @@
         </p:sp>
         <p:sp>
           <p:nvSpPr>
-            <p:cNvPr id="377" name="Shape 11"/>
+            <p:cNvPr id="407" name="Shape 11"/>
             <p:cNvSpPr/>
             <p:nvPr/>
           </p:nvSpPr>
@@ -18331,7 +19633,7 @@
         </p:sp>
         <p:sp>
           <p:nvSpPr>
-            <p:cNvPr id="378" name="Shape 12"/>
+            <p:cNvPr id="408" name="Shape 12"/>
             <p:cNvSpPr/>
             <p:nvPr/>
           </p:nvSpPr>
@@ -18375,7 +19677,7 @@
         </p:sp>
         <p:sp>
           <p:nvSpPr>
-            <p:cNvPr id="379" name="Shape 13"/>
+            <p:cNvPr id="409" name="Shape 13"/>
             <p:cNvSpPr/>
             <p:nvPr/>
           </p:nvSpPr>
@@ -18419,7 +19721,7 @@
         </p:sp>
         <p:sp>
           <p:nvSpPr>
-            <p:cNvPr id="380" name="Shape 14"/>
+            <p:cNvPr id="410" name="Shape 14"/>
             <p:cNvSpPr/>
             <p:nvPr/>
           </p:nvSpPr>
@@ -18463,7 +19765,7 @@
         </p:sp>
         <p:sp>
           <p:nvSpPr>
-            <p:cNvPr id="381" name="Shape 15"/>
+            <p:cNvPr id="411" name="Shape 15"/>
             <p:cNvSpPr/>
             <p:nvPr/>
           </p:nvSpPr>
@@ -18507,7 +19809,7 @@
         </p:sp>
         <p:sp>
           <p:nvSpPr>
-            <p:cNvPr id="382" name="Shape 16"/>
+            <p:cNvPr id="412" name="Shape 16"/>
             <p:cNvSpPr/>
             <p:nvPr/>
           </p:nvSpPr>
@@ -18551,7 +19853,7 @@
         </p:sp>
         <p:sp>
           <p:nvSpPr>
-            <p:cNvPr id="383" name="Shape 17"/>
+            <p:cNvPr id="413" name="Shape 17"/>
             <p:cNvSpPr/>
             <p:nvPr/>
           </p:nvSpPr>
@@ -18595,7 +19897,7 @@
         </p:sp>
         <p:sp>
           <p:nvSpPr>
-            <p:cNvPr id="384" name="Shape 18"/>
+            <p:cNvPr id="414" name="Shape 18"/>
             <p:cNvSpPr/>
             <p:nvPr/>
           </p:nvSpPr>
@@ -18639,7 +19941,7 @@
         </p:sp>
         <p:sp>
           <p:nvSpPr>
-            <p:cNvPr id="385" name="Shape 19"/>
+            <p:cNvPr id="415" name="Shape 19"/>
             <p:cNvSpPr/>
             <p:nvPr/>
           </p:nvSpPr>
@@ -18683,7 +19985,7 @@
         </p:sp>
         <p:sp>
           <p:nvSpPr>
-            <p:cNvPr id="386" name="Shape 20"/>
+            <p:cNvPr id="416" name="Shape 20"/>
             <p:cNvSpPr/>
             <p:nvPr/>
           </p:nvSpPr>
@@ -18727,7 +20029,7 @@
         </p:sp>
         <p:sp>
           <p:nvSpPr>
-            <p:cNvPr id="387" name="Shape 21"/>
+            <p:cNvPr id="417" name="Shape 21"/>
             <p:cNvSpPr/>
             <p:nvPr/>
           </p:nvSpPr>
@@ -18771,7 +20073,7 @@
         </p:sp>
         <p:sp>
           <p:nvSpPr>
-            <p:cNvPr id="388" name="Shape 22"/>
+            <p:cNvPr id="418" name="Shape 22"/>
             <p:cNvSpPr/>
             <p:nvPr/>
           </p:nvSpPr>
@@ -18815,7 +20117,7 @@
         </p:sp>
         <p:sp>
           <p:nvSpPr>
-            <p:cNvPr id="389" name="Shape 23"/>
+            <p:cNvPr id="419" name="Shape 23"/>
             <p:cNvSpPr/>
             <p:nvPr/>
           </p:nvSpPr>
@@ -18859,7 +20161,7 @@
         </p:sp>
         <p:sp>
           <p:nvSpPr>
-            <p:cNvPr id="390" name="Shape 24"/>
+            <p:cNvPr id="420" name="Shape 24"/>
             <p:cNvSpPr/>
             <p:nvPr/>
           </p:nvSpPr>
@@ -18905,7 +20207,7 @@
         </p:sp>
         <p:sp>
           <p:nvSpPr>
-            <p:cNvPr id="391" name="Text 25"/>
+            <p:cNvPr id="421" name="Text 25"/>
             <p:cNvSpPr txBox="1"/>
             <p:nvPr/>
           </p:nvSpPr>
@@ -18970,7 +20272,7 @@
       </p:grpSp>
       <p:grpSp>
         <p:nvGrpSpPr>
-          <p:cNvPr id="392" name="Step 8 arrows"/>
+          <p:cNvPr id="422" name="Step 8 arrows"/>
           <p:cNvGrpSpPr/>
           <p:nvPr/>
         </p:nvGrpSpPr>
@@ -18984,7 +20286,7 @@
         </p:grpSpPr>
         <p:cxnSp>
           <p:nvCxnSpPr>
-            <p:cNvPr id="393" name="Arrow 1"/>
+            <p:cNvPr id="423" name="Arrow 1"/>
             <p:cNvCxnSpPr/>
             <p:nvPr/>
           </p:nvCxnSpPr>
@@ -19019,7 +20321,7 @@
         </p:cxnSp>
         <p:cxnSp>
           <p:nvCxnSpPr>
-            <p:cNvPr id="394" name="Arrow 2"/>
+            <p:cNvPr id="424" name="Arrow 2"/>
             <p:cNvCxnSpPr/>
             <p:nvPr/>
           </p:nvCxnSpPr>
@@ -19054,7 +20356,7 @@
         </p:cxnSp>
         <p:cxnSp>
           <p:nvCxnSpPr>
-            <p:cNvPr id="395" name="Arrow 3"/>
+            <p:cNvPr id="425" name="Arrow 3"/>
             <p:cNvCxnSpPr/>
             <p:nvPr/>
           </p:nvCxnSpPr>
@@ -19090,7 +20392,7 @@
         </p:cxnSp>
         <p:sp>
           <p:nvSpPr>
-            <p:cNvPr id="396" name="Shape 4"/>
+            <p:cNvPr id="426" name="Shape 4"/>
             <p:cNvSpPr/>
             <p:nvPr/>
           </p:nvSpPr>
@@ -19134,7 +20436,7 @@
         </p:sp>
         <p:sp>
           <p:nvSpPr>
-            <p:cNvPr id="397" name="Text 5"/>
+            <p:cNvPr id="427" name="Text 5"/>
             <p:cNvSpPr txBox="1"/>
             <p:nvPr/>
           </p:nvSpPr>
@@ -19170,7 +20472,7 @@
       </p:grpSp>
       <p:grpSp>
         <p:nvGrpSpPr>
-          <p:cNvPr id="398" name="Step 9 highlight"/>
+          <p:cNvPr id="428" name="Step 9 highlight"/>
           <p:cNvGrpSpPr/>
           <p:nvPr/>
         </p:nvGrpSpPr>
@@ -19184,7 +20486,7 @@
         </p:grpSpPr>
         <p:sp>
           <p:nvSpPr>
-            <p:cNvPr id="399" name="Shape 1"/>
+            <p:cNvPr id="429" name="Shape 1"/>
             <p:cNvSpPr/>
             <p:nvPr/>
           </p:nvSpPr>
@@ -19228,7 +20530,7 @@
         </p:sp>
         <p:sp>
           <p:nvSpPr>
-            <p:cNvPr id="400" name="Shape 2"/>
+            <p:cNvPr id="430" name="Shape 2"/>
             <p:cNvSpPr/>
             <p:nvPr/>
           </p:nvSpPr>
@@ -19272,7 +20574,7 @@
         </p:sp>
         <p:sp>
           <p:nvSpPr>
-            <p:cNvPr id="401" name="Shape 3"/>
+            <p:cNvPr id="431" name="Shape 3"/>
             <p:cNvSpPr/>
             <p:nvPr/>
           </p:nvSpPr>
@@ -19316,7 +20618,7 @@
         </p:sp>
         <p:sp>
           <p:nvSpPr>
-            <p:cNvPr id="402" name="Shape 4"/>
+            <p:cNvPr id="432" name="Shape 4"/>
             <p:cNvSpPr/>
             <p:nvPr/>
           </p:nvSpPr>
@@ -19360,7 +20662,7 @@
         </p:sp>
         <p:sp>
           <p:nvSpPr>
-            <p:cNvPr id="403" name="Shape 5"/>
+            <p:cNvPr id="433" name="Shape 5"/>
             <p:cNvSpPr/>
             <p:nvPr/>
           </p:nvSpPr>
@@ -19404,7 +20706,7 @@
         </p:sp>
         <p:sp>
           <p:nvSpPr>
-            <p:cNvPr id="404" name="Shape 6"/>
+            <p:cNvPr id="434" name="Shape 6"/>
             <p:cNvSpPr/>
             <p:nvPr/>
           </p:nvSpPr>
@@ -19448,7 +20750,7 @@
         </p:sp>
         <p:sp>
           <p:nvSpPr>
-            <p:cNvPr id="405" name="Shape 7"/>
+            <p:cNvPr id="435" name="Shape 7"/>
             <p:cNvSpPr/>
             <p:nvPr/>
           </p:nvSpPr>
@@ -19492,7 +20794,7 @@
         </p:sp>
         <p:sp>
           <p:nvSpPr>
-            <p:cNvPr id="406" name="Shape 8"/>
+            <p:cNvPr id="436" name="Shape 8"/>
             <p:cNvSpPr/>
             <p:nvPr/>
           </p:nvSpPr>
@@ -19536,7 +20838,7 @@
         </p:sp>
         <p:sp>
           <p:nvSpPr>
-            <p:cNvPr id="407" name="Shape 9"/>
+            <p:cNvPr id="437" name="Shape 9"/>
             <p:cNvSpPr/>
             <p:nvPr/>
           </p:nvSpPr>
@@ -19580,7 +20882,7 @@
         </p:sp>
         <p:sp>
           <p:nvSpPr>
-            <p:cNvPr id="408" name="Shape 10"/>
+            <p:cNvPr id="438" name="Shape 10"/>
             <p:cNvSpPr/>
             <p:nvPr/>
           </p:nvSpPr>
@@ -19624,7 +20926,7 @@
         </p:sp>
         <p:sp>
           <p:nvSpPr>
-            <p:cNvPr id="409" name="Shape 11"/>
+            <p:cNvPr id="439" name="Shape 11"/>
             <p:cNvSpPr/>
             <p:nvPr/>
           </p:nvSpPr>
@@ -19668,7 +20970,7 @@
         </p:sp>
         <p:sp>
           <p:nvSpPr>
-            <p:cNvPr id="410" name="Shape 12"/>
+            <p:cNvPr id="440" name="Shape 12"/>
             <p:cNvSpPr/>
             <p:nvPr/>
           </p:nvSpPr>
@@ -19712,7 +21014,7 @@
         </p:sp>
         <p:sp>
           <p:nvSpPr>
-            <p:cNvPr id="411" name="Shape 13"/>
+            <p:cNvPr id="441" name="Shape 13"/>
             <p:cNvSpPr/>
             <p:nvPr/>
           </p:nvSpPr>
@@ -19756,7 +21058,7 @@
         </p:sp>
         <p:sp>
           <p:nvSpPr>
-            <p:cNvPr id="412" name="Shape 14"/>
+            <p:cNvPr id="442" name="Shape 14"/>
             <p:cNvSpPr/>
             <p:nvPr/>
           </p:nvSpPr>
@@ -19800,7 +21102,7 @@
         </p:sp>
         <p:sp>
           <p:nvSpPr>
-            <p:cNvPr id="413" name="Shape 15"/>
+            <p:cNvPr id="443" name="Shape 15"/>
             <p:cNvSpPr/>
             <p:nvPr/>
           </p:nvSpPr>
@@ -19844,7 +21146,7 @@
         </p:sp>
         <p:sp>
           <p:nvSpPr>
-            <p:cNvPr id="414" name="Shape 16"/>
+            <p:cNvPr id="444" name="Shape 16"/>
             <p:cNvSpPr/>
             <p:nvPr/>
           </p:nvSpPr>
@@ -19888,7 +21190,7 @@
         </p:sp>
         <p:sp>
           <p:nvSpPr>
-            <p:cNvPr id="415" name="Shape 17"/>
+            <p:cNvPr id="445" name="Shape 17"/>
             <p:cNvSpPr/>
             <p:nvPr/>
           </p:nvSpPr>
@@ -19932,7 +21234,7 @@
         </p:sp>
         <p:sp>
           <p:nvSpPr>
-            <p:cNvPr id="416" name="Shape 18"/>
+            <p:cNvPr id="446" name="Shape 18"/>
             <p:cNvSpPr/>
             <p:nvPr/>
           </p:nvSpPr>
@@ -19976,7 +21278,7 @@
         </p:sp>
         <p:sp>
           <p:nvSpPr>
-            <p:cNvPr id="417" name="Shape 19"/>
+            <p:cNvPr id="447" name="Shape 19"/>
             <p:cNvSpPr/>
             <p:nvPr/>
           </p:nvSpPr>
@@ -20020,7 +21322,7 @@
         </p:sp>
         <p:sp>
           <p:nvSpPr>
-            <p:cNvPr id="418" name="Shape 20"/>
+            <p:cNvPr id="448" name="Shape 20"/>
             <p:cNvSpPr/>
             <p:nvPr/>
           </p:nvSpPr>
@@ -20064,7 +21366,7 @@
         </p:sp>
         <p:sp>
           <p:nvSpPr>
-            <p:cNvPr id="419" name="Shape 21"/>
+            <p:cNvPr id="449" name="Shape 21"/>
             <p:cNvSpPr/>
             <p:nvPr/>
           </p:nvSpPr>
@@ -20108,7 +21410,7 @@
         </p:sp>
         <p:sp>
           <p:nvSpPr>
-            <p:cNvPr id="420" name="Shape 22"/>
+            <p:cNvPr id="450" name="Shape 22"/>
             <p:cNvSpPr/>
             <p:nvPr/>
           </p:nvSpPr>
@@ -20152,7 +21454,7 @@
         </p:sp>
         <p:sp>
           <p:nvSpPr>
-            <p:cNvPr id="421" name="Shape 23"/>
+            <p:cNvPr id="451" name="Shape 23"/>
             <p:cNvSpPr/>
             <p:nvPr/>
           </p:nvSpPr>
@@ -20196,7 +21498,7 @@
         </p:sp>
         <p:sp>
           <p:nvSpPr>
-            <p:cNvPr id="422" name="Shape 24"/>
+            <p:cNvPr id="452" name="Shape 24"/>
             <p:cNvSpPr/>
             <p:nvPr/>
           </p:nvSpPr>
@@ -20240,7 +21542,7 @@
         </p:sp>
         <p:sp>
           <p:nvSpPr>
-            <p:cNvPr id="423" name="Shape 25"/>
+            <p:cNvPr id="453" name="Shape 25"/>
             <p:cNvSpPr/>
             <p:nvPr/>
           </p:nvSpPr>
@@ -20284,7 +21586,7 @@
         </p:sp>
         <p:sp>
           <p:nvSpPr>
-            <p:cNvPr id="424" name="Shape 26"/>
+            <p:cNvPr id="454" name="Shape 26"/>
             <p:cNvSpPr/>
             <p:nvPr/>
           </p:nvSpPr>
@@ -20328,7 +21630,7 @@
         </p:sp>
         <p:sp>
           <p:nvSpPr>
-            <p:cNvPr id="425" name="Shape 27"/>
+            <p:cNvPr id="455" name="Shape 27"/>
             <p:cNvSpPr/>
             <p:nvPr/>
           </p:nvSpPr>
@@ -20372,7 +21674,7 @@
         </p:sp>
         <p:sp>
           <p:nvSpPr>
-            <p:cNvPr id="426" name="Shape 28"/>
+            <p:cNvPr id="456" name="Shape 28"/>
             <p:cNvSpPr/>
             <p:nvPr/>
           </p:nvSpPr>
@@ -20416,7 +21718,7 @@
         </p:sp>
         <p:sp>
           <p:nvSpPr>
-            <p:cNvPr id="427" name="Shape 29"/>
+            <p:cNvPr id="457" name="Shape 29"/>
             <p:cNvSpPr/>
             <p:nvPr/>
           </p:nvSpPr>
@@ -20460,7 +21762,7 @@
         </p:sp>
         <p:sp>
           <p:nvSpPr>
-            <p:cNvPr id="428" name="Shape 30"/>
+            <p:cNvPr id="458" name="Shape 30"/>
             <p:cNvSpPr/>
             <p:nvPr/>
           </p:nvSpPr>
@@ -20504,7 +21806,7 @@
         </p:sp>
         <p:sp>
           <p:nvSpPr>
-            <p:cNvPr id="429" name="Shape 31"/>
+            <p:cNvPr id="459" name="Shape 31"/>
             <p:cNvSpPr/>
             <p:nvPr/>
           </p:nvSpPr>
@@ -20548,7 +21850,7 @@
         </p:sp>
         <p:sp>
           <p:nvSpPr>
-            <p:cNvPr id="430" name="Shape 32"/>
+            <p:cNvPr id="460" name="Shape 32"/>
             <p:cNvSpPr/>
             <p:nvPr/>
           </p:nvSpPr>
@@ -20594,7 +21896,7 @@
         </p:sp>
         <p:sp>
           <p:nvSpPr>
-            <p:cNvPr id="431" name="Text 33"/>
+            <p:cNvPr id="461" name="Text 33"/>
             <p:cNvSpPr txBox="1"/>
             <p:nvPr/>
           </p:nvSpPr>
@@ -20659,7 +21961,7 @@
       </p:grpSp>
       <p:grpSp>
         <p:nvGrpSpPr>
-          <p:cNvPr id="432" name="Step 9 arrows"/>
+          <p:cNvPr id="462" name="Step 9 arrows"/>
           <p:cNvGrpSpPr/>
           <p:nvPr/>
         </p:nvGrpSpPr>
@@ -20673,7 +21975,7 @@
         </p:grpSpPr>
         <p:cxnSp>
           <p:nvCxnSpPr>
-            <p:cNvPr id="433" name="Arrow 1"/>
+            <p:cNvPr id="463" name="Arrow 1"/>
             <p:cNvCxnSpPr/>
             <p:nvPr/>
           </p:nvCxnSpPr>
@@ -20708,7 +22010,7 @@
         </p:cxnSp>
         <p:cxnSp>
           <p:nvCxnSpPr>
-            <p:cNvPr id="434" name="Arrow 2"/>
+            <p:cNvPr id="464" name="Arrow 2"/>
             <p:cNvCxnSpPr/>
             <p:nvPr/>
           </p:nvCxnSpPr>
@@ -20743,7 +22045,7 @@
         </p:cxnSp>
         <p:cxnSp>
           <p:nvCxnSpPr>
-            <p:cNvPr id="435" name="Arrow 3"/>
+            <p:cNvPr id="465" name="Arrow 3"/>
             <p:cNvCxnSpPr/>
             <p:nvPr/>
           </p:nvCxnSpPr>
@@ -20779,7 +22081,7 @@
         </p:cxnSp>
         <p:sp>
           <p:nvSpPr>
-            <p:cNvPr id="436" name="Shape 4"/>
+            <p:cNvPr id="466" name="Shape 4"/>
             <p:cNvSpPr/>
             <p:nvPr/>
           </p:nvSpPr>
@@ -20823,7 +22125,7 @@
         </p:sp>
         <p:sp>
           <p:nvSpPr>
-            <p:cNvPr id="437" name="Text 5"/>
+            <p:cNvPr id="467" name="Text 5"/>
             <p:cNvSpPr txBox="1"/>
             <p:nvPr/>
           </p:nvSpPr>
@@ -20859,7 +22161,7 @@
       </p:grpSp>
       <p:grpSp>
         <p:nvGrpSpPr>
-          <p:cNvPr id="438" name="Step 10 highlight"/>
+          <p:cNvPr id="468" name="Step 10 highlight"/>
           <p:cNvGrpSpPr/>
           <p:nvPr/>
         </p:nvGrpSpPr>
@@ -20873,7 +22175,7 @@
         </p:grpSpPr>
         <p:sp>
           <p:nvSpPr>
-            <p:cNvPr id="439" name="Shape 1"/>
+            <p:cNvPr id="469" name="Shape 1"/>
             <p:cNvSpPr/>
             <p:nvPr/>
           </p:nvSpPr>
@@ -20917,7 +22219,7 @@
         </p:sp>
         <p:sp>
           <p:nvSpPr>
-            <p:cNvPr id="440" name="Shape 2"/>
+            <p:cNvPr id="470" name="Shape 2"/>
             <p:cNvSpPr/>
             <p:nvPr/>
           </p:nvSpPr>
@@ -20961,7 +22263,7 @@
         </p:sp>
         <p:sp>
           <p:nvSpPr>
-            <p:cNvPr id="441" name="Shape 3"/>
+            <p:cNvPr id="471" name="Shape 3"/>
             <p:cNvSpPr/>
             <p:nvPr/>
           </p:nvSpPr>
@@ -21005,7 +22307,7 @@
         </p:sp>
         <p:sp>
           <p:nvSpPr>
-            <p:cNvPr id="442" name="Shape 4"/>
+            <p:cNvPr id="472" name="Shape 4"/>
             <p:cNvSpPr/>
             <p:nvPr/>
           </p:nvSpPr>
@@ -21049,7 +22351,7 @@
         </p:sp>
         <p:sp>
           <p:nvSpPr>
-            <p:cNvPr id="443" name="Shape 5"/>
+            <p:cNvPr id="473" name="Shape 5"/>
             <p:cNvSpPr/>
             <p:nvPr/>
           </p:nvSpPr>
@@ -21093,7 +22395,7 @@
         </p:sp>
         <p:sp>
           <p:nvSpPr>
-            <p:cNvPr id="444" name="Shape 6"/>
+            <p:cNvPr id="474" name="Shape 6"/>
             <p:cNvSpPr/>
             <p:nvPr/>
           </p:nvSpPr>
@@ -21137,7 +22439,7 @@
         </p:sp>
         <p:sp>
           <p:nvSpPr>
-            <p:cNvPr id="445" name="Shape 7"/>
+            <p:cNvPr id="475" name="Shape 7"/>
             <p:cNvSpPr/>
             <p:nvPr/>
           </p:nvSpPr>
@@ -21181,7 +22483,7 @@
         </p:sp>
         <p:sp>
           <p:nvSpPr>
-            <p:cNvPr id="446" name="Shape 8"/>
+            <p:cNvPr id="476" name="Shape 8"/>
             <p:cNvSpPr/>
             <p:nvPr/>
           </p:nvSpPr>
@@ -21225,7 +22527,7 @@
         </p:sp>
         <p:sp>
           <p:nvSpPr>
-            <p:cNvPr id="447" name="Shape 9"/>
+            <p:cNvPr id="477" name="Shape 9"/>
             <p:cNvSpPr/>
             <p:nvPr/>
           </p:nvSpPr>
@@ -21269,7 +22571,7 @@
         </p:sp>
         <p:sp>
           <p:nvSpPr>
-            <p:cNvPr id="448" name="Shape 10"/>
+            <p:cNvPr id="478" name="Shape 10"/>
             <p:cNvSpPr/>
             <p:nvPr/>
           </p:nvSpPr>
@@ -21313,7 +22615,7 @@
         </p:sp>
         <p:sp>
           <p:nvSpPr>
-            <p:cNvPr id="449" name="Shape 11"/>
+            <p:cNvPr id="479" name="Shape 11"/>
             <p:cNvSpPr/>
             <p:nvPr/>
           </p:nvSpPr>
@@ -21357,7 +22659,7 @@
         </p:sp>
         <p:sp>
           <p:nvSpPr>
-            <p:cNvPr id="450" name="Shape 12"/>
+            <p:cNvPr id="480" name="Shape 12"/>
             <p:cNvSpPr/>
             <p:nvPr/>
           </p:nvSpPr>
@@ -21401,7 +22703,7 @@
         </p:sp>
         <p:sp>
           <p:nvSpPr>
-            <p:cNvPr id="451" name="Shape 13"/>
+            <p:cNvPr id="481" name="Shape 13"/>
             <p:cNvSpPr/>
             <p:nvPr/>
           </p:nvSpPr>
@@ -21445,7 +22747,7 @@
         </p:sp>
         <p:sp>
           <p:nvSpPr>
-            <p:cNvPr id="452" name="Shape 14"/>
+            <p:cNvPr id="482" name="Shape 14"/>
             <p:cNvSpPr/>
             <p:nvPr/>
           </p:nvSpPr>
@@ -21489,7 +22791,7 @@
         </p:sp>
         <p:sp>
           <p:nvSpPr>
-            <p:cNvPr id="453" name="Shape 15"/>
+            <p:cNvPr id="483" name="Shape 15"/>
             <p:cNvSpPr/>
             <p:nvPr/>
           </p:nvSpPr>
@@ -21533,7 +22835,7 @@
         </p:sp>
         <p:sp>
           <p:nvSpPr>
-            <p:cNvPr id="454" name="Shape 16"/>
+            <p:cNvPr id="484" name="Shape 16"/>
             <p:cNvSpPr/>
             <p:nvPr/>
           </p:nvSpPr>
@@ -21577,7 +22879,7 @@
         </p:sp>
         <p:sp>
           <p:nvSpPr>
-            <p:cNvPr id="455" name="Shape 17"/>
+            <p:cNvPr id="485" name="Shape 17"/>
             <p:cNvSpPr/>
             <p:nvPr/>
           </p:nvSpPr>
@@ -21621,7 +22923,7 @@
         </p:sp>
         <p:sp>
           <p:nvSpPr>
-            <p:cNvPr id="456" name="Shape 18"/>
+            <p:cNvPr id="486" name="Shape 18"/>
             <p:cNvSpPr/>
             <p:nvPr/>
           </p:nvSpPr>
@@ -21665,7 +22967,7 @@
         </p:sp>
         <p:sp>
           <p:nvSpPr>
-            <p:cNvPr id="457" name="Shape 19"/>
+            <p:cNvPr id="487" name="Shape 19"/>
             <p:cNvSpPr/>
             <p:nvPr/>
           </p:nvSpPr>
@@ -21709,7 +23011,7 @@
         </p:sp>
         <p:sp>
           <p:nvSpPr>
-            <p:cNvPr id="458" name="Shape 20"/>
+            <p:cNvPr id="488" name="Shape 20"/>
             <p:cNvSpPr/>
             <p:nvPr/>
           </p:nvSpPr>
@@ -21755,7 +23057,7 @@
         </p:sp>
         <p:sp>
           <p:nvSpPr>
-            <p:cNvPr id="459" name="Text 21"/>
+            <p:cNvPr id="489" name="Text 21"/>
             <p:cNvSpPr txBox="1"/>
             <p:nvPr/>
           </p:nvSpPr>
@@ -21820,7 +23122,7 @@
       </p:grpSp>
       <p:grpSp>
         <p:nvGrpSpPr>
-          <p:cNvPr id="460" name="Step 10 arrows"/>
+          <p:cNvPr id="490" name="Step 10 arrows"/>
           <p:cNvGrpSpPr/>
           <p:nvPr/>
         </p:nvGrpSpPr>
@@ -21834,7 +23136,7 @@
         </p:grpSpPr>
         <p:cxnSp>
           <p:nvCxnSpPr>
-            <p:cNvPr id="461" name="Arrow 1"/>
+            <p:cNvPr id="491" name="Arrow 1"/>
             <p:cNvCxnSpPr/>
             <p:nvPr/>
           </p:nvCxnSpPr>
@@ -21869,7 +23171,7 @@
         </p:cxnSp>
         <p:cxnSp>
           <p:nvCxnSpPr>
-            <p:cNvPr id="462" name="Arrow 2"/>
+            <p:cNvPr id="492" name="Arrow 2"/>
             <p:cNvCxnSpPr/>
             <p:nvPr/>
           </p:nvCxnSpPr>
@@ -21904,7 +23206,7 @@
         </p:cxnSp>
         <p:cxnSp>
           <p:nvCxnSpPr>
-            <p:cNvPr id="463" name="Arrow 3"/>
+            <p:cNvPr id="493" name="Arrow 3"/>
             <p:cNvCxnSpPr/>
             <p:nvPr/>
           </p:nvCxnSpPr>
@@ -21940,7 +23242,7 @@
         </p:cxnSp>
         <p:sp>
           <p:nvSpPr>
-            <p:cNvPr id="464" name="Shape 4"/>
+            <p:cNvPr id="494" name="Shape 4"/>
             <p:cNvSpPr/>
             <p:nvPr/>
           </p:nvSpPr>
@@ -21984,7 +23286,7 @@
         </p:sp>
         <p:sp>
           <p:nvSpPr>
-            <p:cNvPr id="465" name="Text 5"/>
+            <p:cNvPr id="495" name="Text 5"/>
             <p:cNvSpPr txBox="1"/>
             <p:nvPr/>
           </p:nvSpPr>
@@ -22020,7 +23322,7 @@
       </p:grpSp>
       <p:grpSp>
         <p:nvGrpSpPr>
-          <p:cNvPr id="466" name="Step 11 highlight"/>
+          <p:cNvPr id="496" name="Step 11 highlight"/>
           <p:cNvGrpSpPr/>
           <p:nvPr/>
         </p:nvGrpSpPr>
@@ -22034,7 +23336,7 @@
         </p:grpSpPr>
         <p:sp>
           <p:nvSpPr>
-            <p:cNvPr id="467" name="Shape 1"/>
+            <p:cNvPr id="497" name="Shape 1"/>
             <p:cNvSpPr/>
             <p:nvPr/>
           </p:nvSpPr>
@@ -22078,7 +23380,7 @@
         </p:sp>
         <p:sp>
           <p:nvSpPr>
-            <p:cNvPr id="468" name="Shape 2"/>
+            <p:cNvPr id="498" name="Shape 2"/>
             <p:cNvSpPr/>
             <p:nvPr/>
           </p:nvSpPr>
@@ -22122,7 +23424,7 @@
         </p:sp>
         <p:sp>
           <p:nvSpPr>
-            <p:cNvPr id="469" name="Shape 3"/>
+            <p:cNvPr id="499" name="Shape 3"/>
             <p:cNvSpPr/>
             <p:nvPr/>
           </p:nvSpPr>
@@ -22166,7 +23468,7 @@
         </p:sp>
         <p:sp>
           <p:nvSpPr>
-            <p:cNvPr id="470" name="Shape 4"/>
+            <p:cNvPr id="500" name="Shape 4"/>
             <p:cNvSpPr/>
             <p:nvPr/>
           </p:nvSpPr>
@@ -22210,7 +23512,7 @@
         </p:sp>
         <p:sp>
           <p:nvSpPr>
-            <p:cNvPr id="471" name="Shape 5"/>
+            <p:cNvPr id="501" name="Shape 5"/>
             <p:cNvSpPr/>
             <p:nvPr/>
           </p:nvSpPr>
@@ -22254,7 +23556,7 @@
         </p:sp>
         <p:sp>
           <p:nvSpPr>
-            <p:cNvPr id="472" name="Shape 6"/>
+            <p:cNvPr id="502" name="Shape 6"/>
             <p:cNvSpPr/>
             <p:nvPr/>
           </p:nvSpPr>
@@ -22298,7 +23600,7 @@
         </p:sp>
         <p:sp>
           <p:nvSpPr>
-            <p:cNvPr id="473" name="Shape 7"/>
+            <p:cNvPr id="503" name="Shape 7"/>
             <p:cNvSpPr/>
             <p:nvPr/>
           </p:nvSpPr>
@@ -22342,7 +23644,7 @@
         </p:sp>
         <p:sp>
           <p:nvSpPr>
-            <p:cNvPr id="474" name="Shape 8"/>
+            <p:cNvPr id="504" name="Shape 8"/>
             <p:cNvSpPr/>
             <p:nvPr/>
           </p:nvSpPr>
@@ -22386,7 +23688,7 @@
         </p:sp>
         <p:sp>
           <p:nvSpPr>
-            <p:cNvPr id="475" name="Shape 9"/>
+            <p:cNvPr id="505" name="Shape 9"/>
             <p:cNvSpPr/>
             <p:nvPr/>
           </p:nvSpPr>
@@ -22430,7 +23732,7 @@
         </p:sp>
         <p:sp>
           <p:nvSpPr>
-            <p:cNvPr id="476" name="Shape 10"/>
+            <p:cNvPr id="506" name="Shape 10"/>
             <p:cNvSpPr/>
             <p:nvPr/>
           </p:nvSpPr>
@@ -22474,7 +23776,7 @@
         </p:sp>
         <p:sp>
           <p:nvSpPr>
-            <p:cNvPr id="477" name="Shape 11"/>
+            <p:cNvPr id="507" name="Shape 11"/>
             <p:cNvSpPr/>
             <p:nvPr/>
           </p:nvSpPr>
@@ -22518,7 +23820,7 @@
         </p:sp>
         <p:sp>
           <p:nvSpPr>
-            <p:cNvPr id="478" name="Shape 12"/>
+            <p:cNvPr id="508" name="Shape 12"/>
             <p:cNvSpPr/>
             <p:nvPr/>
           </p:nvSpPr>
@@ -22562,7 +23864,7 @@
         </p:sp>
         <p:sp>
           <p:nvSpPr>
-            <p:cNvPr id="479" name="Shape 13"/>
+            <p:cNvPr id="509" name="Shape 13"/>
             <p:cNvSpPr/>
             <p:nvPr/>
           </p:nvSpPr>
@@ -22606,7 +23908,7 @@
         </p:sp>
         <p:sp>
           <p:nvSpPr>
-            <p:cNvPr id="480" name="Shape 14"/>
+            <p:cNvPr id="510" name="Shape 14"/>
             <p:cNvSpPr/>
             <p:nvPr/>
           </p:nvSpPr>
@@ -22650,7 +23952,7 @@
         </p:sp>
         <p:sp>
           <p:nvSpPr>
-            <p:cNvPr id="481" name="Shape 15"/>
+            <p:cNvPr id="511" name="Shape 15"/>
             <p:cNvSpPr/>
             <p:nvPr/>
           </p:nvSpPr>
@@ -22694,7 +23996,7 @@
         </p:sp>
         <p:sp>
           <p:nvSpPr>
-            <p:cNvPr id="482" name="Shape 16"/>
+            <p:cNvPr id="512" name="Shape 16"/>
             <p:cNvSpPr/>
             <p:nvPr/>
           </p:nvSpPr>
@@ -22738,7 +24040,7 @@
         </p:sp>
         <p:sp>
           <p:nvSpPr>
-            <p:cNvPr id="483" name="Shape 17"/>
+            <p:cNvPr id="513" name="Shape 17"/>
             <p:cNvSpPr/>
             <p:nvPr/>
           </p:nvSpPr>
@@ -22782,7 +24084,7 @@
         </p:sp>
         <p:sp>
           <p:nvSpPr>
-            <p:cNvPr id="484" name="Shape 18"/>
+            <p:cNvPr id="514" name="Shape 18"/>
             <p:cNvSpPr/>
             <p:nvPr/>
           </p:nvSpPr>
@@ -22828,7 +24130,7 @@
         </p:sp>
         <p:sp>
           <p:nvSpPr>
-            <p:cNvPr id="485" name="Text 19"/>
+            <p:cNvPr id="515" name="Text 19"/>
             <p:cNvSpPr txBox="1"/>
             <p:nvPr/>
           </p:nvSpPr>
@@ -22893,7 +24195,7 @@
       </p:grpSp>
       <p:grpSp>
         <p:nvGrpSpPr>
-          <p:cNvPr id="486" name="Step 11 arrows"/>
+          <p:cNvPr id="516" name="Step 11 arrows"/>
           <p:cNvGrpSpPr/>
           <p:nvPr/>
         </p:nvGrpSpPr>
@@ -22907,7 +24209,7 @@
         </p:grpSpPr>
         <p:cxnSp>
           <p:nvCxnSpPr>
-            <p:cNvPr id="487" name="Arrow 1"/>
+            <p:cNvPr id="517" name="Arrow 1"/>
             <p:cNvCxnSpPr/>
             <p:nvPr/>
           </p:nvCxnSpPr>
@@ -22942,7 +24244,7 @@
         </p:cxnSp>
         <p:cxnSp>
           <p:nvCxnSpPr>
-            <p:cNvPr id="488" name="Arrow 2"/>
+            <p:cNvPr id="518" name="Arrow 2"/>
             <p:cNvCxnSpPr/>
             <p:nvPr/>
           </p:nvCxnSpPr>
@@ -22977,7 +24279,7 @@
         </p:cxnSp>
         <p:cxnSp>
           <p:nvCxnSpPr>
-            <p:cNvPr id="489" name="Arrow 3"/>
+            <p:cNvPr id="519" name="Arrow 3"/>
             <p:cNvCxnSpPr/>
             <p:nvPr/>
           </p:nvCxnSpPr>
@@ -23013,7 +24315,7 @@
         </p:cxnSp>
         <p:sp>
           <p:nvSpPr>
-            <p:cNvPr id="490" name="Shape 4"/>
+            <p:cNvPr id="520" name="Shape 4"/>
             <p:cNvSpPr/>
             <p:nvPr/>
           </p:nvSpPr>
@@ -23057,7 +24359,7 @@
         </p:sp>
         <p:sp>
           <p:nvSpPr>
-            <p:cNvPr id="491" name="Text 5"/>
+            <p:cNvPr id="521" name="Text 5"/>
             <p:cNvSpPr txBox="1"/>
             <p:nvPr/>
           </p:nvSpPr>
@@ -23093,7 +24395,7 @@
       </p:grpSp>
       <p:grpSp>
         <p:nvGrpSpPr>
-          <p:cNvPr id="492" name="Step 12 highlight"/>
+          <p:cNvPr id="522" name="Step 12 highlight"/>
           <p:cNvGrpSpPr/>
           <p:nvPr/>
         </p:nvGrpSpPr>
@@ -23107,7 +24409,7 @@
         </p:grpSpPr>
         <p:sp>
           <p:nvSpPr>
-            <p:cNvPr id="493" name="Shape 1"/>
+            <p:cNvPr id="523" name="Shape 1"/>
             <p:cNvSpPr/>
             <p:nvPr/>
           </p:nvSpPr>
@@ -23151,7 +24453,7 @@
         </p:sp>
         <p:sp>
           <p:nvSpPr>
-            <p:cNvPr id="494" name="Shape 2"/>
+            <p:cNvPr id="524" name="Shape 2"/>
             <p:cNvSpPr/>
             <p:nvPr/>
           </p:nvSpPr>
@@ -23195,7 +24497,7 @@
         </p:sp>
         <p:sp>
           <p:nvSpPr>
-            <p:cNvPr id="495" name="Shape 3"/>
+            <p:cNvPr id="525" name="Shape 3"/>
             <p:cNvSpPr/>
             <p:nvPr/>
           </p:nvSpPr>
@@ -23239,7 +24541,7 @@
         </p:sp>
         <p:sp>
           <p:nvSpPr>
-            <p:cNvPr id="496" name="Shape 4"/>
+            <p:cNvPr id="526" name="Shape 4"/>
             <p:cNvSpPr/>
             <p:nvPr/>
           </p:nvSpPr>
@@ -23283,7 +24585,7 @@
         </p:sp>
         <p:sp>
           <p:nvSpPr>
-            <p:cNvPr id="497" name="Shape 5"/>
+            <p:cNvPr id="527" name="Shape 5"/>
             <p:cNvSpPr/>
             <p:nvPr/>
           </p:nvSpPr>
@@ -23327,7 +24629,7 @@
         </p:sp>
         <p:sp>
           <p:nvSpPr>
-            <p:cNvPr id="498" name="Shape 6"/>
+            <p:cNvPr id="528" name="Shape 6"/>
             <p:cNvSpPr/>
             <p:nvPr/>
           </p:nvSpPr>
@@ -23371,7 +24673,7 @@
         </p:sp>
         <p:sp>
           <p:nvSpPr>
-            <p:cNvPr id="499" name="Shape 7"/>
+            <p:cNvPr id="529" name="Shape 7"/>
             <p:cNvSpPr/>
             <p:nvPr/>
           </p:nvSpPr>
@@ -23415,7 +24717,7 @@
         </p:sp>
         <p:sp>
           <p:nvSpPr>
-            <p:cNvPr id="500" name="Shape 8"/>
+            <p:cNvPr id="530" name="Shape 8"/>
             <p:cNvSpPr/>
             <p:nvPr/>
           </p:nvSpPr>
@@ -23459,7 +24761,7 @@
         </p:sp>
         <p:sp>
           <p:nvSpPr>
-            <p:cNvPr id="501" name="Shape 9"/>
+            <p:cNvPr id="531" name="Shape 9"/>
             <p:cNvSpPr/>
             <p:nvPr/>
           </p:nvSpPr>
@@ -23503,7 +24805,7 @@
         </p:sp>
         <p:sp>
           <p:nvSpPr>
-            <p:cNvPr id="502" name="Shape 10"/>
+            <p:cNvPr id="532" name="Shape 10"/>
             <p:cNvSpPr/>
             <p:nvPr/>
           </p:nvSpPr>
@@ -23547,7 +24849,7 @@
         </p:sp>
         <p:sp>
           <p:nvSpPr>
-            <p:cNvPr id="503" name="Shape 11"/>
+            <p:cNvPr id="533" name="Shape 11"/>
             <p:cNvSpPr/>
             <p:nvPr/>
           </p:nvSpPr>
@@ -23591,7 +24893,7 @@
         </p:sp>
         <p:sp>
           <p:nvSpPr>
-            <p:cNvPr id="504" name="Shape 12"/>
+            <p:cNvPr id="534" name="Shape 12"/>
             <p:cNvSpPr/>
             <p:nvPr/>
           </p:nvSpPr>
@@ -23635,7 +24937,7 @@
         </p:sp>
         <p:sp>
           <p:nvSpPr>
-            <p:cNvPr id="505" name="Shape 13"/>
+            <p:cNvPr id="535" name="Shape 13"/>
             <p:cNvSpPr/>
             <p:nvPr/>
           </p:nvSpPr>
@@ -23679,7 +24981,7 @@
         </p:sp>
         <p:sp>
           <p:nvSpPr>
-            <p:cNvPr id="506" name="Shape 14"/>
+            <p:cNvPr id="536" name="Shape 14"/>
             <p:cNvSpPr/>
             <p:nvPr/>
           </p:nvSpPr>
@@ -23725,7 +25027,7 @@
         </p:sp>
         <p:sp>
           <p:nvSpPr>
-            <p:cNvPr id="507" name="Text 15"/>
+            <p:cNvPr id="537" name="Text 15"/>
             <p:cNvSpPr txBox="1"/>
             <p:nvPr/>
           </p:nvSpPr>
@@ -23790,7 +25092,7 @@
       </p:grpSp>
       <p:grpSp>
         <p:nvGrpSpPr>
-          <p:cNvPr id="508" name="Step 12 arrows"/>
+          <p:cNvPr id="538" name="Step 12 arrows"/>
           <p:cNvGrpSpPr/>
           <p:nvPr/>
         </p:nvGrpSpPr>
@@ -23804,7 +25106,7 @@
         </p:grpSpPr>
         <p:cxnSp>
           <p:nvCxnSpPr>
-            <p:cNvPr id="509" name="Arrow 1"/>
+            <p:cNvPr id="539" name="Arrow 1"/>
             <p:cNvCxnSpPr/>
             <p:nvPr/>
           </p:nvCxnSpPr>
@@ -23841,7 +25143,7 @@
       </p:grpSp>
       <p:grpSp>
         <p:nvGrpSpPr>
-          <p:cNvPr id="510" name="Step 13 highlight"/>
+          <p:cNvPr id="540" name="Step 13 highlight"/>
           <p:cNvGrpSpPr/>
           <p:nvPr/>
         </p:nvGrpSpPr>
@@ -23855,7 +25157,7 @@
         </p:grpSpPr>
         <p:sp>
           <p:nvSpPr>
-            <p:cNvPr id="511" name="Shape 1"/>
+            <p:cNvPr id="541" name="Shape 1"/>
             <p:cNvSpPr/>
             <p:nvPr/>
           </p:nvSpPr>
@@ -23899,7 +25201,7 @@
         </p:sp>
         <p:sp>
           <p:nvSpPr>
-            <p:cNvPr id="512" name="Shape 2"/>
+            <p:cNvPr id="542" name="Shape 2"/>
             <p:cNvSpPr/>
             <p:nvPr/>
           </p:nvSpPr>
@@ -23943,7 +25245,7 @@
         </p:sp>
         <p:sp>
           <p:nvSpPr>
-            <p:cNvPr id="513" name="Shape 3"/>
+            <p:cNvPr id="543" name="Shape 3"/>
             <p:cNvSpPr/>
             <p:nvPr/>
           </p:nvSpPr>
@@ -23987,7 +25289,7 @@
         </p:sp>
         <p:sp>
           <p:nvSpPr>
-            <p:cNvPr id="514" name="Shape 4"/>
+            <p:cNvPr id="544" name="Shape 4"/>
             <p:cNvSpPr/>
             <p:nvPr/>
           </p:nvSpPr>
@@ -24031,7 +25333,7 @@
         </p:sp>
         <p:sp>
           <p:nvSpPr>
-            <p:cNvPr id="515" name="Shape 5"/>
+            <p:cNvPr id="545" name="Shape 5"/>
             <p:cNvSpPr/>
             <p:nvPr/>
           </p:nvSpPr>
@@ -24075,7 +25377,7 @@
         </p:sp>
         <p:sp>
           <p:nvSpPr>
-            <p:cNvPr id="516" name="Shape 6"/>
+            <p:cNvPr id="546" name="Shape 6"/>
             <p:cNvSpPr/>
             <p:nvPr/>
           </p:nvSpPr>
@@ -24119,7 +25421,7 @@
         </p:sp>
         <p:sp>
           <p:nvSpPr>
-            <p:cNvPr id="517" name="Shape 7"/>
+            <p:cNvPr id="547" name="Shape 7"/>
             <p:cNvSpPr/>
             <p:nvPr/>
           </p:nvSpPr>
@@ -24165,7 +25467,7 @@
         </p:sp>
         <p:sp>
           <p:nvSpPr>
-            <p:cNvPr id="518" name="Text 8"/>
+            <p:cNvPr id="548" name="Text 8"/>
             <p:cNvSpPr txBox="1"/>
             <p:nvPr/>
           </p:nvSpPr>
@@ -24979,7 +26281,7 @@
                                           </p:stCondLst>
                                         </p:cTn>
                                         <p:tgtEl>
-                                          <p:spTgt spid="317"/>
+                                          <p:spTgt spid="330"/>
                                         </p:tgtEl>
                                         <p:attrNameLst>
                                           <p:attrName>style.visibility</p:attrName>
@@ -24993,7 +26295,7 @@
                                       <p:cBhvr>
                                         <p:cTn id="71" dur="600"/>
                                         <p:tgtEl>
-                                          <p:spTgt spid="317"/>
+                                          <p:spTgt spid="330"/>
                                         </p:tgtEl>
                                       </p:cBhvr>
                                     </p:animEffect>
@@ -25063,7 +26365,7 @@
                                       <p:cBhvr>
                                         <p:cTn id="78" dur="250"/>
                                         <p:tgtEl>
-                                          <p:spTgt spid="317"/>
+                                          <p:spTgt spid="330"/>
                                         </p:tgtEl>
                                       </p:cBhvr>
                                     </p:animEffect>
@@ -25075,7 +26377,7 @@
                                           </p:stCondLst>
                                         </p:cTn>
                                         <p:tgtEl>
-                                          <p:spTgt spid="317"/>
+                                          <p:spTgt spid="330"/>
                                         </p:tgtEl>
                                         <p:attrNameLst>
                                           <p:attrName>style.visibility</p:attrName>
@@ -25102,7 +26404,7 @@
                                           </p:stCondLst>
                                         </p:cTn>
                                         <p:tgtEl>
-                                          <p:spTgt spid="322"/>
+                                          <p:spTgt spid="337"/>
                                         </p:tgtEl>
                                         <p:attrNameLst>
                                           <p:attrName>style.visibility</p:attrName>
@@ -25116,7 +26418,7 @@
                                       <p:cBhvr>
                                         <p:cTn id="82" dur="350"/>
                                         <p:tgtEl>
-                                          <p:spTgt spid="322"/>
+                                          <p:spTgt spid="337"/>
                                         </p:tgtEl>
                                       </p:cBhvr>
                                     </p:animEffect>
@@ -25146,7 +26448,7 @@
                                           </p:stCondLst>
                                         </p:cTn>
                                         <p:tgtEl>
-                                          <p:spTgt spid="331"/>
+                                          <p:spTgt spid="359"/>
                                         </p:tgtEl>
                                         <p:attrNameLst>
                                           <p:attrName>style.visibility</p:attrName>
@@ -25160,7 +26462,7 @@
                                       <p:cBhvr>
                                         <p:cTn id="86" dur="600"/>
                                         <p:tgtEl>
-                                          <p:spTgt spid="331"/>
+                                          <p:spTgt spid="359"/>
                                         </p:tgtEl>
                                       </p:cBhvr>
                                     </p:animEffect>
@@ -25195,7 +26497,7 @@
                                       <p:cBhvr>
                                         <p:cTn id="90" dur="250"/>
                                         <p:tgtEl>
-                                          <p:spTgt spid="322"/>
+                                          <p:spTgt spid="337"/>
                                         </p:tgtEl>
                                       </p:cBhvr>
                                     </p:animEffect>
@@ -25207,7 +26509,7 @@
                                           </p:stCondLst>
                                         </p:cTn>
                                         <p:tgtEl>
-                                          <p:spTgt spid="322"/>
+                                          <p:spTgt spid="337"/>
                                         </p:tgtEl>
                                         <p:attrNameLst>
                                           <p:attrName>style.visibility</p:attrName>
@@ -25230,7 +26532,7 @@
                                       <p:cBhvr>
                                         <p:cTn id="93" dur="250"/>
                                         <p:tgtEl>
-                                          <p:spTgt spid="331"/>
+                                          <p:spTgt spid="359"/>
                                         </p:tgtEl>
                                       </p:cBhvr>
                                     </p:animEffect>
@@ -25242,7 +26544,7 @@
                                           </p:stCondLst>
                                         </p:cTn>
                                         <p:tgtEl>
-                                          <p:spTgt spid="331"/>
+                                          <p:spTgt spid="359"/>
                                         </p:tgtEl>
                                         <p:attrNameLst>
                                           <p:attrName>style.visibility</p:attrName>
@@ -25269,7 +26571,7 @@
                                           </p:stCondLst>
                                         </p:cTn>
                                         <p:tgtEl>
-                                          <p:spTgt spid="340"/>
+                                          <p:spTgt spid="370"/>
                                         </p:tgtEl>
                                         <p:attrNameLst>
                                           <p:attrName>style.visibility</p:attrName>
@@ -25283,7 +26585,7 @@
                                       <p:cBhvr>
                                         <p:cTn id="97" dur="350"/>
                                         <p:tgtEl>
-                                          <p:spTgt spid="340"/>
+                                          <p:spTgt spid="370"/>
                                         </p:tgtEl>
                                       </p:cBhvr>
                                     </p:animEffect>
@@ -25313,7 +26615,7 @@
                                           </p:stCondLst>
                                         </p:cTn>
                                         <p:tgtEl>
-                                          <p:spTgt spid="360"/>
+                                          <p:spTgt spid="390"/>
                                         </p:tgtEl>
                                         <p:attrNameLst>
                                           <p:attrName>style.visibility</p:attrName>
@@ -25327,7 +26629,7 @@
                                       <p:cBhvr>
                                         <p:cTn id="101" dur="600"/>
                                         <p:tgtEl>
-                                          <p:spTgt spid="360"/>
+                                          <p:spTgt spid="390"/>
                                         </p:tgtEl>
                                       </p:cBhvr>
                                     </p:animEffect>
@@ -25362,7 +26664,7 @@
                                       <p:cBhvr>
                                         <p:cTn id="105" dur="250"/>
                                         <p:tgtEl>
-                                          <p:spTgt spid="340"/>
+                                          <p:spTgt spid="370"/>
                                         </p:tgtEl>
                                       </p:cBhvr>
                                     </p:animEffect>
@@ -25374,7 +26676,7 @@
                                           </p:stCondLst>
                                         </p:cTn>
                                         <p:tgtEl>
-                                          <p:spTgt spid="340"/>
+                                          <p:spTgt spid="370"/>
                                         </p:tgtEl>
                                         <p:attrNameLst>
                                           <p:attrName>style.visibility</p:attrName>
@@ -25397,7 +26699,7 @@
                                       <p:cBhvr>
                                         <p:cTn id="108" dur="250"/>
                                         <p:tgtEl>
-                                          <p:spTgt spid="360"/>
+                                          <p:spTgt spid="390"/>
                                         </p:tgtEl>
                                       </p:cBhvr>
                                     </p:animEffect>
@@ -25409,7 +26711,7 @@
                                           </p:stCondLst>
                                         </p:cTn>
                                         <p:tgtEl>
-                                          <p:spTgt spid="360"/>
+                                          <p:spTgt spid="390"/>
                                         </p:tgtEl>
                                         <p:attrNameLst>
                                           <p:attrName>style.visibility</p:attrName>
@@ -25436,7 +26738,7 @@
                                           </p:stCondLst>
                                         </p:cTn>
                                         <p:tgtEl>
-                                          <p:spTgt spid="366"/>
+                                          <p:spTgt spid="396"/>
                                         </p:tgtEl>
                                         <p:attrNameLst>
                                           <p:attrName>style.visibility</p:attrName>
@@ -25450,7 +26752,7 @@
                                       <p:cBhvr>
                                         <p:cTn id="112" dur="350"/>
                                         <p:tgtEl>
-                                          <p:spTgt spid="366"/>
+                                          <p:spTgt spid="396"/>
                                         </p:tgtEl>
                                       </p:cBhvr>
                                     </p:animEffect>
@@ -25480,7 +26782,7 @@
                                           </p:stCondLst>
                                         </p:cTn>
                                         <p:tgtEl>
-                                          <p:spTgt spid="392"/>
+                                          <p:spTgt spid="422"/>
                                         </p:tgtEl>
                                         <p:attrNameLst>
                                           <p:attrName>style.visibility</p:attrName>
@@ -25494,7 +26796,7 @@
                                       <p:cBhvr>
                                         <p:cTn id="116" dur="600"/>
                                         <p:tgtEl>
-                                          <p:spTgt spid="392"/>
+                                          <p:spTgt spid="422"/>
                                         </p:tgtEl>
                                       </p:cBhvr>
                                     </p:animEffect>
@@ -25529,7 +26831,7 @@
                                       <p:cBhvr>
                                         <p:cTn id="120" dur="250"/>
                                         <p:tgtEl>
-                                          <p:spTgt spid="366"/>
+                                          <p:spTgt spid="396"/>
                                         </p:tgtEl>
                                       </p:cBhvr>
                                     </p:animEffect>
@@ -25541,7 +26843,7 @@
                                           </p:stCondLst>
                                         </p:cTn>
                                         <p:tgtEl>
-                                          <p:spTgt spid="366"/>
+                                          <p:spTgt spid="396"/>
                                         </p:tgtEl>
                                         <p:attrNameLst>
                                           <p:attrName>style.visibility</p:attrName>
@@ -25564,7 +26866,7 @@
                                       <p:cBhvr>
                                         <p:cTn id="123" dur="250"/>
                                         <p:tgtEl>
-                                          <p:spTgt spid="392"/>
+                                          <p:spTgt spid="422"/>
                                         </p:tgtEl>
                                       </p:cBhvr>
                                     </p:animEffect>
@@ -25576,7 +26878,7 @@
                                           </p:stCondLst>
                                         </p:cTn>
                                         <p:tgtEl>
-                                          <p:spTgt spid="392"/>
+                                          <p:spTgt spid="422"/>
                                         </p:tgtEl>
                                         <p:attrNameLst>
                                           <p:attrName>style.visibility</p:attrName>
@@ -25603,7 +26905,7 @@
                                           </p:stCondLst>
                                         </p:cTn>
                                         <p:tgtEl>
-                                          <p:spTgt spid="398"/>
+                                          <p:spTgt spid="428"/>
                                         </p:tgtEl>
                                         <p:attrNameLst>
                                           <p:attrName>style.visibility</p:attrName>
@@ -25617,7 +26919,7 @@
                                       <p:cBhvr>
                                         <p:cTn id="127" dur="350"/>
                                         <p:tgtEl>
-                                          <p:spTgt spid="398"/>
+                                          <p:spTgt spid="428"/>
                                         </p:tgtEl>
                                       </p:cBhvr>
                                     </p:animEffect>
@@ -25647,7 +26949,7 @@
                                           </p:stCondLst>
                                         </p:cTn>
                                         <p:tgtEl>
-                                          <p:spTgt spid="432"/>
+                                          <p:spTgt spid="462"/>
                                         </p:tgtEl>
                                         <p:attrNameLst>
                                           <p:attrName>style.visibility</p:attrName>
@@ -25661,7 +26963,7 @@
                                       <p:cBhvr>
                                         <p:cTn id="131" dur="600"/>
                                         <p:tgtEl>
-                                          <p:spTgt spid="432"/>
+                                          <p:spTgt spid="462"/>
                                         </p:tgtEl>
                                       </p:cBhvr>
                                     </p:animEffect>
@@ -25696,7 +26998,7 @@
                                       <p:cBhvr>
                                         <p:cTn id="135" dur="250"/>
                                         <p:tgtEl>
-                                          <p:spTgt spid="398"/>
+                                          <p:spTgt spid="428"/>
                                         </p:tgtEl>
                                       </p:cBhvr>
                                     </p:animEffect>
@@ -25708,7 +27010,7 @@
                                           </p:stCondLst>
                                         </p:cTn>
                                         <p:tgtEl>
-                                          <p:spTgt spid="398"/>
+                                          <p:spTgt spid="428"/>
                                         </p:tgtEl>
                                         <p:attrNameLst>
                                           <p:attrName>style.visibility</p:attrName>
@@ -25731,7 +27033,7 @@
                                       <p:cBhvr>
                                         <p:cTn id="138" dur="250"/>
                                         <p:tgtEl>
-                                          <p:spTgt spid="432"/>
+                                          <p:spTgt spid="462"/>
                                         </p:tgtEl>
                                       </p:cBhvr>
                                     </p:animEffect>
@@ -25743,7 +27045,7 @@
                                           </p:stCondLst>
                                         </p:cTn>
                                         <p:tgtEl>
-                                          <p:spTgt spid="432"/>
+                                          <p:spTgt spid="462"/>
                                         </p:tgtEl>
                                         <p:attrNameLst>
                                           <p:attrName>style.visibility</p:attrName>
@@ -25770,7 +27072,7 @@
                                           </p:stCondLst>
                                         </p:cTn>
                                         <p:tgtEl>
-                                          <p:spTgt spid="438"/>
+                                          <p:spTgt spid="468"/>
                                         </p:tgtEl>
                                         <p:attrNameLst>
                                           <p:attrName>style.visibility</p:attrName>
@@ -25784,7 +27086,7 @@
                                       <p:cBhvr>
                                         <p:cTn id="142" dur="350"/>
                                         <p:tgtEl>
-                                          <p:spTgt spid="438"/>
+                                          <p:spTgt spid="468"/>
                                         </p:tgtEl>
                                       </p:cBhvr>
                                     </p:animEffect>
@@ -25814,7 +27116,7 @@
                                           </p:stCondLst>
                                         </p:cTn>
                                         <p:tgtEl>
-                                          <p:spTgt spid="460"/>
+                                          <p:spTgt spid="490"/>
                                         </p:tgtEl>
                                         <p:attrNameLst>
                                           <p:attrName>style.visibility</p:attrName>
@@ -25828,7 +27130,7 @@
                                       <p:cBhvr>
                                         <p:cTn id="146" dur="600"/>
                                         <p:tgtEl>
-                                          <p:spTgt spid="460"/>
+                                          <p:spTgt spid="490"/>
                                         </p:tgtEl>
                                       </p:cBhvr>
                                     </p:animEffect>
@@ -25863,7 +27165,7 @@
                                       <p:cBhvr>
                                         <p:cTn id="150" dur="250"/>
                                         <p:tgtEl>
-                                          <p:spTgt spid="438"/>
+                                          <p:spTgt spid="468"/>
                                         </p:tgtEl>
                                       </p:cBhvr>
                                     </p:animEffect>
@@ -25875,7 +27177,7 @@
                                           </p:stCondLst>
                                         </p:cTn>
                                         <p:tgtEl>
-                                          <p:spTgt spid="438"/>
+                                          <p:spTgt spid="468"/>
                                         </p:tgtEl>
                                         <p:attrNameLst>
                                           <p:attrName>style.visibility</p:attrName>
@@ -25898,7 +27200,7 @@
                                       <p:cBhvr>
                                         <p:cTn id="153" dur="250"/>
                                         <p:tgtEl>
-                                          <p:spTgt spid="460"/>
+                                          <p:spTgt spid="490"/>
                                         </p:tgtEl>
                                       </p:cBhvr>
                                     </p:animEffect>
@@ -25910,7 +27212,7 @@
                                           </p:stCondLst>
                                         </p:cTn>
                                         <p:tgtEl>
-                                          <p:spTgt spid="460"/>
+                                          <p:spTgt spid="490"/>
                                         </p:tgtEl>
                                         <p:attrNameLst>
                                           <p:attrName>style.visibility</p:attrName>
@@ -25937,7 +27239,7 @@
                                           </p:stCondLst>
                                         </p:cTn>
                                         <p:tgtEl>
-                                          <p:spTgt spid="466"/>
+                                          <p:spTgt spid="496"/>
                                         </p:tgtEl>
                                         <p:attrNameLst>
                                           <p:attrName>style.visibility</p:attrName>
@@ -25951,7 +27253,7 @@
                                       <p:cBhvr>
                                         <p:cTn id="157" dur="350"/>
                                         <p:tgtEl>
-                                          <p:spTgt spid="466"/>
+                                          <p:spTgt spid="496"/>
                                         </p:tgtEl>
                                       </p:cBhvr>
                                     </p:animEffect>
@@ -25981,7 +27283,7 @@
                                           </p:stCondLst>
                                         </p:cTn>
                                         <p:tgtEl>
-                                          <p:spTgt spid="486"/>
+                                          <p:spTgt spid="516"/>
                                         </p:tgtEl>
                                         <p:attrNameLst>
                                           <p:attrName>style.visibility</p:attrName>
@@ -25995,7 +27297,7 @@
                                       <p:cBhvr>
                                         <p:cTn id="161" dur="600"/>
                                         <p:tgtEl>
-                                          <p:spTgt spid="486"/>
+                                          <p:spTgt spid="516"/>
                                         </p:tgtEl>
                                       </p:cBhvr>
                                     </p:animEffect>
@@ -26030,7 +27332,7 @@
                                       <p:cBhvr>
                                         <p:cTn id="165" dur="250"/>
                                         <p:tgtEl>
-                                          <p:spTgt spid="466"/>
+                                          <p:spTgt spid="496"/>
                                         </p:tgtEl>
                                       </p:cBhvr>
                                     </p:animEffect>
@@ -26042,7 +27344,7 @@
                                           </p:stCondLst>
                                         </p:cTn>
                                         <p:tgtEl>
-                                          <p:spTgt spid="466"/>
+                                          <p:spTgt spid="496"/>
                                         </p:tgtEl>
                                         <p:attrNameLst>
                                           <p:attrName>style.visibility</p:attrName>
@@ -26065,7 +27367,7 @@
                                       <p:cBhvr>
                                         <p:cTn id="168" dur="250"/>
                                         <p:tgtEl>
-                                          <p:spTgt spid="486"/>
+                                          <p:spTgt spid="516"/>
                                         </p:tgtEl>
                                       </p:cBhvr>
                                     </p:animEffect>
@@ -26077,7 +27379,7 @@
                                           </p:stCondLst>
                                         </p:cTn>
                                         <p:tgtEl>
-                                          <p:spTgt spid="486"/>
+                                          <p:spTgt spid="516"/>
                                         </p:tgtEl>
                                         <p:attrNameLst>
                                           <p:attrName>style.visibility</p:attrName>
@@ -26104,7 +27406,7 @@
                                           </p:stCondLst>
                                         </p:cTn>
                                         <p:tgtEl>
-                                          <p:spTgt spid="492"/>
+                                          <p:spTgt spid="522"/>
                                         </p:tgtEl>
                                         <p:attrNameLst>
                                           <p:attrName>style.visibility</p:attrName>
@@ -26118,7 +27420,7 @@
                                       <p:cBhvr>
                                         <p:cTn id="172" dur="350"/>
                                         <p:tgtEl>
-                                          <p:spTgt spid="492"/>
+                                          <p:spTgt spid="522"/>
                                         </p:tgtEl>
                                       </p:cBhvr>
                                     </p:animEffect>
@@ -26148,7 +27450,7 @@
                                           </p:stCondLst>
                                         </p:cTn>
                                         <p:tgtEl>
-                                          <p:spTgt spid="508"/>
+                                          <p:spTgt spid="538"/>
                                         </p:tgtEl>
                                         <p:attrNameLst>
                                           <p:attrName>style.visibility</p:attrName>
@@ -26162,7 +27464,7 @@
                                       <p:cBhvr>
                                         <p:cTn id="176" dur="600"/>
                                         <p:tgtEl>
-                                          <p:spTgt spid="508"/>
+                                          <p:spTgt spid="538"/>
                                         </p:tgtEl>
                                       </p:cBhvr>
                                     </p:animEffect>
@@ -26197,7 +27499,7 @@
                                       <p:cBhvr>
                                         <p:cTn id="180" dur="250"/>
                                         <p:tgtEl>
-                                          <p:spTgt spid="492"/>
+                                          <p:spTgt spid="522"/>
                                         </p:tgtEl>
                                       </p:cBhvr>
                                     </p:animEffect>
@@ -26209,7 +27511,7 @@
                                           </p:stCondLst>
                                         </p:cTn>
                                         <p:tgtEl>
-                                          <p:spTgt spid="492"/>
+                                          <p:spTgt spid="522"/>
                                         </p:tgtEl>
                                         <p:attrNameLst>
                                           <p:attrName>style.visibility</p:attrName>
@@ -26232,7 +27534,7 @@
                                       <p:cBhvr>
                                         <p:cTn id="183" dur="250"/>
                                         <p:tgtEl>
-                                          <p:spTgt spid="508"/>
+                                          <p:spTgt spid="538"/>
                                         </p:tgtEl>
                                       </p:cBhvr>
                                     </p:animEffect>
@@ -26244,7 +27546,7 @@
                                           </p:stCondLst>
                                         </p:cTn>
                                         <p:tgtEl>
-                                          <p:spTgt spid="508"/>
+                                          <p:spTgt spid="538"/>
                                         </p:tgtEl>
                                         <p:attrNameLst>
                                           <p:attrName>style.visibility</p:attrName>
@@ -26271,7 +27573,7 @@
                                           </p:stCondLst>
                                         </p:cTn>
                                         <p:tgtEl>
-                                          <p:spTgt spid="510"/>
+                                          <p:spTgt spid="540"/>
                                         </p:tgtEl>
                                         <p:attrNameLst>
                                           <p:attrName>style.visibility</p:attrName>
@@ -26285,7 +27587,7 @@
                                       <p:cBhvr>
                                         <p:cTn id="187" dur="350"/>
                                         <p:tgtEl>
-                                          <p:spTgt spid="510"/>
+                                          <p:spTgt spid="540"/>
                                         </p:tgtEl>
                                       </p:cBhvr>
                                     </p:animEffect>
@@ -26320,7 +27622,7 @@
                                       <p:cBhvr>
                                         <p:cTn id="191" dur="250"/>
                                         <p:tgtEl>
-                                          <p:spTgt spid="510"/>
+                                          <p:spTgt spid="540"/>
                                         </p:tgtEl>
                                       </p:cBhvr>
                                     </p:animEffect>
@@ -26332,7 +27634,7 @@
                                           </p:stCondLst>
                                         </p:cTn>
                                         <p:tgtEl>
-                                          <p:spTgt spid="510"/>
+                                          <p:spTgt spid="540"/>
                                         </p:tgtEl>
                                         <p:attrNameLst>
                                           <p:attrName>style.visibility</p:attrName>

</xml_diff>